<commit_message>
Core deck v1.1: full build at d925f7a (26 slides, 1,273 traced values, 195 checks pass, 0 FAIL) with PDF; D-063 and SPEC 16 record the second appendix review round
Co-Authored-By: Claude Opus 5.5 <noreply@anthropic.com>
Claude-Session: https://claude.ai/code/session_01VcVRPzFxTqkW2KRC1Wkk1r
</commit_message>
<xml_diff>
--- a/reports/deck/dupilumab_AUCinf_core_deck_v1.1.pptx
+++ b/reports/deck/dupilumab_AUCinf_core_deck_v1.1.pptx
@@ -778,7 +778,7 @@
 구조적 원인, 잔차(그림 왼쪽): 2016 모델 구조에서 비례 잔차를 24.2%에서 12.0%로 줄이면 세트 (iii) 미달은 38.8%에서 27.2%로 줄지만 여전히 크고, 세트 (iv)(span ≥ 3)는 65.9%에서 66.0%로 그대로다(Wilson 95% 구간 65.2~66.5 대 65.4~66.7; 대응 비교 구간은 없다). adjusted R² 중앙값: 0.930 → 0.946. 잔차가 줄면 adjusted R² 미달로 빠지던 대상자가 span 미달로 옮겨 간다(세트 (iii)은 충족하고 span만 미달하는 몫 27.1%p → 38.8%p). λz 구간이 절벽 앞 채혈점에 묶여 span 중앙값(3.07~3.29)이 기준 3에 가깝기 때문이다(λz 구간 끝의 중앙값이 정량한계 도달일 중앙값보다 앞선다). 잔차를 줄인 변형은 2016 모델 구조에만 있다(2020 모델 세트 (iii) 미달 33.2%).
 구조적 원인, 정량한계: 정량한계를 0.078에서 0.02 mg/L로 낮추면 세트 (i)(adjusted R² ≥ 0.80) 충족이 2016 모델 -2.33%p (95% CI -2.80~-1.86), 2020 모델 -5.93%p (95% CI -6.39~-5.47) 바뀐다(같은 대상자 대응 비교). 가법 잔차를 정량한계에 비례시켜도 -1.93%p (95% CI -2.16~-1.69), -2.43%p (95% CI -2.66~-2.19)로 떨어진다. 마지막 정량 시점이 늦어지면서 adjusted R² 0.80 미달이 는다(2016 모델 11.4% → 14.8%, 2020 모델 7.0% → 13.5%); 보고서 5.10절은 정량한계 근처의 잡음이 정량되기 때문이라고 설명한다. 정량한계 격자는 세트 (i)·(ii)만 계산했으므로 세트 (iii)으로 넓히지 않는다.
 무작위가 아님(세트 (iii)): 기준 미달자 대 충족자의 참 AUCinf 기하평균비는 2016 모델 0.928 (95% CI 0.918~0.938), 2020 모델 0.895 (95% CI 0.885~0.906), 관측 AUClast 기하평균비는 0.89~0.91이다. 체중 차이(미달자 - 충족자)는 0.42 kg (95% CI 0.21~0.62), 0.35 kg (95% CI 0.14~0.56)이다. 층별 미달: 가벼운 층 37.6%, 무거운 층(75 kg 초과) 39.9%(2016 모델); 32.2%, 34.2%(2020 모델); 차이 2.3%p (95% CI 0.9~3.6), 2.0%p (95% CI 0.7~3.4)(Newcombe 구간). 그 결과 동일 제품 시험 2,000회에서 세트 (iii) 분석군의 arm 간 무거운 층 비율 차이가 5%p를 넘는 시험이 28.6~33.4%이고(5~95백분위 -8.7~8.5%p), AUClast 분석군에서는 그런 시험이 0.0%다(무작위배정의 층 구성 유지; 층 내 1:1 배정에서 두 arm의 차이는 최대 0.9%p, 한 명).
-arm마다 다름(그림 오른쪽): 시험 2,000회를 운용 특성 시드로 다시 만들어 arm별 세트 (iii) 미달 비율의 차이(시험군 - 대조군)를 평균했다. 동일 제품 -0.2~0.1%p(대조군 평균 미달 33.9~38.6%); 이것은 시험 2,000회의 평균이며, 개별 시험의 arm 간 차이는 동일 제품이어도 5~95백분위 -10.3~11.1%p로 퍼진다. 참 AUCinf 비 0.80 경계 칸(기전 하나를 바꾼 가상 시험약): 흡수 속도 감소 12.6~13.0, 표적 소실 증가 7.2~8.9, 흡수량 감소 2.6~3.0, 선형 소실 증가 -2.1~-1.4, 말초 분포 증가 -9.4~-8.4(두 모델, %p). 참 비 1.25 경계 칸: 표적 소실 감소 -9.2~-7.1, 흡수량 증가 -2.8~-2.6, 선형 소실 감소 0.6~1.7. 흡수 속도 감소 칸은 참 Cmax 비가 0.63로 동등 범위 밖이라 Cmax를 넣은 판정 구성은 이 칸에서 통과한 시험이 하나도 없다(results/oc_models/type1_models.csv). 그래서 판정에 의미 있는 칸(참 Cmax 비가 범위 안)의 최대 차이 9.4%p(말초 분포 증가, 2020 모델)를 요점에 적었다. 평균의 95% 구간 폭은 최대 0.57%p로 표식보다 좁다. 로그 참 비에 대한 선형 적합의 R²는 0.17~0.18로, 차이는 참 비가 아니라 기전이 정한다. 인원 수 기반 결과라 분석 모형(M0/M1)과 무관하다.
+arm마다 다름(그림 오른쪽): 시험 2,000회를 운용 특성 시드로 다시 만들어 arm별 세트 (iii) 미달 비율의 차이(시험군 - 대조군)를 평균했다. 동일 제품 -0.2~0.1%p(대조군 평균 미달 33.9~38.6%); 이것은 시험 2,000회의 평균이며, 개별 시험의 arm 간 차이는 동일 제품이어도 5~95백분위 -10.3~11.1%p로 퍼진다. 참 AUCinf 비 0.80 경계 칸(기전 하나를 바꾼 가상 시험약): 흡수 속도 감소 12.6~13.0, 표적 소실 증가 7.2~8.9, 흡수량 감소 2.6~3.0, 선형 소실 증가 -2.1~-1.4, 말초 분포 증가 -9.4~-8.4(두 모델, %p). 참 비 1.25 경계 칸: 표적 소실 감소 -9.2~-7.1, 흡수량 증가 -2.8~-2.6, 선형 소실 감소 0.6~1.7. 흡수 속도 감소 칸은 참 Cmax 비가 0.63으로 동등 범위 밖이라 Cmax를 넣은 판정 구성은 이 칸에서 통과한 시험이 하나도 없다(results/oc_models/type1_models.csv). 그래서 판정에 의미 있는 칸(참 Cmax 비가 범위 안)의 최대 차이 9.4%p(말초 분포 증가, 2020 모델)를 요점에 적었다. 평균의 95% 구간 폭은 최대 0.57%p로 표식보다 좁다. 로그 참 비에 대한 선형 적합의 R²는 0.17~0.18로, 차이는 참 비가 아니라 기전이 정한다. 인원 수 기반 결과라 분석 모형(M0/M1)과 무관하다.
 사전 등록: 층 구성과 arm 간 차이는 section6 등록 후 처음 계산했다(DECISIONS.md D-059). 관련 보고서: 5.3절(Table 5-6, Table 5-7, Figure 5-5, Figure 5-6), 5.10절, 6.5절.</a:t>
             </a:r>
           </a:p>
@@ -928,7 +928,7 @@
           <a:p>
             <a:r>
               <a:rPr/>
-              <a:t>S9 점도표의 칸별 값이다. 경계 칸 = 시험약의 기전 하나를 바꿔 참 AUCinf 비를 동등 한계에 맞춘 가상 제품. 모델마다 8칸, 합 16칸. 두 구성: AUClast + Cmax(두 지표 모두 통과해야 동등), AUCinf + Cmax(신뢰할 수 있는 AUCinf, 곧 adjusted R² ≥ 0.90와 외삽 ≤ 20%를 얻은 대상자만으로 AUCinf를 판정하는 규칙 A 세트 (iii)).
+              <a:t>S9 점도표의 칸별 값이다. 경계 칸 = 시험약의 기전 하나를 바꿔 참 AUCinf 비를 동등 한계에 맞춘 가상 제품. 모델마다 8칸, 합 16칸. 두 구성: AUClast + Cmax(두 지표 모두 통과해야 동등), AUCinf + Cmax(신뢰할 수 있는 AUCinf, 곧 adjusted R² ≥ 0.90과 외삽 ≤ 20%를 얻은 대상자만으로 AUCinf를 판정하는 규칙 A 세트 (iii)).
 Wilson 분류(칸마다 시험 10,000회의 통과 비율과 Wilson 95% 구간): 보수적 = 상한 &lt; 5%, 명목 = 구간이 5% 포함, 초과 = 하한 &gt; 5%. 점추정만 보면 AUCinf 구성은 10칸, AUClast 구성은 1칸이 5%를 넘는다(S9 본문의 칸 수).
 AUClast + Cmax(M1): 보수적 15칸, 명목 0칸, 초과 1칸. 초과 칸은 2020 모델 말초 분포 증가 칸 5.63% (95% CI 5.31~5.95)이다(원인은 별첨 A5b). 같은 칸에서 AUCinf 구성은 2.13% (95% CI 1.94~2.34)로 보수적이다.
 AUCinf + Cmax(M1): 초과 9칸, 명목 2칸, 보수적 5칸. 최댓값은 두 모델 모두 표적 소실 증가 칸으로 2016 모델 17.47% (95% CI 16.74~18.23), 2020 모델 14.08% (95% CI 13.41~14.78)이다. 점추정 5% 초과 10칸 중 2016 모델 선형 소실 증가 칸(5.30%)만 명목이고 나머지는 초과다.
@@ -1138,7 +1138,7 @@
 (a)·(b)는 시험 수준 결과로, 일정 판정 모의 때 설계의 분석법(합동 t 검정, M0)으로만 계산했다(체중 층을 넣은 M1로 다시 계산하지 않음). (a)는 양수가 폭이 좁아지는 쪽이다: 추가 채혈 D1~D4 중 폭이 좁아진 것은 2020 모델 D3뿐이고 가장 큰 감소도 0.06%로 기준 2%에 못 미친다. (c)·(d)는 대상자 수준이라 분석 모형과 무관하다.
 (c)의 세트별 범위(D1~D4, 두 모델): 세트 (i) -1.02~2.76%p, 세트 (ii) -3.50~1.69%p(최대 +1.69%p). 참고 열의 세트 (iii)(이 덱의 신뢰할 수 있는 AUCinf)은 같은 대상자 20,000명(모델마다)에서 B0 61.2%(2016 모델), 66.8%(2020 모델) 대비 -2.4~+1.4%p 바뀐다: D1, D2, D4에서는 오히려 줄고, 주 두 번 채혈(D3)에서만 0.7~1.4%p 오른다(S6). B-의 세트 (iii)은 계산하지 않았다.
 (d) D3: 0.60 (95% CI 0.53~0.67) / 0.69 (95% CI 0.61~0.76)(2016 모델 / 2020 모델, 부트스트랩 95% 구간). 200,000명 재평가: 2016 모델 0.603 (95% CI 0.583~0.624), 2020 모델 0.725 (95% CI 0.701~0.748)으로 기준 0.5 미충족이다.
-민감도 변형(판정 기록 D-031, D-037): 모든 곡선·잔차·체중 변형 가운데 규칙상 추가 채혈이 권고된 곳은 양 군 Vmax ×0.8 변형의 D3 하나다(기준 (d) 단독: 0.488, 20,000명, 부트스트랩 95% 구간 0.37~0.62). 같은 변형의 200,000명 재평가는 0.586(0.552~0.623)로 기준 0.5를 넘었다. 판정 기록(config/schedule_decision.yaml)은 규칙을 주 모델(2016 모델)에 적용하고 변형은 견고성 평가로만 쓰며, 이 권고를 판단으로 받아들이지 않았다: (a)·(b)·(c)는 모든 변형에서 미충족, 부트스트랩 구간이 0.5를 포함, 외삽 20% 초과 대상자의 절대 감소가 arm당 0.26명으로 한 명에 못 미침, 대가는 추가 방문 1,040회. 기록은 발생률이 낮은 사건의 상대 감소 기준에 절대 하한(예: arm당 최소 인원)이 필요했다는 교훈도 적고, 이번 판정에는 소급하지 않았다.
+민감도 변형(판정 기록 D-031, D-037): 모든 곡선·잔차·체중 변형 가운데 규칙상 추가 채혈이 권고된 곳은 두 arm 모두 Vmax ×0.8인 변형의 D3 하나다(기준 (d) 단독: 0.488, 20,000명, 부트스트랩 95% 구간 0.37~0.62). 같은 변형의 200,000명 재평가는 0.586(0.552~0.623)로 기준 0.5를 넘었다. 판정 기록(config/schedule_decision.yaml)은 규칙을 주 모델(2016 모델)에 적용하고 변형은 견고성 평가로만 쓰며, 이 권고를 판단으로 받아들이지 않았다: (a)·(b)·(c)는 모든 변형에서 미충족, 부트스트랩 구간이 0.5를 포함, 외삽 20% 초과 대상자의 절대 감소가 arm당 0.26명으로 한 명에 못 미침, 대가는 추가 방문 1,040회. 기록은 발생률이 낮은 사건의 상대 감소 기준에 절대 하한(예: arm당 최소 인원)이 필요했다는 교훈도 적고, 이번 판정에는 소급하지 않았다.
 v1.0 결과: 일정 판정 모의와 판정 기록(2026-09-24)은 v1.0.1 사전 등록(2026-09-25)보다 앞선 v1.0 결과다. 참고 열의 세트 (iii) 변화만 핵심 덱 사전 등록(config/prereg_20260929.yaml)으로 새로 계산했다. B0의 신뢰할 수 있는 AUCinf 비율은 61.2%(2016 모델), 66.8%(2020 모델)이다.
 Day 50 제거(B-): 판정 기록의 사유는 AUCinf 2차 평가변수와 대응안(fallback)에 쓸 말단 점 확보다. 빼면 신뢰구간 평균 폭은 0.69 / 0.87% 좁아지지만(기준 (a) 2%에 못 미침) NCA 외삽 20% 초과 비율이 B0의 1.29 / 1.29배가 되고 세트 (ii) 신뢰 충족률이 -1.82 / -3.18%p 바뀐다(2016 모델 / 2020 모델).
 Day 57 이후 채혈 일정은 어느 결과 파일에서도 모의하지 않았다(DECISIONS D-016에서 철회한 연장안 포함).
@@ -1296,7 +1296,8 @@
 [대응안] 규제기관이 AUCinf 공동 1차를 요구할 때만 쓴다. AUClast를 빼지 않고 AUCinf를 더한 세 지표 공동 1차(구성 F3B). AUCinf는 규칙 B(λz 산출 전원 포함; 기준 미달자는 제외하지 않고 표시만)다. 경계 1종 오류는 M1에서 16칸 모두 보수적이고 최대 3.95% (95% CI 3.59~4.35), M0 최대 3.57%. 참고로 AUCinf를 규칙 A(세트 (ii) 미달자 제외)로 더하면 최대 3.39%, 규칙 C(미달자에 AUClast 대입)로 더하면 최대 5.16%(점추정 5% 초과 1칸)다. 규칙 A가 아니라 규칙 B를 쓰는 이유: 규칙 A는 1종 오류가 조금 더 낮지만 동시 통과율 손실이 커지고(표) 기준 미달자, 곧 참 AUCinf가 낮은 대상자를 체계적으로 뺀다. 규칙 A를 세트 (iii)으로 적용한 세 지표 구성은 계산하지 않았다.
 대응안의 비용(v1.0 대응안 모의: 같은 시험에서 AUClast + Cmax 대비 동시 통과율 감소, 2016 모델, 체중 층 없는 합동 t 검정 M0, 제품당 시험 5,000~20,000회): 동일 제품 0.015%p (95% CI -0.002~0.032)(동시 통과율 99.52% → 99.50%), 참 AUCinf 비 0.950 제품 0.34%p (95% CI 0.18~0.50), 0.953 제품 0.16%p (95% CI 0.05~0.27). F097 제품에서 AUClast + Cmax만의 검정력은 96.82%다. AUCinf를 규칙 A(세트 (ii))로 더하면 감소가 2.06~2.36%p로 커진다. M1 운용 특성 모의(두 모델, 동일 제품과 F097 제품)에서도 검정력 차이는 0.01~0.13%p다. 표본 수는 AUClast + Cmax 기준(별첨 A9)으로 정한다.
 [AUCinf + Cmax만] AUClast 없이 AUCinf + Cmax로 판정하는 안은 권하지 않는다. M1 경계 1종 오류: 신뢰할 수 있는 AUCinf만(규칙 A 세트 (iii)) 최대 17.47%, Wilson 하한까지 5% 초과 9칸; 규칙 B 최대 16.03%, 8칸. 신뢰 기준을 쓰면 AUCinf 분석에서 빠지는 대상자가 많고(세트 (iii) 미달 33.2~38.8%, arm당 남는 인원 중앙값 72~78명(시험 10,000회); 세트 (i) 0.80 기준 미달 8.2~13.4%) 빠지는 대상자는 참 AUCinf가 낮아(표의 비) 노출이 낮은 쪽이 체계적으로 빠진다. 규칙 B는 λz 산출 불가(0.62~1.46%)만 빠져 인원 손실은 작지만 16칸 중 10칸의 점추정이 5%를 넘는다.
-[표] 점추정 5% 초과 칸: 경계 16칸(M1) 중 통과율 점추정이 5%를 넘는 칸 수. arm당 빠지는 인원 = 평가 가능 117명 - AUCinf 분석 인원(시험 10,000회의 중앙값, 두 모델 범위). 빠지는/남는 참 AUCinf 비 = 빠지는 대상자와 남는 대상자의 참 AUCinf 기하평균 비(두 모델). 세트 (i) = adjusted R² ≥ 0.80, 외삽 ≤ 20%.
+[대응안을 기본으로 두지 않는 이유] 세 지표 판정은 AUClast + Cmax를 통과한 시험 가운데 AUCinf까지 통과한 시험만 통과시키므로(교집합), 경계 16칸 모두에서 통과율이 AUClast + Cmax와 같거나 낮다. 대응안의 1종 오류가 낮은 것(M1 최대 3.95%)은 이 때문이며 AUCinf가 주는 정보 때문이 아니다: 같은 규칙 B의 AUCinf를 Cmax와만 쓰면 16칸 중 10칸의 점추정이 5%를 넘는다. 또 규칙 B는 λz가 산출되면 신뢰 기준(세트 (iii))에 못 미쳐도 AUCinf를 쓰므로, λz는 산출되나 기준 미달인 대상자(33~37%)의 AUCinf가 1차 판정에 들어간다. 제안(AUClast + Cmax)의 점추정 5% 초과는 1칸(5.63%, 2020 모델 말초 분포용적(V2) 증가 칸)뿐이며, AUClast 기하평균비가 참 AUCinf 비보다 1 쪽으로 0.41% (95% CI 0.34~0.48) 치우친 결과로 AUClast와 AUCinf의 추정 대상 차이다(별첨 A5b). 그래서 대응안은 규제기관이 AUCinf 공동 1차를 요구할 때만 쓴다.
+[표] 점추정 5% 초과 칸: 경계 16칸(M1) 중 통과율 점추정이 5%를 넘는 칸 수. arm당 빠지는 인원 = 평가 가능 117명 - AUCinf 분석 인원(시험 10,000회의 중앙값, 두 모델 범위). 빠지는/남는 참 AUCinf 비 = 빠지는 대상자와 남는 대상자의 참 AUCinf 기하평균 비(두 모델). 세트 (i) = adjusted R² ≥ 0.80, 외삽 ≤ 20%; 세트 (ii) = 세트 (i) + span ≥ 2. M1 = 투여군과 무작위배정 체중 층을 넣은 분산분석(주분석 후보, 의뢰자 결정 대기), M0 = 체중 층 없는 합동 t 검정. 세트 (i) 충족자만 쓰는 AUCinf + Cmax(규칙 A 세트 (i))도 표에 있다.
 규제 맥락: EMA 단클론항체 바이오시밀러 지침(EMA/CHMP/BMWP/403543/2010)의 기본값은 단회 투여 시험에서 AUCinf 1차, 피하 투여면 Cmax 공동 1차다. 선례로 토실리주맙 바이오시밀러 MSB11456의 건강인 단회 정맥 투여 시험은 AUClast를 1차, Cmax와 AUCinf를 2차로 두었다. 두 출처 모두 검색 발췌로만 확인했다(config/literature_precedents.yaml, 원문 미대조). 이 덱의 제안은 이 기본값에서 벗어나며, 그 근거가 S4~S9다.
 관련 보고서: 5.9절, 6.2절, 6.3절, 7절; SAP 제안 1절~7절; 예상 질의 Q9, Q11.</a:t>
             </a:r>
@@ -1348,11 +1349,11 @@
               <a:t>왼쪽 그림(체중 범위, 아토피 피부염 성인)은 평가변수 선택의 근거가 아니다. 오른쪽 표의 모델 가정 행은 S8, S9, 별첨 A5에 있는 근거를 요약한 것이다. 근거는 시험 모집단(건강인 60~90 kg, 체중 층화 배정, 현행 채혈 B0)뿐이며, 연구 범위 밖 체중과 아토피 피부염 성인 체중 분포의 결과는 의뢰자 결정으로 별첨의 견고성 점검으로 옮겼다(분석은 바뀌지 않고 보고 위치만 바뀜, 보고서 부록 D·부록 I). 핵심 덱에서 아토피 환자 모집단 결과를 쓰는 곳은 이 슬라이드뿐이다.
 (a) 체중 구간(구간 안 균일 분포, 구간당 20,000명; 구간 폭은 같지 않다, 점은 구간 체중 중앙값): 무거운 구간일수록 신뢰 기준(세트 (i), adjusted R² ≥ 0.80) 미달이 늘어난다. 2016 모델 9.2% → 29.2%, 2020 모델 5.9% → 18.0%. 이 결과 파일에는 세트 (iii)이 없다. AUClast/AUCinf 5번째 백분위수는 2016 모델 97.3% → 91.5%, 2020 모델 97.1% → 92.6%이고, 80% 미만 대상자는 구간마다 0.01% 이하다. 모델 개발 자료의 체중 범위는 보고되지 않아 130 kg 이상 구간(점선 오른쪽)은 모델 외삽일 수 있다.
 (b) 아토피 피부염 성인 체중 분포는 Kamal 2022, Kovalenko 2021, NCT03389893 요약에서 만든 가정 분포(자리표시자)다(로그정규, 평균 78 kg, SD 19 kg, 40~180 kg 절단). 3상 원자료 체중은 분석 환경에서 확인할 수 없었다. 모의 20,000명 중 연구 범위 밖은 40.4%, 100 kg 초과는 12.9%이다. 점은 구간 평균 체중이며 구간은 60 kg 미만, 60~90 kg, 90~100 kg, 100 kg 초과다.
-신뢰할 수 있는 AUCinf 미확보(세트 (iii)): 아토피 분포 전체 2016 모델 39.5%, 2020 모델 33.6%(세 모델 변형 33.6~39.8%)로 시험 모집단(38.8%, 33.2%)과 비슷하다. 무거운 환자에 몰린다: 2016 모델 60 kg 미만 33.9%, 100 kg 초과 47.5%; 2020 모델 28.5%, 39.3%. 민감도 체중 분포 두 개에서는 33.1~40.1%(세 모델 변형)다.
-제목 수치: 그린 자료(두 모델)에서 신뢰 기준 미달의 최대는 47.5%(아토피 분포, 가장 무거운 구간, 세트 (iii))이고, AUClast/AUCinf 80% 미만 대상자는 (a)의 모든 체중 구간과 (b)의 모든 구간에서 0.01% 이하다. 세트 (iii) 미달 환자의 AUClast/AUCinf(참 AUClast / 참 AUCinf) 최솟값은 세 모델 변형 중 가장 작은 값 78.9%(내림)로, S8이 쓰는 EMA 기준 80%보다 낮은 환자가 드물게 있다. 2016 모델 81.4%, 2020 모델 80.8%; 중앙값 99.5~99.8%, 5번째 백분위수 94.2~95.0%. 전체 환자 중 80% 미만은 0.005% 이하다. 세 모델 변형: 2016 모델, 2020 모델(Model 1), 2016 모델에 성인 3상 공변량(Kovalenko 2020: 선형 소실에 BMI, 중심 분포 용적에 체중)을 넣은 변형.
+세트 (iii) 기준 미달(신뢰할 수 있는 AUCinf를 얻지 못함): 아토피 분포 전체 2016 모델 39.5%, 2020 모델 33.6%(세 모델 변형 33.6~39.8%)로 시험 모집단(38.8%, 33.2%)과 비슷하다. 무거운 환자에 몰린다: 2016 모델 60 kg 미만 33.9%, 100 kg 초과 47.5%; 2020 모델 28.5%, 39.3%. 민감도 체중 분포 두 개에서는 33.1~40.1%(세 모델 변형)다.
+제목 수치: 그린 자료(두 모델)에서 신뢰 기준 미달의 최대는 47.5%(아토피 가정 분포의 100 kg 초과 구간, 2016 모델, 세트 (iii))이고, AUClast/AUCinf 80% 미만 대상자는 (a)의 모든 체중 구간과 (b)의 모든 구간에서 0.01% 이하다. 세트 (iii) 미달 환자의 AUClast/AUCinf(참 AUClast / 참 AUCinf) 최솟값은 세 모델 변형 중 가장 작은 값 78.9%(내림)로, S8이 쓰는 EMA 기준 80%보다 낮은 환자가 드물게 있다. 2016 모델 81.4%, 2020 모델 80.8%; 중앙값 99.5~99.8%, 5번째 백분위수 94.2~95.0%. 전체 환자 중 80% 미만은 0.005% 이하다. 세 모델 변형: 2016 모델, 2020 모델(Model 1), 2016 모델에 성인 3상 공변량(Kovalenko 2020: 선형 소실에 BMI, 중심 분포 용적에 체중)을 넣은 변형.
 평균 체중이 높은 모집단의 모의 시험(스트레스 시험, 보고서 부록 I): 엔진의 기본 신뢰 표시(세트 (ii))의 기준 미달자가 충족자보다 3.2~6.4 kg 무겁다(세 모델 변형, 시나리오, arm 전체의 범위). 아토피 분포의 모의 시험(시나리오당 2,000회, M0): AUClast 기하평균비(GMR) 편향 -0.94~0.39%, AUCinf 규칙 A 세트 (iii) 편향 -2.42~3.97%; AUClast + Cmax와 AUCinf + Cmax(규칙 A, 세트 (iii))의 판정 일치 70.2~88.7%; Vmax 증가 시나리오(VM125)에서 세트 (iii) 미달의 arm 간 차이(시험 - 대조) 4.86~5.71%p.
 오른쪽 표(결과보고 덱 S21 요약, 핵심 덱 용어): 구조 모델은 모델마다 경계 조건 8개(조건당 시험 10,000회, 2020 모델 V2 조건만 20,000회). 신뢰할 수 있는 AUCinf + Cmax의 최대는 17.5%(S9). 분석 모형: 2020 모델 V2 증가 조건의 AUClast + Cmax는 M0 5.18%(명목: Wilson 95% 구간이 5% 포함), M1 5.63% (95% CI 5.31~5.95)와 M2 5.75%(둘 다 초과: Wilson 하한 &gt; 5%)이고, 원인 분해는 별첨 A5에 있다.
-곡선 모양은 2016 모델만, 대상자 수준(AUClast/AUCinf(참값) 분포)으로 모의했고 경계 1종 오류는 계산하지 않았다(S8). 정량한계는 2016 모델 경계 3개 조건(흡수량 감소, 표적 매개 소실 감소·증가), 조건당 5,000회: AUClast + Cmax M0 2.22~4.22%; AUCinf 쪽은 세트 (ii)(adjusted R² ≥ 0.80, 외삽 ≤ 20%, span 조건)만 계산했다. 잔차 12%는 신뢰 기준 미달만 계산했다(세트 (i) 13.4% → 5.8%; 세트 (iii)은 표). 결론: 계산한 범위에서 AUClast + Cmax 점추정의 5% 초과는 2020 모델 V2 조건뿐이고, AUCinf 쪽의 신뢰 기준 미달과 점추정 5% 초과는 조건을 바꿔도 남는다.
+곡선 모양은 2016 모델만, 대상자 수준(AUClast/AUCinf(참값) 분포)으로 모의했고 경계 1종 오류는 계산하지 않았다(S8). 정량한계는 2016 모델 경계 3개 조건(흡수량 감소, 표적 매개 소실 감소·증가), 조건당 5,000회: AUClast + Cmax는 M1 2.60~4.62%(표), M0 2.22~4.22%; AUCinf 쪽은 세트 (ii)(adjusted R² ≥ 0.80, 외삽 ≤ 20%, span 조건)만 계산했다. 잔차 12%는 신뢰 기준 미달만 계산했다(세트 (i) 13.4% → 5.8%; 세트 (iii)은 표). 결론: 계산한 범위에서 AUClast + Cmax 점추정의 5% 초과는 2020 모델 V2 조건뿐이고, AUCinf 쪽의 신뢰 기준 미달과 점추정 5% 초과는 조건을 바꿔도 남는다.
 관련 보고서: 5.2절, 5.3절, 5.8절, 5.9절, 5.10절, 6.5절, 부록 I(Table I-1, Table I-2, Figure I-1, Figure I-2); 예상 질의 Q16, Q20.</a:t>
             </a:r>
           </a:p>
@@ -1400,17 +1401,19 @@
           <a:p>
             <a:r>
               <a:rPr/>
-              <a:t>곡선 모양과 Km: 정량한계 아래 말단 곡선은 관측할 수 없고, Km(표적 매개 소실의 Michaelis-Menten 상수, 결합 친화도 자체가 아님)은 두 모델 모두 0.01 mg/L로 고정되어 개인 간 변동이 없다. 이 가정은 민감도 분석으로만 확인했다: 사전 등록한 곡선 모양 변형(2016 모델, 양 군 공통 Vmax ×0.8·×1.25, Km ×0.5·×10) 4개 모두 AUClast/AUCinf 80% 미만 대상자가 없고 5번째 백분위수는 94.7% 이상이다(S8). 사전 등록 밖의 스트레스 시험(양 군 Vmax ×0.5, 노출 확인 불통과)에서는 80% 미만이 0.035%, 참 외삽 95백분위가 6.41%였다. Km 변형의 참 외삽 중앙값은 0.40~0.67%다. 시험약 Km만 ×0.01~×100로 바꿔도 참 AUCinf 비는 0.999~1.059로 동등 한계(80~125%) 안에 머문다. 곧 이 모델 구조에서는 Km 차이가 AUC로 드러나지 않는다(Km이 정량한계 아래 고정값이라 모델 구조가 정한 결과). 결합 유사성은 비교 분석적 평가로 입증한다(별첨 A8).
+              <a:t>곡선 모양과 Km: 정량한계 아래 말단 곡선은 관측할 수 없고, Km(표적 매개 소실의 Michaelis-Menten 상수, 결합 친화도 자체가 아님)은 두 모델 모두 0.01 mg/L로 고정되어 개인 간 변동이 없다. 이 가정은 민감도 분석으로만 확인했다: 사전 등록한 곡선 모양 변형(2016 모델, 두 arm 공통 Vmax ×0.8·×1.25, Km ×0.5·×10) 4개 모두 AUClast/AUCinf 80% 미만 대상자가 없고 5번째 백분위수는 94.7% 이상이다(S8). 사전 등록 밖의 스트레스 시험(두 arm 모두 Vmax ×0.5, 노출 확인 불통과)에서는 80% 미만이 0.035%, 참 외삽 95백분위가 6.41%였다. Km 변형의 참 외삽 중앙값은 0.40~0.67%다. 시험약 Km만 ×0.01~×100으로 바꿔도 참 AUCinf 비는 0.999~1.059로 동등 한계(80~125%) 안에 머문다. 곧 이 모델 구조에서는 Km 차이가 AUC로 드러나지 않는다(Km이 정량한계 아래 고정값이라 모델 구조가 정한 결과). 결합 유사성은 비교 분석적 평가로 입증한다(별첨 A8).
 200 mg(175 mg/mL) 제형: 관측 tmax 3.0~3.1일인데 모의는 7일이고, AUClast 모의/관측은 0.82~0.91(2016 모델), 0.90~1.00(2020 모델)이다. 연구 제형이 아니어서 외부 점검으로만 보고했다. 연구 제형 300 mg(150 mg/mL) 자료는 AUClast 모의/관측 0.94~1.04(2016 모델), 1.02~1.13(2020 모델)로 노출 확인 범위 ±15% 안이다(별첨 A1). 시험약과 대조약이 모두 이 제형인지 시험 계획에서 확인한다.
 Cmax: 연구 제형 자료에서 모의 Cmax가 관측보다 크다(모의/관측 1.08~1.27, 2016 모델; 1.00~1.17, 2020 모델). Cmax는 제안하는 1차 평가변수이고 경계 1종 오류와 검정력 계산은 모의 Cmax를 그대로 썼다(보고서 한계 목록).
+측정 오차(잔차) 가정: 모의 농도의 측정 오차는 두 문헌 모델의 비례 잔차(24.2%, 2016 모델; 15%, 2020 모델)를 그대로 썼다. 이 잔차는 모델 개발 자료(원개발사 분석법)에서 추정된 값이다. 2016 모델 구조에서 비례 잔차를 12%로 줄이면 세트 (iii) 미달이 38.8%에서 27.2%로 준다(별첨 A3b). ①의 크기는 이 가정에 달려 있으므로 의뢰자 분석법의 실제 정밀도를 확인해야 한다.
+완전 외부 재판정(별첨 A1, A6; DECISIONS D-030): 모델 개발에 쓰인 자료를 뺀 외부 자료만으로 다시 판정하면 두 모델 모두 기준을 충족하지 못한다(2016 모델 1/10개 항목, 2020 모델 3/8개 항목 불통과). 불통과는 모두 Li 2020의 단일 arm이며 그중 PKM12350(연구 제형 300 mg)의 두 arm은 모의/관측 1.14~1.27로 모의가 높다. 이 arm들은 체중이 보고되지 않아 평균 78 kg으로 가정했고, 가정 평균 체중이 82 kg(2016 모델), 86 kg(2020 모델) 이상이면 두 arm 모두 ±15% 안에 든다(results/step1*/step1i_arm_weight_sensitivity.csv).
 λz 수동 검토: ①(신뢰할 수 있는 AUCinf 비율)은 자동 Best Fit(adjusted R² 최대 구간) 선택 결과다. 실제 시험에서는 약동학 담당자가 λz 구간을 검토·수정할 수 있고 이는 모의하지 않았다(보고서 한계 목록). 수동 검토가 신뢰 기준 충족 비율을 얼마나 바꿀지는 계산하지 않았다.
-NCA 엔진: 검증 범위는 NonCompart·PKNCA 두 참조 구현뿐이다(λz 창 3,054 / 3,054 일치, 최대 상대 차이 4.9×10⁻¹³). results/nca_engine에 Phoenix 출력이 없다. 보고서 3.4절은 'Phoenix 규칙 재현'이라고 적었고, Phoenix 미대조는 보고서 한계 목록(6.5절, 부록 B)에 없는 새 항목이다. 제출 전 대표 프로필 일부를 실제 Phoenix WinNonlin으로 돌려 λz 창과 AUCinf를 대조하는 것을 제안한다(미실시).
+NCA 엔진: 검증 범위는 NonCompart·PKNCA 두 참조 구현뿐이다(λz 구간 3,054 / 3,054 일치, 최대 상대 차이 4.9×10⁻¹³). results/nca_engine에 Phoenix 출력이 없다. 보고서 3.4절은 'Phoenix 규칙 재현'이라고 적었고, Phoenix 미대조는 보고서 한계 목록(6.5절, 부록 B)에 없는 새 항목이다. 제출 전 대표 프로필 일부를 실제 Phoenix WinNonlin으로 돌려 λz 구간과 AUCinf를 대조하는 것을 제안한다(미실시).
 독립 QC: regulatory/tables/verification_qc.csv의 해당 행 결과가 'PENDING (sponsor)'(의뢰자 검토 대기)이고 보고서 서명 페이지는 공란이다. 이 덱과 보고서는 AI 코딩 도우미의 도움으로 작성되었으므로 담당자가 수치는 추적표(core_deck_traceability.csv, regulatory/traceability.csv)와, 본문은 결과 파일과 대조해야 한다.
 인용 상태(config 파일의 status 값): config/literature_core_deck.yaml의 FDA BLA 761055 임상약리 리뷰(2016-07-29) 'search excerpt', EMA 생동 지침 'search excerpt'; config/literature_precedents.yaml의 MSB11456 시험 'search excerpt', EMA 2012 단클론항체 바이오시밀러 지침 'search excerpt'. 공개 SAP NCT04700163의 기준은 사이트 접근이 막혀 검색 발췌로 확인했고(사전 등록 2026-09-26 6절), Phoenix 8.2 NCA 문서의 Lambda Z Acceptance Criteria 설명도 문서 사이트가 막혀 검색으로 확인했다(DECISIONS.md). 원문 PDF와 학술지 페이지는 분석 환경의 네트워크 정책으로 열리지 않아 검색 요약으로만 확인했다. FDA 리뷰의 쪽 번호(48쪽, 지시문 값)와 문구 'very steep target-mediated phase'는 확인되지 않았고, 같은 내용은 Kovalenko 2020 결과 절에도 있다(S4). 외부 사용 전 원문과 대조한다.
-재생성 대조(scripts/63, 사전 등록 config/prereg_20260929.yaml section7, DECISIONS D-063): 개체 수준 파일이 git 밖에 있는 곡선 모양 변형과 대표 대상자 관측값을 원래 시드 규칙(scripts/10, scripts/21과 같은 기준 시드)으로 다시 만들고, 커밋된 요약·저장된 비구획 분석 결과와 대조했다. provenance.csv에는 입력 파일 해시 9개와 대조 36개가 있고 대조는 모두 일치했다(대표 대상자 관련 8개 포함). 새 모의는 없다.
-의뢰자 결정 대기(결과보고 덱 S26, 보고서 7절·부록 B): 분석법 LLOQ 0.078 mg/L는 원개발사 분석법 값을 빌린 가정이다(격자 0.02~0.50 mg/L에서 AUClast/AUCinf 80% 미만 0.00~0.01%, 2016 모델). 잠정 설계값(모두 config 상태 assumption): 첫 채혈 Day 1 투여 후 0.25일, 체중 평균 75 kg·SD 9 kg, 남성 비율 50%, 층 경계 75 kg, 방문 허용 범위. 주분석 모형: 주분석 후보는 M1(체중 층 포함, 의뢰자 결정 대기)이고 M0(층 없음)를 함께 보고한다. 목표 검정력과 n: arm당 무작위배정 130명, 평가 가능 117명; CV 43%, 참 GMR 0.95에서 AUClast + Cmax 검정력 94.5%(M1), 94.0%(M0). 목표 90%에 평가 가능 97명(M1), 100명(M0), 목표 85%에 83명(M1), 85명(M0). 값이 정해지면 config 한 곳을 바꾸고 전체를 다시 만든다.
+재생성 대조(표에서 뺌; 한계가 아니라 검증 결과이며 별첨 A14에 있다. scripts/63, 사전 등록 config/prereg_20260929.yaml section7, DECISIONS D-063): 개체 수준 파일이 git 밖에 있는 곡선 모양 변형과 대표 대상자 관측값을 원래 시드 규칙(scripts/10, scripts/21과 같은 기준 시드)으로 다시 만들고, 커밋된 요약·저장된 비구획 분석 결과와 대조했다. provenance.csv에는 입력 파일 해시 9개와 대조 36개가 있고 대조는 모두 일치했다(대표 대상자 관련 8개 포함). 새 모의는 없다.
+의뢰자 결정 대기(결과보고 덱 S26, 보고서 7절·부록 B): 분석법 정량한계 0.078 mg/L는 원개발사 분석법 값을 빌린 가정이다(격자 0.02~0.50 mg/L에서 AUClast/AUCinf 80% 미만 0.00~0.01%, 2016 모델). 잠정 설계값(모두 config 상태 assumption): 첫 채혈 Day 1 투여 후 0.25일, 체중 평균 75 kg·SD 9 kg, 남성 비율 50%, 층 경계 75 kg, 방문 허용 범위. 주분석 모형: 주분석 후보는 M1(체중 층 포함, 의뢰자 결정 대기)이고 M0(층 없음)를 함께 보고한다. 목표 검정력과 n: arm당 무작위배정 130명, 평가 가능 117명; CV 43%, 참 GMR 0.95에서 AUClast + Cmax 검정력 94.5%(M1), 94.0%(M0). 목표 90%에 평가 가능 97명(M1), 100명(M0), 목표 85%에 83명(M1), 85명(M0). 값이 정해지면 config 한 곳을 바꾸고 전체를 다시 만든다.
 그 밖에 보고서가 적은 한계: 항약물항체(ADA) 영향은 유사 하위군 민감도 분석으로만 모의, 문헌 모델(개인 자료 없음), 중도 탈락은 모의하지 않음.
-별첨 A13(규제 업무 포지션 페이퍼 7절 대응표)은 넣지 않았다. 직전 지시(포지션 페이퍼 연계 보완)의 결과와 포지션 페이퍼 자체가 저장소에 없어 대응 내용을 만들 수 없다(DECISIONS D-063, 지시 "없으면 생략").
+별첨 A13(규제 업무 포지션 페이퍼 7절 대응표)은 넣지 않았다. 직전 지시(포지션 페이퍼 연계 보완)의 결과와 포지션 페이퍼 자체가 저장소에 없어 대응 내용을 만들 수 없다(DECISIONS D-063, 지시 "없으면 생략"). 같은 이유로 별첨 A6에서 FDA 리뷰 Table 4.2.b, TYENNE(BLA 761275), MSB11456 피하 투여 초록 항목을 뺐다.
 관련 보고서: 3.4절, 4.1절, 4.2절, 5.2절, 5.6절, 5.10절, 5.11절, 6.5절, 7절, 부록 B.</a:t>
             </a:r>
           </a:p>
@@ -1460,10 +1463,10 @@
               <a:rPr/>
               <a:t>핵심 덱 입력(scripts/63, 사전 등록 config/prereg_20260929.yaml 7절, 결정 기록 D-063): 새 시험 모의는 없다. 저장된 대상자 수준 결과를 요약하고, 개체 수준 파일이 없는 곡선 모양 변형과 대표 대상자의 관측값은 원래 시드 규칙(주 시드 20260923, 태그별 파생)으로 다시 만들었다. 다시 만든 값이 커밋된 요약·저장된 비구획 분석과 다르면 멈추게 했다(허용 오차는 사전 등록에 적음).
 대조 36개(results/core_deck/provenance.csv, 모두 equal): 곡선 모양 연구의 추출 5개(기본 추출과 변형 4개), 대표 대상자 모집단(두 모델, 모델마다 20,000명)의 비구획 분석 7개 열 대조 14개(결측 형태와 값), 대표 대상자 대조 8개(관측 tlast의 참 누적 AUC, 참 농도 재계산), 저장 요약 대조 9개(기본 두 모델, 정량한계 두 경우, 비례 잔차, 세트 (iii) 미달 비율 두 모델, λz 산출 인원 두 모델). 입력 파일 9개는 SHA-256으로 기록했다.
-사전 등록은 계산 전에 커밋했다: 마지막 scripts/63 실행(커밋 925975a)은 코드·설정에 커밋 전 변경이 없는 상태였고, 로그에 적힌 사전 등록 파일의 SHA-256이 현재 파일과 같다.
+사전 등록은 계산 전에 커밋했다: 마지막 scripts/63 실행(커밋 925975a)은 코드·설정에 커밋 전 변경이 없는 상태였고(그 앞 실행은 스크립트 수정을 커밋하기 전이라 git_code_clean이 거짓이었으며, 커밋 뒤 다시 실행한 산출이 바이트 단위로 같았다: D-063), 로그에 적힌 사전 등록 파일의 SHA-256이 현재 파일과 같다.
 멈춘 실행(DECISIONS D-063): 기록된 실행 전에 세 번의 실행이 결과를 내기 전에 멈추거나 대체됐다. 하나는 스크립트에 premise 함수가 없어 멈췄고, 하나는 대표 대상자에 'λz 산출 가능'이라는 전제를 두었다가 멈췄다. 그 전제는 사전 등록에 없는 조건이었고(2020 모델 최솟값 대상자는 λz 산출 불가) 빼고 다시 실행했다. 나머지 하나는 추적 파일에 값을 그대로 적어 파일이 너무 커져 개수와 해시로 바꿨다. 세 실행의 로그는 지웠고, D-063은 계산 규칙과 값이 바뀌지 않았다고 적는다.
-v1.0.1 결과: 깨끗한 러너에서 다시 계산한 기록이 아직 없다(아래). 로컬 대조(카드 ①)와 자동 시험(카드 ③)만 있다.
-v1.0 재현: 재현 워크플로 첫 실행(커밋 52f525b, 2026-09-25 UTC)은 새 GitHub 러너(ubuntu-24.04)에서 renv.lock으로 환경을 복원한 뒤 허용 오차를 미리 정한 항목(config/repro_check.yaml)을 다시 계산했다. 항목 7개가 로컬 실행(7개 통과)과 새 러너(7/7) 모두에서 통과했고 값은 유효숫자 8자리까지 같다. 이 실행은 v1.0.1 사전 등록보다 앞서므로 v1.0.1 결과(M1, 기준 세트, 시험 모집단)를 깨끗한 러너에서 다시 계산한 기록은 없다.
+v1.0.1 결과: 새 러너에서 다시 계산한 기록이 아직 없다(아래). 로컬 대조(카드 ①)와 자동 시험(카드 ③)만 있다.
+v1.0 재현: 재현 워크플로 첫 실행(커밋 52f525b, 2026-09-25 UTC)은 새 GitHub 러너(ubuntu-24.04)에서 renv.lock으로 환경을 복원한 뒤 허용 오차를 미리 정한 항목(config/repro_check.yaml)을 다시 계산했다. 항목 7개가 로컬 실행(7개 통과)과 새 러너(7/7) 모두에서 통과했고 값은 유효숫자 8자리까지 같다. 이 실행은 v1.0.1 사전 등록보다 앞서므로 v1.0.1 결과(M1, 기준 세트, 시험 모집단)를 새 러너에서 다시 계산한 기록은 없다.
 자동 시험(tests 워크플로): 실행 1~71은 시험 전 환경 설정 단계에서 멈췄다(renv.lock 없음 1회, JUnit 보고기의 xml2 없음 70회). 실행 72~101: 성공 21, 취소 3(같은 브랜치의 새 push로 대체), 실패 6. 실패는 건너뛴 시험을 실패로 세는 규칙(87~91)과 환경 설정(99)이었고 실행 92, 100에서 고쳤다. 기록(ci_runs_*.csv, GitHub Actions API)의 마지막 실행 101은 성공이며, 그 뒤의 실행은 기록에 없다.
 난수와 환경: 난수는 고정한 주 시드와 태그에서 derive_seed(시드, 태그, 구성 요소)로 파생하며(R/seeds.R), 규칙 버전은 실행 로그에 남는다. 패키지 버전은 renv.lock(R 4.3.3, rxode2 5.1.7, renv 1.2.4)으로 고정했다.
 관련 보고서: 4.1절, 부록 C, 부록 G; 결정 기록 D-063.</a:t>
@@ -5490,7 +5493,7 @@
         <p:spPr>
           <a:xfrm>
             <a:off x="502920" y="603504"/>
-            <a:ext cx="11094415" cy="576072"/>
+            <a:ext cx="11094415" cy="1024128"/>
           </a:xfrm>
           <a:prstGeom prst="rect">
             <a:avLst/>
@@ -5524,7 +5527,35 @@
                 <a:ea typeface="Pretendard"/>
                 <a:sym typeface="Pretendard"/>
               </a:rPr>
-              <a:t>두 모델은 연구 제형의 관측 AUClast 평균을 ±15% 안에서 재현한다</a:t>
+              <a:t>두 모델은 연구 제형의 적격성 기준(gate) 자료 5⁠개에서</a:t>
+            </a:r>
+          </a:p>
+          <a:p>
+            <a:pPr algn="l" marL="0" marR="0" eaLnBrk="0">
+              <a:lnSpc>
+                <a:spcPct val="105000"/>
+              </a:lnSpc>
+              <a:spcBef>
+                <a:spcPts val="0"/>
+              </a:spcBef>
+              <a:spcAft>
+                <a:spcPts val="0"/>
+              </a:spcAft>
+              <a:buNone/>
+            </a:pPr>
+            <a:r>
+              <a:rPr cap="none" sz="2800" i="0" b="1" u="none">
+                <a:solidFill>
+                  <a:srgbClr val="0B0B0B">
+                    <a:alpha val="100000"/>
+                  </a:srgbClr>
+                </a:solidFill>
+                <a:latin typeface="Pretendard"/>
+                <a:cs typeface="Pretendard"/>
+                <a:ea typeface="Pretendard"/>
+                <a:sym typeface="Pretendard"/>
+              </a:rPr>
+              <a:t>관측 AUClast 평균을 사전 고정한 ±15% 안에서 재현한다</a:t>
             </a:r>
           </a:p>
         </p:txBody>
@@ -5539,8 +5570,8 @@
         </p:nvSpPr>
         <p:spPr>
           <a:xfrm>
-            <a:off x="502920" y="4945888"/>
-            <a:ext cx="6172200" cy="1308608"/>
+            <a:off x="502920" y="5649976"/>
+            <a:ext cx="11185855" cy="604520"/>
           </a:xfrm>
           <a:prstGeom prst="rect">
             <a:avLst/>
@@ -5574,7 +5605,7 @@
                 <a:ea typeface="Pretendard"/>
                 <a:sym typeface="Pretendard"/>
               </a:rPr>
-              <a:t>음영: gate 허용 범위 ±15%(비교 전 고정). 속이 빈 표식은 그 모델의 개발 자료다: 비아시아인 통합은 두 모델 일부, 일본인은 2020 ⁠모델.</a:t>
+              <a:t>음영: gate 허용 범위 ±15%(비교 전 고정). 속이 빈 표식: 그 모델의 개발 자료(비아시아인 통합은 두 모델 일부, 일본인은 2020 ⁠모델). 회색: gate 제외.</a:t>
             </a:r>
           </a:p>
           <a:p>
@@ -5602,7 +5633,7 @@
                 <a:ea typeface="Pretendard"/>
                 <a:sym typeface="Pretendard"/>
               </a:rPr>
-              <a:t>모의/관측 = 코호트 평균 체중으로 모의한 평균 AUClast / 공개 관측 평균(Clot 2021, Li 2020, Cohen 2022). 모델 파라미터는 조정하지 않았다. Cmax⁠는 gate 밖(노트).</a:t>
+              <a:t>모의/관측 = 코호트 평균 체중의 모의 평균 AUClast / 공개 관측 평균(Clot 2021, Li 2020, Cohen 2022). 파라미터 조정 없음. Cmax⁠는 노트.</a:t>
             </a:r>
           </a:p>
         </p:txBody>
@@ -5617,8 +5648,8 @@
         </p:nvSpPr>
         <p:spPr>
           <a:xfrm>
-            <a:off x="6949440" y="1417320"/>
-            <a:ext cx="4739335" cy="4639056"/>
+            <a:off x="6537960" y="1865376"/>
+            <a:ext cx="5150815" cy="3632200"/>
           </a:xfrm>
           <a:prstGeom prst="rect">
             <a:avLst/>
@@ -5636,7 +5667,7 @@
                 <a:spcPts val="0"/>
               </a:spcBef>
               <a:spcAft>
-                <a:spcPts val="1200"/>
+                <a:spcPts val="800"/>
               </a:spcAft>
               <a:buNone/>
             </a:pPr>
@@ -5652,7 +5683,7 @@
                 <a:ea typeface="Pretendard"/>
                 <a:sym typeface="Pretendard"/>
               </a:rPr>
-              <a:t>연구 제형 적격성 기준(gate)</a:t>
+              <a:t>연구 제형</a:t>
             </a:r>
             <a:r>
               <a:rPr cap="none" sz="1800" i="0" b="0" u="none">
@@ -5666,7 +5697,7 @@
                 <a:ea typeface="Pretendard"/>
                 <a:sym typeface="Pretendard"/>
               </a:rPr>
-              <a:t>: 자료 5⁠개(150 ⁠mg/mL 2 ⁠mL, 600 ⁠mg⁠은 두 번 주사)⁠의 모의/관측이 2016 ⁠모델 0.94~1.07, 2020 ⁠모델 1.02~1.13⁠이다. 그중 300 ⁠mg 자료 3⁠개는 2016 ⁠모델 0.94~1.04, 2020 ⁠모델 1.02~1.13⁠이다(S3).</a:t>
+              <a:t>(150 ⁠mg/mL 2 ⁠mL, 600 ⁠mg⁠은 두 번 주사): 모의/관측 2016 ⁠모델 0.94~1.07, 2020 ⁠모델 1.02~1.13. 그중 300 ⁠mg 3⁠개는 2016 ⁠모델 0.94~1.04, 2020 ⁠모델 1.02~1.13⁠이다(S3).</a:t>
             </a:r>
           </a:p>
           <a:p>
@@ -5678,7 +5709,7 @@
                 <a:spcPts val="0"/>
               </a:spcBef>
               <a:spcAft>
-                <a:spcPts val="1200"/>
+                <a:spcPts val="800"/>
               </a:spcAft>
               <a:buNone/>
             </a:pPr>
@@ -5708,7 +5739,7 @@
                 <a:ea typeface="Pretendard"/>
                 <a:sym typeface="Pretendard"/>
               </a:rPr>
-              <a:t>(회색, gate 제외; 175 ⁠mg/mL): 최고 농도 도달 시간(tmax)⁠이 관측 3.0~3.1⁠일, 모의 7⁠일로 빠른 흡수를 재현하지 못해 첫 비교 뒤 gate⁠에서 뺐다.</a:t>
+              <a:t>(회색; 175 ⁠mg/mL): 최고 농도 도달 시간(tmax) 관측 3.0~3.1⁠일 대 모의 7⁠일로 흡수를 재현하지 못해 첫 비교 뒤 gate⁠에서 뺐다(사후 결정).</a:t>
             </a:r>
           </a:p>
           <a:p>
@@ -5720,7 +5751,7 @@
                 <a:spcPts val="0"/>
               </a:spcBef>
               <a:spcAft>
-                <a:spcPts val="1200"/>
+                <a:spcPts val="800"/>
               </a:spcAft>
               <a:buNone/>
             </a:pPr>
@@ -5771,8 +5802,8 @@
         </p:blipFill>
         <p:spPr>
           <a:xfrm>
-            <a:off x="502920" y="1325880"/>
-            <a:ext cx="6172200" cy="3510280"/>
+            <a:off x="502920" y="1773936"/>
+            <a:ext cx="5760720" cy="3766312"/>
           </a:xfrm>
           <a:prstGeom prst="rect">
             <a:avLst/>
@@ -6063,7 +6094,7 @@
                 <a:ea typeface="Pretendard"/>
                 <a:sym typeface="Pretendard"/>
               </a:rPr>
-              <a:t>Phoenix⁠는 λz 기준을 강제하지 않아 adjusted R² 0.80·0.90⁠으로 정했다</a:t>
+              <a:t>Phoenix⁠는 λz 기준을 정하지 않아 관행 하한 0.80⁠과 공개 SAP 0.90⁠을 썼다</a:t>
             </a:r>
           </a:p>
         </p:txBody>
@@ -6448,7 +6479,7 @@
         </p:nvGraphicFramePr>
         <p:xfrm rot="0">
           <a:off x="6355080" y="1709928"/>
-          <a:ext cx="5333695" cy="2487168"/>
+          <a:ext cx="5333695" cy="2379472"/>
         </p:xfrm>
         <a:graphic>
           <a:graphicData uri="http://schemas.openxmlformats.org/drawingml/2006/table">
@@ -6889,12 +6920,8 @@
                       <a:noFill/>
                       <a:prstDash val="solid"/>
                     </a:lnT>
-                    <a:lnB algn="ctr" cmpd="sng" cap="flat" w="9525">
-                      <a:solidFill>
-                        <a:srgbClr val="E6E5E0">
-                          <a:alpha val="100000"/>
-                        </a:srgbClr>
-                      </a:solidFill>
+                    <a:lnB algn="ctr" cmpd="sng" cap="flat" w="0">
+                      <a:noFill/>
                       <a:prstDash val="solid"/>
                     </a:lnB>
                     <a:solidFill>
@@ -6950,12 +6977,8 @@
                       <a:noFill/>
                       <a:prstDash val="solid"/>
                     </a:lnT>
-                    <a:lnB algn="ctr" cmpd="sng" cap="flat" w="9525">
-                      <a:solidFill>
-                        <a:srgbClr val="E6E5E0">
-                          <a:alpha val="100000"/>
-                        </a:srgbClr>
-                      </a:solidFill>
+                    <a:lnB algn="ctr" cmpd="sng" cap="flat" w="0">
+                      <a:noFill/>
                       <a:prstDash val="solid"/>
                     </a:lnB>
                     <a:solidFill>
@@ -7011,12 +7034,8 @@
                       <a:noFill/>
                       <a:prstDash val="solid"/>
                     </a:lnT>
-                    <a:lnB algn="ctr" cmpd="sng" cap="flat" w="9525">
-                      <a:solidFill>
-                        <a:srgbClr val="E6E5E0">
-                          <a:alpha val="100000"/>
-                        </a:srgbClr>
-                      </a:solidFill>
+                    <a:lnB algn="ctr" cmpd="sng" cap="flat" w="0">
+                      <a:noFill/>
                       <a:prstDash val="solid"/>
                     </a:lnB>
                     <a:solidFill>
@@ -7072,12 +7091,8 @@
                       <a:noFill/>
                       <a:prstDash val="solid"/>
                     </a:lnT>
-                    <a:lnB algn="ctr" cmpd="sng" cap="flat" w="9525">
-                      <a:solidFill>
-                        <a:srgbClr val="E6E5E0">
-                          <a:alpha val="100000"/>
-                        </a:srgbClr>
-                      </a:solidFill>
+                    <a:lnB algn="ctr" cmpd="sng" cap="flat" w="0">
+                      <a:noFill/>
                       <a:prstDash val="solid"/>
                     </a:lnB>
                     <a:solidFill>
@@ -7133,12 +7148,8 @@
                       <a:noFill/>
                       <a:prstDash val="solid"/>
                     </a:lnT>
-                    <a:lnB algn="ctr" cmpd="sng" cap="flat" w="9525">
-                      <a:solidFill>
-                        <a:srgbClr val="E6E5E0">
-                          <a:alpha val="100000"/>
-                        </a:srgbClr>
-                      </a:solidFill>
+                    <a:lnB algn="ctr" cmpd="sng" cap="flat" w="0">
+                      <a:noFill/>
                       <a:prstDash val="solid"/>
                     </a:lnB>
                     <a:solidFill>
@@ -7192,20 +7203,12 @@
                       <a:noFill/>
                       <a:prstDash val="solid"/>
                     </a:lnR>
-                    <a:lnT algn="ctr" cmpd="sng" cap="flat" w="9525">
-                      <a:solidFill>
-                        <a:srgbClr val="E6E5E0">
-                          <a:alpha val="100000"/>
-                        </a:srgbClr>
-                      </a:solidFill>
+                    <a:lnT algn="ctr" cmpd="sng" cap="flat" w="0">
+                      <a:noFill/>
                       <a:prstDash val="solid"/>
                     </a:lnT>
-                    <a:lnB algn="ctr" cmpd="sng" cap="flat" w="9525">
-                      <a:solidFill>
-                        <a:srgbClr val="E6E5E0">
-                          <a:alpha val="100000"/>
-                        </a:srgbClr>
-                      </a:solidFill>
+                    <a:lnB algn="ctr" cmpd="sng" cap="flat" w="0">
+                      <a:noFill/>
                       <a:prstDash val="solid"/>
                     </a:lnB>
                     <a:solidFill>
@@ -7257,20 +7260,12 @@
                       <a:noFill/>
                       <a:prstDash val="solid"/>
                     </a:lnR>
-                    <a:lnT algn="ctr" cmpd="sng" cap="flat" w="9525">
-                      <a:solidFill>
-                        <a:srgbClr val="E6E5E0">
-                          <a:alpha val="100000"/>
-                        </a:srgbClr>
-                      </a:solidFill>
+                    <a:lnT algn="ctr" cmpd="sng" cap="flat" w="0">
+                      <a:noFill/>
                       <a:prstDash val="solid"/>
                     </a:lnT>
-                    <a:lnB algn="ctr" cmpd="sng" cap="flat" w="9525">
-                      <a:solidFill>
-                        <a:srgbClr val="E6E5E0">
-                          <a:alpha val="100000"/>
-                        </a:srgbClr>
-                      </a:solidFill>
+                    <a:lnB algn="ctr" cmpd="sng" cap="flat" w="0">
+                      <a:noFill/>
                       <a:prstDash val="solid"/>
                     </a:lnB>
                     <a:solidFill>
@@ -7322,20 +7317,12 @@
                       <a:noFill/>
                       <a:prstDash val="solid"/>
                     </a:lnR>
-                    <a:lnT algn="ctr" cmpd="sng" cap="flat" w="9525">
-                      <a:solidFill>
-                        <a:srgbClr val="E6E5E0">
-                          <a:alpha val="100000"/>
-                        </a:srgbClr>
-                      </a:solidFill>
+                    <a:lnT algn="ctr" cmpd="sng" cap="flat" w="0">
+                      <a:noFill/>
                       <a:prstDash val="solid"/>
                     </a:lnT>
-                    <a:lnB algn="ctr" cmpd="sng" cap="flat" w="9525">
-                      <a:solidFill>
-                        <a:srgbClr val="E6E5E0">
-                          <a:alpha val="100000"/>
-                        </a:srgbClr>
-                      </a:solidFill>
+                    <a:lnB algn="ctr" cmpd="sng" cap="flat" w="0">
+                      <a:noFill/>
                       <a:prstDash val="solid"/>
                     </a:lnB>
                     <a:solidFill>
@@ -7387,20 +7374,12 @@
                       <a:noFill/>
                       <a:prstDash val="solid"/>
                     </a:lnR>
-                    <a:lnT algn="ctr" cmpd="sng" cap="flat" w="9525">
-                      <a:solidFill>
-                        <a:srgbClr val="E6E5E0">
-                          <a:alpha val="100000"/>
-                        </a:srgbClr>
-                      </a:solidFill>
+                    <a:lnT algn="ctr" cmpd="sng" cap="flat" w="0">
+                      <a:noFill/>
                       <a:prstDash val="solid"/>
                     </a:lnT>
-                    <a:lnB algn="ctr" cmpd="sng" cap="flat" w="9525">
-                      <a:solidFill>
-                        <a:srgbClr val="E6E5E0">
-                          <a:alpha val="100000"/>
-                        </a:srgbClr>
-                      </a:solidFill>
+                    <a:lnB algn="ctr" cmpd="sng" cap="flat" w="0">
+                      <a:noFill/>
                       <a:prstDash val="solid"/>
                     </a:lnB>
                     <a:solidFill>
@@ -7452,20 +7431,12 @@
                       <a:noFill/>
                       <a:prstDash val="solid"/>
                     </a:lnR>
-                    <a:lnT algn="ctr" cmpd="sng" cap="flat" w="9525">
-                      <a:solidFill>
-                        <a:srgbClr val="E6E5E0">
-                          <a:alpha val="100000"/>
-                        </a:srgbClr>
-                      </a:solidFill>
+                    <a:lnT algn="ctr" cmpd="sng" cap="flat" w="0">
+                      <a:noFill/>
                       <a:prstDash val="solid"/>
                     </a:lnT>
-                    <a:lnB algn="ctr" cmpd="sng" cap="flat" w="9525">
-                      <a:solidFill>
-                        <a:srgbClr val="E6E5E0">
-                          <a:alpha val="100000"/>
-                        </a:srgbClr>
-                      </a:solidFill>
+                    <a:lnB algn="ctr" cmpd="sng" cap="flat" w="0">
+                      <a:noFill/>
                       <a:prstDash val="solid"/>
                     </a:lnB>
                     <a:solidFill>
@@ -7519,20 +7490,12 @@
                       <a:noFill/>
                       <a:prstDash val="solid"/>
                     </a:lnR>
-                    <a:lnT algn="ctr" cmpd="sng" cap="flat" w="9525">
-                      <a:solidFill>
-                        <a:srgbClr val="E6E5E0">
-                          <a:alpha val="100000"/>
-                        </a:srgbClr>
-                      </a:solidFill>
+                    <a:lnT algn="ctr" cmpd="sng" cap="flat" w="0">
+                      <a:noFill/>
                       <a:prstDash val="solid"/>
                     </a:lnT>
-                    <a:lnB algn="ctr" cmpd="sng" cap="flat" w="9525">
-                      <a:solidFill>
-                        <a:srgbClr val="E6E5E0">
-                          <a:alpha val="100000"/>
-                        </a:srgbClr>
-                      </a:solidFill>
+                    <a:lnB algn="ctr" cmpd="sng" cap="flat" w="0">
+                      <a:noFill/>
                       <a:prstDash val="solid"/>
                     </a:lnB>
                     <a:solidFill>
@@ -7584,20 +7547,12 @@
                       <a:noFill/>
                       <a:prstDash val="solid"/>
                     </a:lnR>
-                    <a:lnT algn="ctr" cmpd="sng" cap="flat" w="9525">
-                      <a:solidFill>
-                        <a:srgbClr val="E6E5E0">
-                          <a:alpha val="100000"/>
-                        </a:srgbClr>
-                      </a:solidFill>
+                    <a:lnT algn="ctr" cmpd="sng" cap="flat" w="0">
+                      <a:noFill/>
                       <a:prstDash val="solid"/>
                     </a:lnT>
-                    <a:lnB algn="ctr" cmpd="sng" cap="flat" w="9525">
-                      <a:solidFill>
-                        <a:srgbClr val="E6E5E0">
-                          <a:alpha val="100000"/>
-                        </a:srgbClr>
-                      </a:solidFill>
+                    <a:lnB algn="ctr" cmpd="sng" cap="flat" w="0">
+                      <a:noFill/>
                       <a:prstDash val="solid"/>
                     </a:lnB>
                     <a:solidFill>
@@ -7649,20 +7604,12 @@
                       <a:noFill/>
                       <a:prstDash val="solid"/>
                     </a:lnR>
-                    <a:lnT algn="ctr" cmpd="sng" cap="flat" w="9525">
-                      <a:solidFill>
-                        <a:srgbClr val="E6E5E0">
-                          <a:alpha val="100000"/>
-                        </a:srgbClr>
-                      </a:solidFill>
+                    <a:lnT algn="ctr" cmpd="sng" cap="flat" w="0">
+                      <a:noFill/>
                       <a:prstDash val="solid"/>
                     </a:lnT>
-                    <a:lnB algn="ctr" cmpd="sng" cap="flat" w="9525">
-                      <a:solidFill>
-                        <a:srgbClr val="E6E5E0">
-                          <a:alpha val="100000"/>
-                        </a:srgbClr>
-                      </a:solidFill>
+                    <a:lnB algn="ctr" cmpd="sng" cap="flat" w="0">
+                      <a:noFill/>
                       <a:prstDash val="solid"/>
                     </a:lnB>
                     <a:solidFill>
@@ -7714,20 +7661,12 @@
                       <a:noFill/>
                       <a:prstDash val="solid"/>
                     </a:lnR>
-                    <a:lnT algn="ctr" cmpd="sng" cap="flat" w="9525">
-                      <a:solidFill>
-                        <a:srgbClr val="E6E5E0">
-                          <a:alpha val="100000"/>
-                        </a:srgbClr>
-                      </a:solidFill>
+                    <a:lnT algn="ctr" cmpd="sng" cap="flat" w="0">
+                      <a:noFill/>
                       <a:prstDash val="solid"/>
                     </a:lnT>
-                    <a:lnB algn="ctr" cmpd="sng" cap="flat" w="9525">
-                      <a:solidFill>
-                        <a:srgbClr val="E6E5E0">
-                          <a:alpha val="100000"/>
-                        </a:srgbClr>
-                      </a:solidFill>
+                    <a:lnB algn="ctr" cmpd="sng" cap="flat" w="0">
+                      <a:noFill/>
                       <a:prstDash val="solid"/>
                     </a:lnB>
                     <a:solidFill>
@@ -7806,20 +7745,12 @@
                       <a:noFill/>
                       <a:prstDash val="solid"/>
                     </a:lnR>
-                    <a:lnT algn="ctr" cmpd="sng" cap="flat" w="9525">
-                      <a:solidFill>
-                        <a:srgbClr val="E6E5E0">
-                          <a:alpha val="100000"/>
-                        </a:srgbClr>
-                      </a:solidFill>
+                    <a:lnT algn="ctr" cmpd="sng" cap="flat" w="0">
+                      <a:noFill/>
                       <a:prstDash val="solid"/>
                     </a:lnT>
-                    <a:lnB algn="ctr" cmpd="sng" cap="flat" w="9525">
-                      <a:solidFill>
-                        <a:srgbClr val="E6E5E0">
-                          <a:alpha val="100000"/>
-                        </a:srgbClr>
-                      </a:solidFill>
+                    <a:lnB algn="ctr" cmpd="sng" cap="flat" w="0">
+                      <a:noFill/>
                       <a:prstDash val="solid"/>
                     </a:lnB>
                     <a:solidFill>
@@ -7873,17 +7804,13 @@
                       <a:noFill/>
                       <a:prstDash val="solid"/>
                     </a:lnR>
-                    <a:lnT algn="ctr" cmpd="sng" cap="flat" w="9525">
-                      <a:solidFill>
-                        <a:srgbClr val="E6E5E0">
-                          <a:alpha val="100000"/>
-                        </a:srgbClr>
-                      </a:solidFill>
+                    <a:lnT algn="ctr" cmpd="sng" cap="flat" w="0">
+                      <a:noFill/>
                       <a:prstDash val="solid"/>
                     </a:lnT>
-                    <a:lnB algn="ctr" cmpd="sng" cap="flat" w="9525">
-                      <a:solidFill>
-                        <a:srgbClr val="E6E5E0">
+                    <a:lnB algn="ctr" cmpd="sng" cap="flat" w="19050">
+                      <a:solidFill>
+                        <a:srgbClr val="52514E">
                           <a:alpha val="100000"/>
                         </a:srgbClr>
                       </a:solidFill>
@@ -7938,17 +7865,13 @@
                       <a:noFill/>
                       <a:prstDash val="solid"/>
                     </a:lnR>
-                    <a:lnT algn="ctr" cmpd="sng" cap="flat" w="9525">
-                      <a:solidFill>
-                        <a:srgbClr val="E6E5E0">
-                          <a:alpha val="100000"/>
-                        </a:srgbClr>
-                      </a:solidFill>
+                    <a:lnT algn="ctr" cmpd="sng" cap="flat" w="0">
+                      <a:noFill/>
                       <a:prstDash val="solid"/>
                     </a:lnT>
-                    <a:lnB algn="ctr" cmpd="sng" cap="flat" w="9525">
-                      <a:solidFill>
-                        <a:srgbClr val="E6E5E0">
+                    <a:lnB algn="ctr" cmpd="sng" cap="flat" w="19050">
+                      <a:solidFill>
+                        <a:srgbClr val="52514E">
                           <a:alpha val="100000"/>
                         </a:srgbClr>
                       </a:solidFill>
@@ -8003,17 +7926,13 @@
                       <a:noFill/>
                       <a:prstDash val="solid"/>
                     </a:lnR>
-                    <a:lnT algn="ctr" cmpd="sng" cap="flat" w="9525">
-                      <a:solidFill>
-                        <a:srgbClr val="E6E5E0">
-                          <a:alpha val="100000"/>
-                        </a:srgbClr>
-                      </a:solidFill>
+                    <a:lnT algn="ctr" cmpd="sng" cap="flat" w="0">
+                      <a:noFill/>
                       <a:prstDash val="solid"/>
                     </a:lnT>
-                    <a:lnB algn="ctr" cmpd="sng" cap="flat" w="9525">
-                      <a:solidFill>
-                        <a:srgbClr val="E6E5E0">
+                    <a:lnB algn="ctr" cmpd="sng" cap="flat" w="19050">
+                      <a:solidFill>
+                        <a:srgbClr val="52514E">
                           <a:alpha val="100000"/>
                         </a:srgbClr>
                       </a:solidFill>
@@ -8068,17 +7987,13 @@
                       <a:noFill/>
                       <a:prstDash val="solid"/>
                     </a:lnR>
-                    <a:lnT algn="ctr" cmpd="sng" cap="flat" w="9525">
-                      <a:solidFill>
-                        <a:srgbClr val="E6E5E0">
-                          <a:alpha val="100000"/>
-                        </a:srgbClr>
-                      </a:solidFill>
+                    <a:lnT algn="ctr" cmpd="sng" cap="flat" w="0">
+                      <a:noFill/>
                       <a:prstDash val="solid"/>
                     </a:lnT>
-                    <a:lnB algn="ctr" cmpd="sng" cap="flat" w="9525">
-                      <a:solidFill>
-                        <a:srgbClr val="E6E5E0">
+                    <a:lnB algn="ctr" cmpd="sng" cap="flat" w="19050">
+                      <a:solidFill>
+                        <a:srgbClr val="52514E">
                           <a:alpha val="100000"/>
                         </a:srgbClr>
                       </a:solidFill>
@@ -8147,7 +8062,7 @@
                           <a:ea typeface="Pretendard"/>
                           <a:sym typeface="Pretendard"/>
                         </a:rPr>
-                        <a:t>조건 + 외삽 20% 이하</a:t>
+                        <a:t>+ 외삽 20% 이하</a:t>
                       </a:r>
                     </a:p>
                   </a:txBody>
@@ -8160,17 +8075,13 @@
                       <a:noFill/>
                       <a:prstDash val="solid"/>
                     </a:lnR>
-                    <a:lnT algn="ctr" cmpd="sng" cap="flat" w="9525">
-                      <a:solidFill>
-                        <a:srgbClr val="E6E5E0">
-                          <a:alpha val="100000"/>
-                        </a:srgbClr>
-                      </a:solidFill>
+                    <a:lnT algn="ctr" cmpd="sng" cap="flat" w="0">
+                      <a:noFill/>
                       <a:prstDash val="solid"/>
                     </a:lnT>
-                    <a:lnB algn="ctr" cmpd="sng" cap="flat" w="9525">
-                      <a:solidFill>
-                        <a:srgbClr val="E6E5E0">
+                    <a:lnB algn="ctr" cmpd="sng" cap="flat" w="19050">
+                      <a:solidFill>
+                        <a:srgbClr val="52514E">
                           <a:alpha val="100000"/>
                         </a:srgbClr>
                       </a:solidFill>
@@ -8198,7 +8109,7 @@
         </p:nvSpPr>
         <p:spPr>
           <a:xfrm>
-            <a:off x="502920" y="4288536"/>
+            <a:off x="502920" y="4250436"/>
             <a:ext cx="11185855" cy="1143000"/>
           </a:xfrm>
           <a:prstGeom prst="roundRect">
@@ -8261,7 +8172,7 @@
                 <a:ea typeface="Pretendard"/>
                 <a:sym typeface="Pretendard"/>
               </a:rPr>
-              <a:t>의 Lambda Z Acceptance Criteria⁠는 사용자 선택 항목이다: 넣지 않으면 기준이 없고, 넣어도 미충족 프로필은 표시만 되며 제외되지 않는다. </a:t>
+              <a:t>의 Lambda Z Acceptance Criteria⁠는 선택 항목이다(Certara Phoenix 8.2 문서, 검색 확인·원문 미대조): 넣지 않으면 기준이 없고, 넣어도 미충족 프로필은 제외되지 않는다. </a:t>
             </a:r>
             <a:r>
               <a:rPr cap="none" sz="1800" i="0" b="1" u="none">
@@ -8275,7 +8186,7 @@
                 <a:ea typeface="Pretendard"/>
                 <a:sym typeface="Pretendard"/>
               </a:rPr>
-              <a:t>공개 통계분석계획의 λz 기준</a:t>
+              <a:t>공개 SAP⁠의 λz 기준</a:t>
             </a:r>
             <a:r>
               <a:rPr cap="none" sz="1800" i="0" b="0" u="none">
@@ -14047,14 +13958,14 @@
                 <a:ea typeface="Pretendard"/>
                 <a:sym typeface="Pretendard"/>
               </a:rPr>
-              <a:t>잔차를 절반으로 줄이면 세트 ⁠(iii) 미달은 38.8%⁠에서 27.2%⁠로 줄지만 남고, arm 간 미달 차이는 제품 차이의 기전이 정한다</a:t>
+              <a:t>2016 ⁠모델에서 잔차를 절반으로 줄이면 세트 ⁠(iii) 미달은 38.8%⁠에서 27.2%⁠로 줄지만 남고, arm 간 미달 차이는 제품 차이의 기전이 정한다</a:t>
             </a:r>
           </a:p>
         </p:txBody>
       </p:sp>
       <p:sp>
         <p:nvSpPr>
-          <p:cNvPr id="5" name="body"/>
+          <p:cNvPr id="5" name="caption"/>
           <p:cNvSpPr>
             <a:spLocks noGrp="1"/>
           </p:cNvSpPr>
@@ -14062,8 +13973,58 @@
         </p:nvSpPr>
         <p:spPr>
           <a:xfrm>
-            <a:off x="502920" y="4767072"/>
-            <a:ext cx="11185855" cy="1487424"/>
+            <a:off x="502920" y="5675376"/>
+            <a:ext cx="11185855" cy="579120"/>
+          </a:xfrm>
+          <a:prstGeom prst="rect">
+            <a:avLst/>
+          </a:prstGeom>
+        </p:spPr>
+        <p:txBody>
+          <a:bodyPr/>
+          <a:lstStyle/>
+          <a:p>
+            <a:pPr algn="l" marL="0" marR="0" eaLnBrk="0">
+              <a:lnSpc>
+                <a:spcPct val="110000"/>
+              </a:lnSpc>
+              <a:spcBef>
+                <a:spcPts val="0"/>
+              </a:spcBef>
+              <a:spcAft>
+                <a:spcPts val="200"/>
+              </a:spcAft>
+              <a:buNone/>
+            </a:pPr>
+            <a:r>
+              <a:rPr cap="none" sz="1400" i="0" b="0" u="none">
+                <a:solidFill>
+                  <a:srgbClr val="52514E">
+                    <a:alpha val="100000"/>
+                  </a:srgbClr>
+                </a:solidFill>
+                <a:latin typeface="Pretendard"/>
+                <a:cs typeface="Pretendard"/>
+                <a:ea typeface="Pretendard"/>
+                <a:sym typeface="Pretendard"/>
+              </a:rPr>
+              <a:t>세트 ⁠(iii) = 신뢰할 수 있는 AUCinf(adjusted R² ≥ ⁠0.90, 외삽 ≤ ⁠20%), (i) = adjusted R² ≥ ⁠0.80·외삽 ≤ ⁠20%, (iv) = (iii) + span ≥ ⁠3. 오른쪽의 시험약은 기전 하나만 바꾼 가상 제품이며, 흡수 속도 감소 칸(13.0%p)⁠은 Cmax 비가 0.63⁠으로 늘 불통과라 요약 최댓값에서 뺐다.</a:t>
+            </a:r>
+          </a:p>
+        </p:txBody>
+      </p:sp>
+      <p:sp>
+        <p:nvSpPr>
+          <p:cNvPr id="6" name="body"/>
+          <p:cNvSpPr>
+            <a:spLocks noGrp="1"/>
+          </p:cNvSpPr>
+          <p:nvPr/>
+        </p:nvSpPr>
+        <p:spPr>
+          <a:xfrm>
+            <a:off x="502920" y="4503928"/>
+            <a:ext cx="11185855" cy="1134872"/>
           </a:xfrm>
           <a:prstGeom prst="rect">
             <a:avLst/>
@@ -14081,7 +14042,7 @@
                 <a:spcPts val="0"/>
               </a:spcBef>
               <a:spcAft>
-                <a:spcPts val="600"/>
+                <a:spcPts val="400"/>
               </a:spcAft>
               <a:buClr>
                 <a:srgbClr val="2A78D6"/>
@@ -14115,7 +14076,7 @@
                 <a:ea typeface="Pretendard"/>
                 <a:sym typeface="Pretendard"/>
               </a:rPr>
-              <a:t>: 잔차를 줄여도 세트 ⁠(iii) 미달이 남고, 정량한계를 낮추면 세트 ⁠(i) 충족이 오히려 2.3~5.9%p 준다.</a:t>
+              <a:t>: 잔차를 줄여도 미달이 남고, 정량한계를 낮추면 세트 ⁠(i) 충족이 오히려 2.3~5.9%p 줄어든다.</a:t>
             </a:r>
           </a:p>
           <a:p>
@@ -14127,7 +14088,7 @@
                 <a:spcPts val="0"/>
               </a:spcBef>
               <a:spcAft>
-                <a:spcPts val="600"/>
+                <a:spcPts val="400"/>
               </a:spcAft>
               <a:buClr>
                 <a:srgbClr val="2A78D6"/>
@@ -14161,7 +14122,7 @@
                 <a:ea typeface="Pretendard"/>
                 <a:sym typeface="Pretendard"/>
               </a:rPr>
-              <a:t>: 기준 미달자는 참 AUCinf⁠가 충족자의 0.90~0.93⁠배이고, 무거운 체중 층에 2.0~2.3%p 더 많다.</a:t>
+              <a:t>: 참 AUCinf⁠는 미달자가 충족자의 0.90~0.93⁠배, 무거운 체중 층의 미달 비율이 2.0~2.3%p 높다.</a:t>
             </a:r>
           </a:p>
           <a:p>
@@ -14173,7 +14134,7 @@
                 <a:spcPts val="0"/>
               </a:spcBef>
               <a:spcAft>
-                <a:spcPts val="600"/>
+                <a:spcPts val="400"/>
               </a:spcAft>
               <a:buClr>
                 <a:srgbClr val="2A78D6"/>
@@ -14207,14 +14168,14 @@
                 <a:ea typeface="Pretendard"/>
                 <a:sym typeface="Pretendard"/>
               </a:rPr>
-              <a:t>: 동일 제품이면 평균 0.2%p 이내, 참 비 0.80 시험약은 최대 9.4%p⁠다. 흡수 속도 감소 칸(13.0%p)⁠은 Cmax 비가 0.63⁠로 늘 불통과라 제외했다.</a:t>
+              <a:t>: 동일 제품이면 평균 0.2%p 이내, 참 비 0.80 시험약은 최대 9.4%p⁠다(흡수 속도 감소 칸 제외, 아래).</a:t>
             </a:r>
           </a:p>
         </p:txBody>
       </p:sp>
       <p:pic>
         <p:nvPicPr>
-          <p:cNvPr id="6" name="figure_a3b_residual" descr=""/>
+          <p:cNvPr id="7" name="figure_a3b_residual" descr=""/>
           <p:cNvPicPr>
             <a:picLocks noGrp="1"/>
           </p:cNvPicPr>
@@ -14229,7 +14190,7 @@
         <p:spPr>
           <a:xfrm>
             <a:off x="502920" y="1773936"/>
-            <a:ext cx="3429000" cy="2901696"/>
+            <a:ext cx="3429000" cy="2638552"/>
           </a:xfrm>
           <a:prstGeom prst="rect">
             <a:avLst/>
@@ -14238,7 +14199,7 @@
       </p:pic>
       <p:pic>
         <p:nvPicPr>
-          <p:cNvPr id="7" name="figure_a3b_arm_difference" descr=""/>
+          <p:cNvPr id="8" name="figure_a3b_arm_difference" descr=""/>
           <p:cNvPicPr>
             <a:picLocks noGrp="1"/>
           </p:cNvPicPr>
@@ -14253,7 +14214,7 @@
         <p:spPr>
           <a:xfrm>
             <a:off x="4114800" y="1773936"/>
-            <a:ext cx="7573975" cy="2901696"/>
+            <a:ext cx="7573975" cy="2638552"/>
           </a:xfrm>
           <a:prstGeom prst="rect">
             <a:avLst/>
@@ -14262,7 +14223,7 @@
       </p:pic>
       <p:sp>
         <p:nvSpPr>
-          <p:cNvPr id="8" name="footer_src"/>
+          <p:cNvPr id="9" name="footer_src"/>
           <p:cNvSpPr>
             <a:spLocks noGrp="1"/>
           </p:cNvSpPr>
@@ -14312,7 +14273,7 @@
       </p:sp>
       <p:sp>
         <p:nvSpPr>
-          <p:cNvPr id="9" name="footer_ver"/>
+          <p:cNvPr id="10" name="footer_ver"/>
           <p:cNvSpPr>
             <a:spLocks noGrp="1"/>
           </p:cNvSpPr>
@@ -14510,7 +14471,7 @@
         <p:spPr>
           <a:xfrm>
             <a:off x="502920" y="603504"/>
-            <a:ext cx="11094415" cy="576072"/>
+            <a:ext cx="11094415" cy="1024128"/>
           </a:xfrm>
           <a:prstGeom prst="rect">
             <a:avLst/>
@@ -14544,7 +14505,35 @@
                 <a:ea typeface="Pretendard"/>
                 <a:sym typeface="Pretendard"/>
               </a:rPr>
-              <a:t>2020 ⁠모델도 AUClast/AUCinf⁠는 대표 대상자 99%, 최솟값도 84%⁠다</a:t>
+              <a:t>2020 ⁠모델도 AUClast/AUCinf⁠는 중앙값 대상자에서 99%,</a:t>
+            </a:r>
+          </a:p>
+          <a:p>
+            <a:pPr algn="l" marL="0" marR="0" eaLnBrk="0">
+              <a:lnSpc>
+                <a:spcPct val="105000"/>
+              </a:lnSpc>
+              <a:spcBef>
+                <a:spcPts val="0"/>
+              </a:spcBef>
+              <a:spcAft>
+                <a:spcPts val="0"/>
+              </a:spcAft>
+              <a:buNone/>
+            </a:pPr>
+            <a:r>
+              <a:rPr cap="none" sz="2800" i="0" b="1" u="none">
+                <a:solidFill>
+                  <a:srgbClr val="0B0B0B">
+                    <a:alpha val="100000"/>
+                  </a:srgbClr>
+                </a:solidFill>
+                <a:latin typeface="Pretendard"/>
+                <a:cs typeface="Pretendard"/>
+                <a:ea typeface="Pretendard"/>
+                <a:sym typeface="Pretendard"/>
+              </a:rPr>
+              <a:t>모의 대상자 중 최솟값도 84.3%⁠다</a:t>
             </a:r>
           </a:p>
         </p:txBody>
@@ -14559,8 +14548,8 @@
         </p:nvSpPr>
         <p:spPr>
           <a:xfrm>
-            <a:off x="502920" y="5649976"/>
-            <a:ext cx="11185855" cy="604520"/>
+            <a:off x="502920" y="5415280"/>
+            <a:ext cx="11185855" cy="839216"/>
           </a:xfrm>
           <a:prstGeom prst="rect">
             <a:avLst/>
@@ -14594,7 +14583,7 @@
                 <a:ea typeface="Pretendard"/>
                 <a:sym typeface="Pretendard"/>
               </a:rPr>
-              <a:t>파랑: AUClast, 주황: tlast 이후 참 외삽(모델 적분), 세로 점선: 관측 tlast. 삽입도: 점선 = 비구획 외삽선, 빗금 = 비구획 외삽.</a:t>
+              <a:t>파랑: AUClast, 주황: tlast 이후 참 외삽, 점: 관측(빈 점 = 정량한계 미만), 세로 점선: 관측 tlast. 삽입도: 점선 = 비구획 외삽선, 빗금 = 비구획 외삽.</a:t>
             </a:r>
           </a:p>
           <a:p>
@@ -14622,7 +14611,7 @@
                 <a:ea typeface="Pretendard"/>
                 <a:sym typeface="Pretendard"/>
               </a:rPr>
-              <a:t>세 대상자: 2020 ⁠모델 20,000⁠명 중 중앙값·5⁠번째 백분위수·최솟값. 외삽 비율 중앙값은 비구획 2.9% 대 참 0.64%(2016 ⁠모델은 S7).</a:t>
+              <a:t>세 대상자: 2020 ⁠모델 20,000⁠명 중 중앙값·5⁠번째 백분위수·최솟값. 외삽 비율 중앙값은 비구획 2.9%(λz 산출 대상자) 대 참 0.64%(전원); 2016 ⁠모델은 S7.</a:t>
             </a:r>
           </a:p>
         </p:txBody>
@@ -14637,7 +14626,7 @@
         </p:nvSpPr>
         <p:spPr>
           <a:xfrm>
-            <a:off x="502920" y="4881880"/>
+            <a:off x="502920" y="4647184"/>
             <a:ext cx="11185855" cy="713232"/>
           </a:xfrm>
           <a:prstGeom prst="rect">
@@ -14693,8 +14682,8 @@
         </p:blipFill>
         <p:spPr>
           <a:xfrm>
-            <a:off x="502920" y="1325880"/>
-            <a:ext cx="11185855" cy="3482848"/>
+            <a:off x="502920" y="1773936"/>
+            <a:ext cx="11185855" cy="2800096"/>
           </a:xfrm>
           <a:prstGeom prst="rect">
             <a:avLst/>
@@ -15013,7 +15002,7 @@
                 <a:ea typeface="Pretendard"/>
                 <a:sym typeface="Pretendard"/>
               </a:rPr>
-              <a:t>NCA AUCinf⁠는 참값의 최대 5.3⁠배까지 퍼진다</a:t>
+              <a:t>비구획 AUCinf⁠는 참 AUCinf⁠의 최대 5.3⁠배(2016 ⁠모델)⁠에 이른다</a:t>
             </a:r>
           </a:p>
         </p:txBody>
@@ -15063,7 +15052,7 @@
                 <a:ea typeface="Pretendard"/>
                 <a:sym typeface="Pretendard"/>
               </a:rPr>
-              <a:t>세로축: 대상자 비율(구간 0.02, 로그 눈금). 관측 대 참 비에는 잔차 오차와 사다리꼴 근사가 들어가며, 동일 제품이면 두 arm⁠에 같게 들어간다. NCA AUCinf⁠는 외삽을 과대추정한다(외삽 비율 중앙값 2.7~2.9% 대 참 0.64~0.65%, S7).</a:t>
+              <a:t>세로축: 대상자 비율(구간 0.02, 로그 눈금). 관측 대 참 비에는 잔차 오차와 사다리꼴 근사가 들어가며, 동일 제품이면 두 arm⁠에 같게 들어간다. NCA AUCinf⁠는 외삽을 과대추정한다(외삽 비율 중앙값 2.7~2.9%(λz 산출 대상자) 대 참 0.64~0.65%(전원), S7).</a:t>
             </a:r>
           </a:p>
           <a:p>
@@ -18688,7 +18677,7 @@
                 <a:ea typeface="Pretendard"/>
                 <a:sym typeface="Pretendard"/>
               </a:rPr>
-              <a:t>AUCinf + Cmax⁠는 9⁠칸이 초과, AUClast + Cmax⁠는 15⁠칸이 보수적이다</a:t>
+              <a:t>Wilson 초과는 AUCinf + Cmax 16⁠칸 중 9⁠칸, AUClast + Cmax 1⁠칸이다</a:t>
             </a:r>
           </a:p>
         </p:txBody>
@@ -18703,8 +18692,8 @@
         </p:nvSpPr>
         <p:spPr>
           <a:xfrm>
-            <a:off x="502920" y="5649976"/>
-            <a:ext cx="11185855" cy="604520"/>
+            <a:off x="502920" y="5389880"/>
+            <a:ext cx="11185855" cy="864616"/>
           </a:xfrm>
           <a:prstGeom prst="rect">
             <a:avLst/>
@@ -18766,7 +18755,35 @@
                 <a:ea typeface="Pretendard"/>
                 <a:sym typeface="Pretendard"/>
               </a:rPr>
-              <a:t>M1(체중 층 포함), 시험 10,000⁠회(†: 20,000⁠회). 흡수 속도 감소 두 칸의 0%⁠는 Cmax⁠가 늘 불통과한 결과로 판정 정보가 없다.</a:t>
+              <a:t>칸 = 모델 × 경계 조건(16 = 2 ⁠모델 × ⁠8 조건). M1(체중 층 포함), 시험 10,000⁠회(†: 20,000⁠회). 참고: 참 AUCinf 단독 판정(M1) 4.53~5.83%.</a:t>
+            </a:r>
+          </a:p>
+          <a:p>
+            <a:pPr algn="l" marL="0" marR="0" eaLnBrk="0">
+              <a:lnSpc>
+                <a:spcPct val="110000"/>
+              </a:lnSpc>
+              <a:spcBef>
+                <a:spcPts val="0"/>
+              </a:spcBef>
+              <a:spcAft>
+                <a:spcPts val="200"/>
+              </a:spcAft>
+              <a:buNone/>
+            </a:pPr>
+            <a:r>
+              <a:rPr cap="none" sz="1400" i="0" b="0" u="none">
+                <a:solidFill>
+                  <a:srgbClr val="52514E">
+                    <a:alpha val="100000"/>
+                  </a:srgbClr>
+                </a:solidFill>
+                <a:latin typeface="Pretendard"/>
+                <a:cs typeface="Pretendard"/>
+                <a:ea typeface="Pretendard"/>
+                <a:sym typeface="Pretendard"/>
+              </a:rPr>
+              <a:t>흡수 속도 감소 두 칸의 0%⁠는 Cmax⁠가 늘 불통과한 결과로 판정 정보가 없다.</a:t>
             </a:r>
           </a:p>
         </p:txBody>
@@ -18781,8 +18798,8 @@
         </p:nvSpPr>
         <p:spPr>
           <a:xfrm>
-            <a:off x="502920" y="4881880"/>
-            <a:ext cx="11185855" cy="713232"/>
+            <a:off x="502920" y="4923536"/>
+            <a:ext cx="11185855" cy="411480"/>
           </a:xfrm>
           <a:prstGeom prst="rect">
             <a:avLst/>
@@ -18816,7 +18833,7 @@
                 <a:ea typeface="Pretendard"/>
                 <a:sym typeface="Pretendard"/>
               </a:rPr>
-              <a:t>S9⁠의 10⁠개는 점추정 기준이다. 2016 ⁠모델 선형 소실 증가 칸(5.30%)⁠은 점추정이 5%⁠를 넘지만 95% 구간이 5%⁠를 포함해 명목이다.</a:t>
+              <a:t>S9⁠의 10⁠개는 점추정 기준이다: 2016 ⁠모델 선형 소실 증가 칸(5.30%)⁠은 95% 구간이 5%⁠를 포함해 명목이다.</a:t>
             </a:r>
           </a:p>
         </p:txBody>
@@ -18881,7 +18898,7 @@
         </p:nvGraphicFramePr>
         <p:xfrm rot="0">
           <a:off x="502920" y="1682496"/>
-          <a:ext cx="5455768" cy="3107944"/>
+          <a:ext cx="5455768" cy="3149600"/>
         </p:xfrm>
         <a:graphic>
           <a:graphicData uri="http://schemas.openxmlformats.org/drawingml/2006/table">
@@ -20771,7 +20788,7 @@
         </p:nvGraphicFramePr>
         <p:xfrm rot="0">
           <a:off x="6233008" y="1682496"/>
-          <a:ext cx="5455768" cy="3107944"/>
+          <a:ext cx="5455768" cy="3149600"/>
         </p:xfrm>
         <a:graphic>
           <a:graphicData uri="http://schemas.openxmlformats.org/drawingml/2006/table">
@@ -22885,7 +22902,7 @@
                 <a:ea typeface="Pretendard"/>
                 <a:sym typeface="Pretendard"/>
               </a:rPr>
-              <a:t>AUCinf + Cmax⁠는 M0·M1 모두 16⁠칸 중 9~10⁠칸의 점추정이 5%⁠를 넘고,</a:t>
+              <a:t>신뢰할 수 있는 AUCinf + Cmax(규칙 ⁠A (iii))⁠는 M0·M1 모두 9~10⁠칸,</a:t>
             </a:r>
           </a:p>
           <a:p>
@@ -22913,7 +22930,7 @@
                 <a:ea typeface="Pretendard"/>
                 <a:sym typeface="Pretendard"/>
               </a:rPr>
-              <a:t>AUClast + Cmax⁠의 점추정 5% 초과 한 칸은 AUClast 편향에서 나온다</a:t>
+              <a:t>AUClast + Cmax⁠는 16⁠칸 중 1⁠칸(AUClast 편향)⁠만 점추정이 5%⁠를 넘는다</a:t>
             </a:r>
           </a:p>
         </p:txBody>
@@ -22963,7 +22980,7 @@
                 <a:ea typeface="Pretendard"/>
                 <a:sym typeface="Pretendard"/>
               </a:rPr>
-              <a:t>기전(M1): 표적 소실 증가 칸(참 비 0.80)⁠에서 비구획 AUCinf GMR⁠이 1 쪽으로 4.5%·3.6% 치우친다(2016/2020 ⁠모델; λz 산출 전원 3.3%·2.6%).</a:t>
+              <a:t>표적 소실 증가 칸의 AUCinf GMR 편향(1 쪽): 신뢰할 수 있는 AUCinf⁠만(규칙 ⁠A (iii)) 4.5%·3.6%, λz 산출 전원 3.3%·2.6%(2016/2020 ⁠모델, M1)</a:t>
             </a:r>
           </a:p>
           <a:p>
@@ -23019,7 +23036,7 @@
                 <a:ea typeface="Pretendard"/>
                 <a:sym typeface="Pretendard"/>
               </a:rPr>
-              <a:t>규칙 ⁠B: λz 산출 전원 · 규칙 ⁠C: 미달자에 AUClast 대입 · M1: 체중 층(주분석 후보) · 미산출: 사전 등록 범위(M0·M1) 밖</a:t>
+              <a:t>규칙 ⁠B: λz 산출 전원 · 규칙 ⁠C: 미달자에 AUClast 대입 · M0: 층 없음(현행) · M1: 체중 층 포함(주분석 후보) · M2: log 체중 · 미산출: 사전 등록 범위 밖</a:t>
             </a:r>
           </a:p>
         </p:txBody>
@@ -23069,7 +23086,7 @@
                 <a:ea typeface="Pretendard"/>
                 <a:sym typeface="Pretendard"/>
               </a:rPr>
-              <a:t>점추정이 5%⁠를 넘는 AUClast + Cmax 한 칸(M1·M2⁠는 Wilson 초과, M0⁠는 명목)⁠은 AUClast 기하평균비(GMR)⁠가 동등 쪽으로 +0.41% 치우친 결과로, 16⁠칸 중 이 칸뿐이다.</a:t>
+              <a:t>점추정이 5%⁠를 넘는 AUClast + Cmax 한 칸(M1·M2⁠는 Wilson 초과, M0⁠는 명목)⁠은 AUClast 기하평균비(GMR)⁠가 1 쪽(동등 판정 쪽)⁠으로 0.41% 치우친 결과로, 16⁠칸 중 이 칸뿐이다.</a:t>
             </a:r>
           </a:p>
         </p:txBody>
@@ -26881,7 +26898,7 @@
                 <a:ea typeface="Pretendard"/>
                 <a:sym typeface="Pretendard"/>
               </a:rPr>
-              <a:t>현행 B0(Day ⁠57⁠까지 13⁠회 채혈)⁠를 유지한다: 채혈 후보 어느 것도 두 모델에서 결정 기준 ⁠(a)~(d)⁠를 충족하지 못했다</a:t>
+              <a:t>현행 B0(Day ⁠57⁠까지 13⁠회 채혈)⁠를 유지한다: 채혈 후보 어느 것도 두 모델의 기본 조건에서 결정 기준 ⁠(a)~(d)⁠를 충족하지 못했다</a:t>
             </a:r>
           </a:p>
         </p:txBody>
@@ -26896,7 +26913,7 @@
         </p:nvGraphicFramePr>
         <p:xfrm rot="0">
           <a:off x="502920" y="1773936"/>
-          <a:ext cx="11185855" cy="2312416"/>
+          <a:ext cx="11185855" cy="2294128"/>
         </p:xfrm>
         <a:graphic>
           <a:graphicData uri="http://schemas.openxmlformats.org/drawingml/2006/table">
@@ -29698,8 +29715,8 @@
         </p:nvSpPr>
         <p:spPr>
           <a:xfrm>
-            <a:off x="502920" y="5675376"/>
-            <a:ext cx="11185855" cy="579120"/>
+            <a:off x="502920" y="5440680"/>
+            <a:ext cx="11185855" cy="813816"/>
           </a:xfrm>
           <a:prstGeom prst="rect">
             <a:avLst/>
@@ -29733,7 +29750,7 @@
                 <a:ea typeface="Pretendard"/>
                 <a:sym typeface="Pretendard"/>
               </a:rPr>
-              <a:t>Vmax ⁠×0.8 변형의 B0 유지 사유(판정 기록 D-031): 부트스트랩 95% 구간 0.37~0.62⁠가 0.5 포함, 감소 arm⁠당 0.26⁠명, 추가 방문 1,040⁠회, 규칙에 절대 하한 없음. 결정 규칙은 첫 일정 모의 뒤, 결과 보고 전에 정했다(사전 규정 아님). (a)·(b)⁠는 합동 t 검정(M0)⁠의 시험 수준, (c)·(d)·세트 ⁠(iii)⁠은 대상자 수준 결과다.</a:t>
+              <a:t>Vmax ⁠×0.8 변형의 B0 유지 사유(D-031): 부트스트랩 95% 구간 0.37~0.62⁠가 0.5 포함, 외삽 20% 초과 대상자 절대 감소 arm⁠당 0.26⁠명, 추가 방문 1,040⁠회, 규칙에 절대 하한 없음. 결정 규칙은 첫 일정 모의 뒤, 결과 보고 전에 정했다(사전 규정 아님). (a)·(b)⁠는 합동 t 검정(M0) 시험 수준, 나머지는 대상자 수준. 세트 ⁠(ii) = adjusted R² ≥ ⁠0.80, 외삽 ≤ ⁠20%, span ≥ ⁠2; 세트 ⁠(iii) = 신뢰할 수 있는 AUCinf(adjusted R² ≥ ⁠0.90, 외삽 ≤ ⁠20%).</a:t>
             </a:r>
           </a:p>
         </p:txBody>
@@ -29748,8 +29765,8 @@
         </p:nvSpPr>
         <p:spPr>
           <a:xfrm>
-            <a:off x="502920" y="4177792"/>
-            <a:ext cx="11185855" cy="1461008"/>
+            <a:off x="502920" y="4086352"/>
+            <a:ext cx="11185855" cy="1336040"/>
           </a:xfrm>
           <a:prstGeom prst="rect">
             <a:avLst/>
@@ -29767,7 +29784,7 @@
                 <a:spcPts val="0"/>
               </a:spcBef>
               <a:spcAft>
-                <a:spcPts val="600"/>
+                <a:spcPts val="300"/>
               </a:spcAft>
               <a:buClr>
                 <a:srgbClr val="2A78D6"/>
@@ -29799,7 +29816,7 @@
                 <a:spcPts val="0"/>
               </a:spcBef>
               <a:spcAft>
-                <a:spcPts val="600"/>
+                <a:spcPts val="300"/>
               </a:spcAft>
               <a:buClr>
                 <a:srgbClr val="2A78D6"/>
@@ -29819,7 +29836,7 @@
                 <a:ea typeface="Pretendard"/>
                 <a:sym typeface="Pretendard"/>
               </a:rPr>
-              <a:t>민감도 변형(양 군 최대 소실 속도(Vmax) ×0.8)⁠에서는 D3⁠가 기준 ⁠(d)⁠를 충족했으나(20,000⁠명 0.488; 200,000⁠명 재평가 0.586⁠는 미충족), 판정 기록은 B0⁠를 유지했다.</a:t>
+              <a:t>민감도 변형(두 arm 모두 최대 소실 속도(Vmax) ×0.8)⁠에서는 D3⁠가 기준 ⁠(d)⁠를 충족했으나(20,000⁠명 0.488; 200,000⁠명 재평가 0.586⁠은 미충족), 판정 기록은 B0⁠를 유지했다.</a:t>
             </a:r>
           </a:p>
         </p:txBody>
@@ -31956,8 +31973,8 @@
         </p:nvSpPr>
         <p:spPr>
           <a:xfrm>
-            <a:off x="502920" y="5649976"/>
-            <a:ext cx="11185855" cy="604520"/>
+            <a:off x="502920" y="5389880"/>
+            <a:ext cx="11185855" cy="864616"/>
           </a:xfrm>
           <a:prstGeom prst="rect">
             <a:avLst/>
@@ -32019,6 +32036,34 @@
                 <a:ea typeface="Pretendard"/>
                 <a:sym typeface="Pretendard"/>
               </a:rPr>
+              <a:t>Cmax: 변동계수 34.3%(모의값 고정), 참 Cmax 비 = 참 AUClast 비(보수적 가정). M1 = 투여군 + 무작위배정 체중 층 분산분석(주분석 후보).</a:t>
+            </a:r>
+          </a:p>
+          <a:p>
+            <a:pPr algn="l" marL="0" marR="0" eaLnBrk="0">
+              <a:lnSpc>
+                <a:spcPct val="110000"/>
+              </a:lnSpc>
+              <a:spcBef>
+                <a:spcPts val="0"/>
+              </a:spcBef>
+              <a:spcAft>
+                <a:spcPts val="200"/>
+              </a:spcAft>
+              <a:buNone/>
+            </a:pPr>
+            <a:r>
+              <a:rPr cap="none" sz="1400" i="0" b="0" u="none">
+                <a:solidFill>
+                  <a:srgbClr val="52514E">
+                    <a:alpha val="100000"/>
+                  </a:srgbClr>
+                </a:solidFill>
+                <a:latin typeface="Pretendard"/>
+                <a:cs typeface="Pretendard"/>
+                <a:ea typeface="Pretendard"/>
+                <a:sym typeface="Pretendard"/>
+              </a:rPr>
               <a:t>CV 근거: PK 모델 40.3%(2016 ⁠모델), 42.8%(2020 ⁠모델), Li 2020 표준편차/평균 35~51%, Cohen 2022 약 52%(다른 제형).</a:t>
             </a:r>
           </a:p>
@@ -32034,8 +32079,8 @@
         </p:nvSpPr>
         <p:spPr>
           <a:xfrm>
-            <a:off x="502920" y="4794504"/>
-            <a:ext cx="6949440" cy="764032"/>
+            <a:off x="502920" y="4269232"/>
+            <a:ext cx="6949440" cy="1065784"/>
           </a:xfrm>
           <a:prstGeom prst="rect">
             <a:avLst/>
@@ -32069,7 +32114,7 @@
                 <a:ea typeface="Pretendard"/>
                 <a:sym typeface="Pretendard"/>
               </a:rPr>
-              <a:t>현행 117⁠명(무작위배정 130⁠명)⁠은 CV 46%⁠까지 검정력 90% 이상이다.</a:t>
+              <a:t>참 기하평균비 0.95⁠에서 현행 117⁠명(무작위배정 130⁠명)⁠은 CV 46%⁠까지 검정력 90% 이상이다.</a:t>
             </a:r>
           </a:p>
           <a:p>
@@ -32147,7 +32192,7 @@
                 <a:ea typeface="Pretendard"/>
                 <a:sym typeface="Pretendard"/>
               </a:rPr>
-              <a:t>동시 통과 검정력(%, M1) · 열 = arm⁠당 평가 가능 인원</a:t>
+              <a:t>동시 통과 검정력(%, M1, 참 기하평균비 0.95) · 열 = arm⁠당 평가 가능 인원</a:t>
             </a:r>
           </a:p>
         </p:txBody>
@@ -32162,7 +32207,7 @@
         </p:nvGraphicFramePr>
         <p:xfrm rot="0">
           <a:off x="502920" y="2139696"/>
-          <a:ext cx="6949440" cy="2563368"/>
+          <a:ext cx="6949440" cy="2074672"/>
         </p:xfrm>
         <a:graphic>
           <a:graphicData uri="http://schemas.openxmlformats.org/drawingml/2006/table">
@@ -32186,10 +32231,10 @@
                           <a:spcPct val="100000"/>
                         </a:lnSpc>
                         <a:spcBef>
-                          <a:spcPts val="400"/>
+                          <a:spcPts val="200"/>
                         </a:spcBef>
                         <a:spcAft>
-                          <a:spcPts val="400"/>
+                          <a:spcPts val="200"/>
                         </a:spcAft>
                         <a:buNone/>
                       </a:pPr>
@@ -32236,7 +32281,7 @@
                       </a:r>
                     </a:p>
                   </a:txBody>
-                  <a:tcPr anchor="ctr" marB="50800" marT="50800" marR="0" marL="0">
+                  <a:tcPr anchor="ctr" marB="25400" marT="25400" marR="0" marL="0">
                     <a:lnL algn="ctr" cmpd="sng" cap="flat" w="0">
                       <a:noFill/>
                       <a:prstDash val="solid"/>
@@ -32278,10 +32323,10 @@
                           <a:spcPct val="100000"/>
                         </a:lnSpc>
                         <a:spcBef>
-                          <a:spcPts val="400"/>
+                          <a:spcPts val="200"/>
                         </a:spcBef>
                         <a:spcAft>
-                          <a:spcPts val="400"/>
+                          <a:spcPts val="200"/>
                         </a:spcAft>
                         <a:buNone/>
                       </a:pPr>
@@ -32301,7 +32346,7 @@
                       </a:r>
                     </a:p>
                   </a:txBody>
-                  <a:tcPr anchor="ctr" marB="50800" marT="50800" marR="0" marL="0">
+                  <a:tcPr anchor="ctr" marB="25400" marT="25400" marR="0" marL="0">
                     <a:lnL algn="ctr" cmpd="sng" cap="flat" w="0">
                       <a:noFill/>
                       <a:prstDash val="solid"/>
@@ -32343,10 +32388,10 @@
                           <a:spcPct val="100000"/>
                         </a:lnSpc>
                         <a:spcBef>
-                          <a:spcPts val="400"/>
+                          <a:spcPts val="200"/>
                         </a:spcBef>
                         <a:spcAft>
-                          <a:spcPts val="400"/>
+                          <a:spcPts val="200"/>
                         </a:spcAft>
                         <a:buNone/>
                       </a:pPr>
@@ -32393,7 +32438,7 @@
                       </a:r>
                     </a:p>
                   </a:txBody>
-                  <a:tcPr anchor="ctr" marB="50800" marT="50800" marR="0" marL="0">
+                  <a:tcPr anchor="ctr" marB="25400" marT="25400" marR="0" marL="0">
                     <a:lnL algn="ctr" cmpd="sng" cap="flat" w="0">
                       <a:noFill/>
                       <a:prstDash val="solid"/>
@@ -32435,10 +32480,10 @@
                           <a:spcPct val="100000"/>
                         </a:lnSpc>
                         <a:spcBef>
-                          <a:spcPts val="400"/>
+                          <a:spcPts val="200"/>
                         </a:spcBef>
                         <a:spcAft>
-                          <a:spcPts val="400"/>
+                          <a:spcPts val="200"/>
                         </a:spcAft>
                         <a:buNone/>
                       </a:pPr>
@@ -32458,7 +32503,7 @@
                       </a:r>
                     </a:p>
                   </a:txBody>
-                  <a:tcPr anchor="ctr" marB="50800" marT="50800" marR="0" marL="0">
+                  <a:tcPr anchor="ctr" marB="25400" marT="25400" marR="0" marL="0">
                     <a:lnL algn="ctr" cmpd="sng" cap="flat" w="0">
                       <a:noFill/>
                       <a:prstDash val="solid"/>
@@ -32500,10 +32545,10 @@
                           <a:spcPct val="100000"/>
                         </a:lnSpc>
                         <a:spcBef>
-                          <a:spcPts val="400"/>
+                          <a:spcPts val="200"/>
                         </a:spcBef>
                         <a:spcAft>
-                          <a:spcPts val="400"/>
+                          <a:spcPts val="200"/>
                         </a:spcAft>
                         <a:buNone/>
                       </a:pPr>
@@ -32523,7 +32568,7 @@
                       </a:r>
                     </a:p>
                   </a:txBody>
-                  <a:tcPr anchor="ctr" marB="50800" marT="50800" marR="0" marL="0">
+                  <a:tcPr anchor="ctr" marB="25400" marT="25400" marR="0" marL="0">
                     <a:lnL algn="ctr" cmpd="sng" cap="flat" w="0">
                       <a:noFill/>
                       <a:prstDash val="solid"/>
@@ -32567,10 +32612,10 @@
                           <a:spcPct val="100000"/>
                         </a:lnSpc>
                         <a:spcBef>
-                          <a:spcPts val="400"/>
+                          <a:spcPts val="200"/>
                         </a:spcBef>
                         <a:spcAft>
-                          <a:spcPts val="400"/>
+                          <a:spcPts val="200"/>
                         </a:spcAft>
                         <a:buNone/>
                       </a:pPr>
@@ -32590,7 +32635,7 @@
                       </a:r>
                     </a:p>
                   </a:txBody>
-                  <a:tcPr anchor="ctr" marB="50800" marT="50800" marR="0" marL="0">
+                  <a:tcPr anchor="ctr" marB="25400" marT="25400" marR="0" marL="0">
                     <a:lnL algn="ctr" cmpd="sng" cap="flat" w="0">
                       <a:noFill/>
                       <a:prstDash val="solid"/>
@@ -32628,10 +32673,10 @@
                           <a:spcPct val="100000"/>
                         </a:lnSpc>
                         <a:spcBef>
-                          <a:spcPts val="400"/>
+                          <a:spcPts val="200"/>
                         </a:spcBef>
                         <a:spcAft>
-                          <a:spcPts val="400"/>
+                          <a:spcPts val="200"/>
                         </a:spcAft>
                         <a:buNone/>
                       </a:pPr>
@@ -32651,7 +32696,7 @@
                       </a:r>
                     </a:p>
                   </a:txBody>
-                  <a:tcPr anchor="ctr" marB="50800" marT="50800" marR="0" marL="0">
+                  <a:tcPr anchor="ctr" marB="25400" marT="25400" marR="0" marL="0">
                     <a:lnL algn="ctr" cmpd="sng" cap="flat" w="0">
                       <a:noFill/>
                       <a:prstDash val="solid"/>
@@ -32689,10 +32734,10 @@
                           <a:spcPct val="100000"/>
                         </a:lnSpc>
                         <a:spcBef>
-                          <a:spcPts val="400"/>
+                          <a:spcPts val="200"/>
                         </a:spcBef>
                         <a:spcAft>
-                          <a:spcPts val="400"/>
+                          <a:spcPts val="200"/>
                         </a:spcAft>
                         <a:buNone/>
                       </a:pPr>
@@ -32712,7 +32757,7 @@
                       </a:r>
                     </a:p>
                   </a:txBody>
-                  <a:tcPr anchor="ctr" marB="50800" marT="50800" marR="0" marL="0">
+                  <a:tcPr anchor="ctr" marB="25400" marT="25400" marR="0" marL="0">
                     <a:lnL algn="ctr" cmpd="sng" cap="flat" w="0">
                       <a:noFill/>
                       <a:prstDash val="solid"/>
@@ -32750,10 +32795,10 @@
                           <a:spcPct val="100000"/>
                         </a:lnSpc>
                         <a:spcBef>
-                          <a:spcPts val="400"/>
+                          <a:spcPts val="200"/>
                         </a:spcBef>
                         <a:spcAft>
-                          <a:spcPts val="400"/>
+                          <a:spcPts val="200"/>
                         </a:spcAft>
                         <a:buNone/>
                       </a:pPr>
@@ -32773,7 +32818,7 @@
                       </a:r>
                     </a:p>
                   </a:txBody>
-                  <a:tcPr anchor="ctr" marB="50800" marT="50800" marR="0" marL="0">
+                  <a:tcPr anchor="ctr" marB="25400" marT="25400" marR="0" marL="0">
                     <a:lnL algn="ctr" cmpd="sng" cap="flat" w="0">
                       <a:noFill/>
                       <a:prstDash val="solid"/>
@@ -32811,10 +32856,10 @@
                           <a:spcPct val="100000"/>
                         </a:lnSpc>
                         <a:spcBef>
-                          <a:spcPts val="400"/>
+                          <a:spcPts val="200"/>
                         </a:spcBef>
                         <a:spcAft>
-                          <a:spcPts val="400"/>
+                          <a:spcPts val="200"/>
                         </a:spcAft>
                         <a:buNone/>
                       </a:pPr>
@@ -32834,7 +32879,7 @@
                       </a:r>
                     </a:p>
                   </a:txBody>
-                  <a:tcPr anchor="ctr" marB="50800" marT="50800" marR="0" marL="0">
+                  <a:tcPr anchor="ctr" marB="25400" marT="25400" marR="0" marL="0">
                     <a:lnL algn="ctr" cmpd="sng" cap="flat" w="0">
                       <a:noFill/>
                       <a:prstDash val="solid"/>
@@ -32874,10 +32919,10 @@
                           <a:spcPct val="100000"/>
                         </a:lnSpc>
                         <a:spcBef>
-                          <a:spcPts val="400"/>
+                          <a:spcPts val="200"/>
                         </a:spcBef>
                         <a:spcAft>
-                          <a:spcPts val="400"/>
+                          <a:spcPts val="200"/>
                         </a:spcAft>
                         <a:buNone/>
                       </a:pPr>
@@ -32897,7 +32942,7 @@
                       </a:r>
                     </a:p>
                   </a:txBody>
-                  <a:tcPr anchor="ctr" marB="50800" marT="50800" marR="0" marL="0">
+                  <a:tcPr anchor="ctr" marB="25400" marT="25400" marR="0" marL="0">
                     <a:lnL algn="ctr" cmpd="sng" cap="flat" w="0">
                       <a:noFill/>
                       <a:prstDash val="solid"/>
@@ -32939,10 +32984,10 @@
                           <a:spcPct val="100000"/>
                         </a:lnSpc>
                         <a:spcBef>
-                          <a:spcPts val="400"/>
+                          <a:spcPts val="200"/>
                         </a:spcBef>
                         <a:spcAft>
-                          <a:spcPts val="400"/>
+                          <a:spcPts val="200"/>
                         </a:spcAft>
                         <a:buNone/>
                       </a:pPr>
@@ -32962,7 +33007,7 @@
                       </a:r>
                     </a:p>
                   </a:txBody>
-                  <a:tcPr anchor="ctr" marB="50800" marT="50800" marR="0" marL="0">
+                  <a:tcPr anchor="ctr" marB="25400" marT="25400" marR="0" marL="0">
                     <a:lnL algn="ctr" cmpd="sng" cap="flat" w="0">
                       <a:noFill/>
                       <a:prstDash val="solid"/>
@@ -33004,10 +33049,10 @@
                           <a:spcPct val="100000"/>
                         </a:lnSpc>
                         <a:spcBef>
-                          <a:spcPts val="400"/>
+                          <a:spcPts val="200"/>
                         </a:spcBef>
                         <a:spcAft>
-                          <a:spcPts val="400"/>
+                          <a:spcPts val="200"/>
                         </a:spcAft>
                         <a:buNone/>
                       </a:pPr>
@@ -33027,7 +33072,7 @@
                       </a:r>
                     </a:p>
                   </a:txBody>
-                  <a:tcPr anchor="ctr" marB="50800" marT="50800" marR="0" marL="0">
+                  <a:tcPr anchor="ctr" marB="25400" marT="25400" marR="0" marL="0">
                     <a:lnL algn="ctr" cmpd="sng" cap="flat" w="0">
                       <a:noFill/>
                       <a:prstDash val="solid"/>
@@ -33069,10 +33114,10 @@
                           <a:spcPct val="100000"/>
                         </a:lnSpc>
                         <a:spcBef>
-                          <a:spcPts val="400"/>
+                          <a:spcPts val="200"/>
                         </a:spcBef>
                         <a:spcAft>
-                          <a:spcPts val="400"/>
+                          <a:spcPts val="200"/>
                         </a:spcAft>
                         <a:buNone/>
                       </a:pPr>
@@ -33092,7 +33137,7 @@
                       </a:r>
                     </a:p>
                   </a:txBody>
-                  <a:tcPr anchor="ctr" marB="50800" marT="50800" marR="0" marL="0">
+                  <a:tcPr anchor="ctr" marB="25400" marT="25400" marR="0" marL="0">
                     <a:lnL algn="ctr" cmpd="sng" cap="flat" w="0">
                       <a:noFill/>
                       <a:prstDash val="solid"/>
@@ -33134,10 +33179,10 @@
                           <a:spcPct val="100000"/>
                         </a:lnSpc>
                         <a:spcBef>
-                          <a:spcPts val="400"/>
+                          <a:spcPts val="200"/>
                         </a:spcBef>
                         <a:spcAft>
-                          <a:spcPts val="400"/>
+                          <a:spcPts val="200"/>
                         </a:spcAft>
                         <a:buNone/>
                       </a:pPr>
@@ -33157,7 +33202,7 @@
                       </a:r>
                     </a:p>
                   </a:txBody>
-                  <a:tcPr anchor="ctr" marB="50800" marT="50800" marR="0" marL="0">
+                  <a:tcPr anchor="ctr" marB="25400" marT="25400" marR="0" marL="0">
                     <a:lnL algn="ctr" cmpd="sng" cap="flat" w="0">
                       <a:noFill/>
                       <a:prstDash val="solid"/>
@@ -33201,10 +33246,10 @@
                           <a:spcPct val="100000"/>
                         </a:lnSpc>
                         <a:spcBef>
-                          <a:spcPts val="400"/>
+                          <a:spcPts val="200"/>
                         </a:spcBef>
                         <a:spcAft>
-                          <a:spcPts val="400"/>
+                          <a:spcPts val="200"/>
                         </a:spcAft>
                         <a:buNone/>
                       </a:pPr>
@@ -33224,7 +33269,7 @@
                       </a:r>
                     </a:p>
                   </a:txBody>
-                  <a:tcPr anchor="ctr" marB="50800" marT="50800" marR="0" marL="0">
+                  <a:tcPr anchor="ctr" marB="25400" marT="25400" marR="0" marL="0">
                     <a:lnL algn="ctr" cmpd="sng" cap="flat" w="0">
                       <a:noFill/>
                       <a:prstDash val="solid"/>
@@ -33266,10 +33311,10 @@
                           <a:spcPct val="100000"/>
                         </a:lnSpc>
                         <a:spcBef>
-                          <a:spcPts val="400"/>
+                          <a:spcPts val="200"/>
                         </a:spcBef>
                         <a:spcAft>
-                          <a:spcPts val="400"/>
+                          <a:spcPts val="200"/>
                         </a:spcAft>
                         <a:buNone/>
                       </a:pPr>
@@ -33289,7 +33334,7 @@
                       </a:r>
                     </a:p>
                   </a:txBody>
-                  <a:tcPr anchor="ctr" marB="50800" marT="50800" marR="0" marL="0">
+                  <a:tcPr anchor="ctr" marB="25400" marT="25400" marR="0" marL="0">
                     <a:lnL algn="ctr" cmpd="sng" cap="flat" w="0">
                       <a:noFill/>
                       <a:prstDash val="solid"/>
@@ -33331,10 +33376,10 @@
                           <a:spcPct val="100000"/>
                         </a:lnSpc>
                         <a:spcBef>
-                          <a:spcPts val="400"/>
+                          <a:spcPts val="200"/>
                         </a:spcBef>
                         <a:spcAft>
-                          <a:spcPts val="400"/>
+                          <a:spcPts val="200"/>
                         </a:spcAft>
                         <a:buNone/>
                       </a:pPr>
@@ -33354,7 +33399,7 @@
                       </a:r>
                     </a:p>
                   </a:txBody>
-                  <a:tcPr anchor="ctr" marB="50800" marT="50800" marR="0" marL="0">
+                  <a:tcPr anchor="ctr" marB="25400" marT="25400" marR="0" marL="0">
                     <a:lnL algn="ctr" cmpd="sng" cap="flat" w="0">
                       <a:noFill/>
                       <a:prstDash val="solid"/>
@@ -33396,10 +33441,10 @@
                           <a:spcPct val="100000"/>
                         </a:lnSpc>
                         <a:spcBef>
-                          <a:spcPts val="400"/>
+                          <a:spcPts val="200"/>
                         </a:spcBef>
                         <a:spcAft>
-                          <a:spcPts val="400"/>
+                          <a:spcPts val="200"/>
                         </a:spcAft>
                         <a:buNone/>
                       </a:pPr>
@@ -33419,7 +33464,7 @@
                       </a:r>
                     </a:p>
                   </a:txBody>
-                  <a:tcPr anchor="ctr" marB="50800" marT="50800" marR="0" marL="0">
+                  <a:tcPr anchor="ctr" marB="25400" marT="25400" marR="0" marL="0">
                     <a:lnL algn="ctr" cmpd="sng" cap="flat" w="0">
                       <a:noFill/>
                       <a:prstDash val="solid"/>
@@ -33461,10 +33506,10 @@
                           <a:spcPct val="100000"/>
                         </a:lnSpc>
                         <a:spcBef>
-                          <a:spcPts val="400"/>
+                          <a:spcPts val="200"/>
                         </a:spcBef>
                         <a:spcAft>
-                          <a:spcPts val="400"/>
+                          <a:spcPts val="200"/>
                         </a:spcAft>
                         <a:buNone/>
                       </a:pPr>
@@ -33484,7 +33529,7 @@
                       </a:r>
                     </a:p>
                   </a:txBody>
-                  <a:tcPr anchor="ctr" marB="50800" marT="50800" marR="0" marL="0">
+                  <a:tcPr anchor="ctr" marB="25400" marT="25400" marR="0" marL="0">
                     <a:lnL algn="ctr" cmpd="sng" cap="flat" w="0">
                       <a:noFill/>
                       <a:prstDash val="solid"/>
@@ -33528,10 +33573,10 @@
                           <a:spcPct val="100000"/>
                         </a:lnSpc>
                         <a:spcBef>
-                          <a:spcPts val="400"/>
+                          <a:spcPts val="200"/>
                         </a:spcBef>
                         <a:spcAft>
-                          <a:spcPts val="400"/>
+                          <a:spcPts val="200"/>
                         </a:spcAft>
                         <a:buNone/>
                       </a:pPr>
@@ -33551,7 +33596,7 @@
                       </a:r>
                     </a:p>
                   </a:txBody>
-                  <a:tcPr anchor="ctr" marB="50800" marT="50800" marR="0" marL="0">
+                  <a:tcPr anchor="ctr" marB="25400" marT="25400" marR="0" marL="0">
                     <a:lnL algn="ctr" cmpd="sng" cap="flat" w="0">
                       <a:noFill/>
                       <a:prstDash val="solid"/>
@@ -33593,10 +33638,10 @@
                           <a:spcPct val="100000"/>
                         </a:lnSpc>
                         <a:spcBef>
-                          <a:spcPts val="400"/>
+                          <a:spcPts val="200"/>
                         </a:spcBef>
                         <a:spcAft>
-                          <a:spcPts val="400"/>
+                          <a:spcPts val="200"/>
                         </a:spcAft>
                         <a:buNone/>
                       </a:pPr>
@@ -33616,7 +33661,7 @@
                       </a:r>
                     </a:p>
                   </a:txBody>
-                  <a:tcPr anchor="ctr" marB="50800" marT="50800" marR="0" marL="0">
+                  <a:tcPr anchor="ctr" marB="25400" marT="25400" marR="0" marL="0">
                     <a:lnL algn="ctr" cmpd="sng" cap="flat" w="0">
                       <a:noFill/>
                       <a:prstDash val="solid"/>
@@ -33658,10 +33703,10 @@
                           <a:spcPct val="100000"/>
                         </a:lnSpc>
                         <a:spcBef>
-                          <a:spcPts val="400"/>
+                          <a:spcPts val="200"/>
                         </a:spcBef>
                         <a:spcAft>
-                          <a:spcPts val="400"/>
+                          <a:spcPts val="200"/>
                         </a:spcAft>
                         <a:buNone/>
                       </a:pPr>
@@ -33681,7 +33726,7 @@
                       </a:r>
                     </a:p>
                   </a:txBody>
-                  <a:tcPr anchor="ctr" marB="50800" marT="50800" marR="0" marL="0">
+                  <a:tcPr anchor="ctr" marB="25400" marT="25400" marR="0" marL="0">
                     <a:lnL algn="ctr" cmpd="sng" cap="flat" w="0">
                       <a:noFill/>
                       <a:prstDash val="solid"/>
@@ -33723,10 +33768,10 @@
                           <a:spcPct val="100000"/>
                         </a:lnSpc>
                         <a:spcBef>
-                          <a:spcPts val="400"/>
+                          <a:spcPts val="200"/>
                         </a:spcBef>
                         <a:spcAft>
-                          <a:spcPts val="400"/>
+                          <a:spcPts val="200"/>
                         </a:spcAft>
                         <a:buNone/>
                       </a:pPr>
@@ -33746,7 +33791,7 @@
                       </a:r>
                     </a:p>
                   </a:txBody>
-                  <a:tcPr anchor="ctr" marB="50800" marT="50800" marR="0" marL="0">
+                  <a:tcPr anchor="ctr" marB="25400" marT="25400" marR="0" marL="0">
                     <a:lnL algn="ctr" cmpd="sng" cap="flat" w="0">
                       <a:noFill/>
                       <a:prstDash val="solid"/>
@@ -33788,10 +33833,10 @@
                           <a:spcPct val="100000"/>
                         </a:lnSpc>
                         <a:spcBef>
-                          <a:spcPts val="400"/>
+                          <a:spcPts val="200"/>
                         </a:spcBef>
                         <a:spcAft>
-                          <a:spcPts val="400"/>
+                          <a:spcPts val="200"/>
                         </a:spcAft>
                         <a:buNone/>
                       </a:pPr>
@@ -33811,7 +33856,7 @@
                       </a:r>
                     </a:p>
                   </a:txBody>
-                  <a:tcPr anchor="ctr" marB="50800" marT="50800" marR="0" marL="0">
+                  <a:tcPr anchor="ctr" marB="25400" marT="25400" marR="0" marL="0">
                     <a:lnL algn="ctr" cmpd="sng" cap="flat" w="0">
                       <a:noFill/>
                       <a:prstDash val="solid"/>
@@ -33855,10 +33900,10 @@
                           <a:spcPct val="100000"/>
                         </a:lnSpc>
                         <a:spcBef>
-                          <a:spcPts val="400"/>
+                          <a:spcPts val="200"/>
                         </a:spcBef>
                         <a:spcAft>
-                          <a:spcPts val="400"/>
+                          <a:spcPts val="200"/>
                         </a:spcAft>
                         <a:buNone/>
                       </a:pPr>
@@ -33878,7 +33923,7 @@
                       </a:r>
                     </a:p>
                   </a:txBody>
-                  <a:tcPr anchor="ctr" marB="50800" marT="50800" marR="0" marL="0">
+                  <a:tcPr anchor="ctr" marB="25400" marT="25400" marR="0" marL="0">
                     <a:lnL algn="ctr" cmpd="sng" cap="flat" w="0">
                       <a:noFill/>
                       <a:prstDash val="solid"/>
@@ -33920,10 +33965,10 @@
                           <a:spcPct val="100000"/>
                         </a:lnSpc>
                         <a:spcBef>
-                          <a:spcPts val="400"/>
+                          <a:spcPts val="200"/>
                         </a:spcBef>
                         <a:spcAft>
-                          <a:spcPts val="400"/>
+                          <a:spcPts val="200"/>
                         </a:spcAft>
                         <a:buNone/>
                       </a:pPr>
@@ -33943,7 +33988,7 @@
                       </a:r>
                     </a:p>
                   </a:txBody>
-                  <a:tcPr anchor="ctr" marB="50800" marT="50800" marR="0" marL="0">
+                  <a:tcPr anchor="ctr" marB="25400" marT="25400" marR="0" marL="0">
                     <a:lnL algn="ctr" cmpd="sng" cap="flat" w="0">
                       <a:noFill/>
                       <a:prstDash val="solid"/>
@@ -33985,10 +34030,10 @@
                           <a:spcPct val="100000"/>
                         </a:lnSpc>
                         <a:spcBef>
-                          <a:spcPts val="400"/>
+                          <a:spcPts val="200"/>
                         </a:spcBef>
                         <a:spcAft>
-                          <a:spcPts val="400"/>
+                          <a:spcPts val="200"/>
                         </a:spcAft>
                         <a:buNone/>
                       </a:pPr>
@@ -34008,7 +34053,7 @@
                       </a:r>
                     </a:p>
                   </a:txBody>
-                  <a:tcPr anchor="ctr" marB="50800" marT="50800" marR="0" marL="0">
+                  <a:tcPr anchor="ctr" marB="25400" marT="25400" marR="0" marL="0">
                     <a:lnL algn="ctr" cmpd="sng" cap="flat" w="0">
                       <a:noFill/>
                       <a:prstDash val="solid"/>
@@ -34050,10 +34095,10 @@
                           <a:spcPct val="100000"/>
                         </a:lnSpc>
                         <a:spcBef>
-                          <a:spcPts val="400"/>
+                          <a:spcPts val="200"/>
                         </a:spcBef>
                         <a:spcAft>
-                          <a:spcPts val="400"/>
+                          <a:spcPts val="200"/>
                         </a:spcAft>
                         <a:buNone/>
                       </a:pPr>
@@ -34073,7 +34118,7 @@
                       </a:r>
                     </a:p>
                   </a:txBody>
-                  <a:tcPr anchor="ctr" marB="50800" marT="50800" marR="0" marL="0">
+                  <a:tcPr anchor="ctr" marB="25400" marT="25400" marR="0" marL="0">
                     <a:lnL algn="ctr" cmpd="sng" cap="flat" w="0">
                       <a:noFill/>
                       <a:prstDash val="solid"/>
@@ -34115,10 +34160,10 @@
                           <a:spcPct val="100000"/>
                         </a:lnSpc>
                         <a:spcBef>
-                          <a:spcPts val="400"/>
+                          <a:spcPts val="200"/>
                         </a:spcBef>
                         <a:spcAft>
-                          <a:spcPts val="400"/>
+                          <a:spcPts val="200"/>
                         </a:spcAft>
                         <a:buNone/>
                       </a:pPr>
@@ -34138,7 +34183,7 @@
                       </a:r>
                     </a:p>
                   </a:txBody>
-                  <a:tcPr anchor="ctr" marB="50800" marT="50800" marR="0" marL="0">
+                  <a:tcPr anchor="ctr" marB="25400" marT="25400" marR="0" marL="0">
                     <a:lnL algn="ctr" cmpd="sng" cap="flat" w="0">
                       <a:noFill/>
                       <a:prstDash val="solid"/>
@@ -34182,10 +34227,10 @@
                           <a:spcPct val="100000"/>
                         </a:lnSpc>
                         <a:spcBef>
-                          <a:spcPts val="400"/>
+                          <a:spcPts val="200"/>
                         </a:spcBef>
                         <a:spcAft>
-                          <a:spcPts val="400"/>
+                          <a:spcPts val="200"/>
                         </a:spcAft>
                         <a:buNone/>
                       </a:pPr>
@@ -34205,7 +34250,7 @@
                       </a:r>
                     </a:p>
                   </a:txBody>
-                  <a:tcPr anchor="ctr" marB="50800" marT="50800" marR="0" marL="0">
+                  <a:tcPr anchor="ctr" marB="25400" marT="25400" marR="0" marL="0">
                     <a:lnL algn="ctr" cmpd="sng" cap="flat" w="0">
                       <a:noFill/>
                       <a:prstDash val="solid"/>
@@ -34247,10 +34292,10 @@
                           <a:spcPct val="100000"/>
                         </a:lnSpc>
                         <a:spcBef>
-                          <a:spcPts val="400"/>
+                          <a:spcPts val="200"/>
                         </a:spcBef>
                         <a:spcAft>
-                          <a:spcPts val="400"/>
+                          <a:spcPts val="200"/>
                         </a:spcAft>
                         <a:buNone/>
                       </a:pPr>
@@ -34270,7 +34315,7 @@
                       </a:r>
                     </a:p>
                   </a:txBody>
-                  <a:tcPr anchor="ctr" marB="50800" marT="50800" marR="0" marL="0">
+                  <a:tcPr anchor="ctr" marB="25400" marT="25400" marR="0" marL="0">
                     <a:lnL algn="ctr" cmpd="sng" cap="flat" w="0">
                       <a:noFill/>
                       <a:prstDash val="solid"/>
@@ -34312,10 +34357,10 @@
                           <a:spcPct val="100000"/>
                         </a:lnSpc>
                         <a:spcBef>
-                          <a:spcPts val="400"/>
+                          <a:spcPts val="200"/>
                         </a:spcBef>
                         <a:spcAft>
-                          <a:spcPts val="400"/>
+                          <a:spcPts val="200"/>
                         </a:spcAft>
                         <a:buNone/>
                       </a:pPr>
@@ -34335,7 +34380,7 @@
                       </a:r>
                     </a:p>
                   </a:txBody>
-                  <a:tcPr anchor="ctr" marB="50800" marT="50800" marR="0" marL="0">
+                  <a:tcPr anchor="ctr" marB="25400" marT="25400" marR="0" marL="0">
                     <a:lnL algn="ctr" cmpd="sng" cap="flat" w="0">
                       <a:noFill/>
                       <a:prstDash val="solid"/>
@@ -34377,10 +34422,10 @@
                           <a:spcPct val="100000"/>
                         </a:lnSpc>
                         <a:spcBef>
-                          <a:spcPts val="400"/>
+                          <a:spcPts val="200"/>
                         </a:spcBef>
                         <a:spcAft>
-                          <a:spcPts val="400"/>
+                          <a:spcPts val="200"/>
                         </a:spcAft>
                         <a:buNone/>
                       </a:pPr>
@@ -34400,7 +34445,7 @@
                       </a:r>
                     </a:p>
                   </a:txBody>
-                  <a:tcPr anchor="ctr" marB="50800" marT="50800" marR="0" marL="0">
+                  <a:tcPr anchor="ctr" marB="25400" marT="25400" marR="0" marL="0">
                     <a:lnL algn="ctr" cmpd="sng" cap="flat" w="0">
                       <a:noFill/>
                       <a:prstDash val="solid"/>
@@ -34442,10 +34487,10 @@
                           <a:spcPct val="100000"/>
                         </a:lnSpc>
                         <a:spcBef>
-                          <a:spcPts val="400"/>
+                          <a:spcPts val="200"/>
                         </a:spcBef>
                         <a:spcAft>
-                          <a:spcPts val="400"/>
+                          <a:spcPts val="200"/>
                         </a:spcAft>
                         <a:buNone/>
                       </a:pPr>
@@ -34465,7 +34510,7 @@
                       </a:r>
                     </a:p>
                   </a:txBody>
-                  <a:tcPr anchor="ctr" marB="50800" marT="50800" marR="0" marL="0">
+                  <a:tcPr anchor="ctr" marB="25400" marT="25400" marR="0" marL="0">
                     <a:lnL algn="ctr" cmpd="sng" cap="flat" w="0">
                       <a:noFill/>
                       <a:prstDash val="solid"/>
@@ -34513,11 +34558,11 @@
         <p:spPr>
           <a:xfrm>
             <a:off x="7726680" y="1773936"/>
-            <a:ext cx="3962095" cy="1800860"/>
+            <a:ext cx="3962095" cy="1670812"/>
           </a:xfrm>
           <a:prstGeom prst="roundRect">
             <a:avLst>
-              <a:gd name="adj" fmla="val 5078"/>
+              <a:gd name="adj" fmla="val 5473"/>
             </a:avLst>
           </a:prstGeom>
           <a:solidFill>
@@ -34577,7 +34622,7 @@
         <p:spPr>
           <a:xfrm>
             <a:off x="7726680" y="2258568"/>
-            <a:ext cx="3962095" cy="1261364"/>
+            <a:ext cx="3962095" cy="1131316"/>
           </a:xfrm>
           <a:prstGeom prst="rect">
             <a:avLst/>
@@ -34666,12 +34711,12 @@
         </p:nvSpPr>
         <p:spPr>
           <a:xfrm>
-            <a:off x="7726680" y="3757676"/>
-            <a:ext cx="3962095" cy="1800860"/>
+            <a:off x="7726680" y="3627628"/>
+            <a:ext cx="3962095" cy="1670812"/>
           </a:xfrm>
           <a:prstGeom prst="roundRect">
             <a:avLst>
-              <a:gd name="adj" fmla="val 5078"/>
+              <a:gd name="adj" fmla="val 5473"/>
             </a:avLst>
           </a:prstGeom>
           <a:solidFill>
@@ -34730,8 +34775,8 @@
         </p:nvSpPr>
         <p:spPr>
           <a:xfrm>
-            <a:off x="7726680" y="4242308"/>
-            <a:ext cx="3962095" cy="1261364"/>
+            <a:off x="7726680" y="4112260"/>
+            <a:ext cx="3962095" cy="1131316"/>
           </a:xfrm>
           <a:prstGeom prst="rect">
             <a:avLst/>
@@ -35109,8 +35154,8 @@
         </p:nvSpPr>
         <p:spPr>
           <a:xfrm>
-            <a:off x="502920" y="5440680"/>
-            <a:ext cx="11185855" cy="813816"/>
+            <a:off x="502920" y="5205984"/>
+            <a:ext cx="11185855" cy="1048512"/>
           </a:xfrm>
           <a:prstGeom prst="rect">
             <a:avLst/>
@@ -35144,7 +35189,7 @@
                 <a:ea typeface="Pretendard"/>
                 <a:sym typeface="Pretendard"/>
               </a:rPr>
-              <a:t>규제 기본값(이 제안과 다름): EMA 2012 단클론항체 지침은 단회 투여 시험에서 AUCinf 1⁠차(피하면 Cmax 공동 1⁠차), 선례 MSB11456 정맥 시험은 AUClast 1⁠차(검색 발췌). 세 지표 = AUClast + AUCinf + Cmax; 규칙 ⁠A = 미달자 제외, B = λz 산출 전원(규칙 ⁠A 세트 ⁠(iii)⁠의 세 지표 구성은 미산출). 통과율 감소: AUClast + Cmax 대비, 참 비 0.95~1.00 제품 세 개(2016 ⁠모델, M0, v1.0 대응안 모의; M1⁠에서 규칙 ⁠B 0.01~0.13%p).</a:t>
+              <a:t>AUClast + Cmax⁠의 점추정 5% 초과 1⁠칸(5.63%)⁠은 2020 ⁠모델 V2 ⁠칸에서 AUClast 기하평균비가 참 비보다 1 쪽으로 0.41% 치우친 추정 대상 차이다(별첨 A5b). 세트 ⁠(i) = adjusted R² ≥ ⁠0.80, 외삽 ≤ ⁠20%, (ii) = (i) + span ≥ ⁠2. M1 = 체중 층 포함(주분석 후보), M0 = 층 없음. 통과율 감소: AUClast + Cmax 대비, 참 비 0.95~1.00 제품 세 개, 2016 ⁠모델 v1.0 모의(M1⁠에서 규칙 ⁠B 0.01~0.13%p). 규제 기본값: EMA 2012 단클론항체 지침은 단회 투여 시험에서 AUCinf 1⁠차(피하면 Cmax 공동 1⁠차), 선례 MSB11456 정맥 시험은 AUClast 1⁠차(두 출처 모두 검색 발췌, 원문 미대조).</a:t>
             </a:r>
           </a:p>
         </p:txBody>
@@ -35158,7 +35203,7 @@
           <p:nvPr/>
         </p:nvGraphicFramePr>
         <p:xfrm rot="0">
-          <a:off x="502920" y="3250184"/>
+          <a:off x="502920" y="3015488"/>
           <a:ext cx="11185855" cy="2099056"/>
         </p:xfrm>
         <a:graphic>
@@ -35166,12 +35211,12 @@
             <a:tbl>
               <a:tblPr/>
               <a:tblGrid>
-                <a:gridCol w="3749960"/>
-                <a:gridCol w="1189012"/>
-                <a:gridCol w="823162"/>
-                <a:gridCol w="1280474"/>
-                <a:gridCol w="2103636"/>
-                <a:gridCol w="2039612"/>
+                <a:gridCol w="3567035"/>
+                <a:gridCol w="1234743"/>
+                <a:gridCol w="868893"/>
+                <a:gridCol w="1326205"/>
+                <a:gridCol w="2012173"/>
+                <a:gridCol w="2176806"/>
               </a:tblGrid>
               <a:tr h="228600">
                 <a:tc>
@@ -35425,7 +35470,7 @@
                           <a:ea typeface="Pretendard"/>
                           <a:sym typeface="Pretendard"/>
                         </a:rPr>
-                        <a:t>통과율</a:t>
+                        <a:t>통과율 감소</a:t>
                       </a:r>
                       <a:br>
                         <a:rPr cap="none" sz="1400" i="0" b="1" u="none">
@@ -35452,7 +35497,7 @@
                           <a:ea typeface="Pretendard"/>
                           <a:sym typeface="Pretendard"/>
                         </a:rPr>
-                        <a:t>감소</a:t>
+                        <a:t>(M0)</a:t>
                       </a:r>
                     </a:p>
                   </a:txBody>
@@ -36463,7 +36508,7 @@
                           <a:ea typeface="Pretendard"/>
                           <a:sym typeface="Pretendard"/>
                         </a:rPr>
-                        <a:t>세 지표, AUCinf 규칙 ⁠A 세트 ⁠(ii)</a:t>
+                        <a:t>세 지표, AUCinf 세트 ⁠(ii) 충족자만</a:t>
                       </a:r>
                     </a:p>
                   </a:txBody>
@@ -36855,7 +36900,7 @@
                           <a:ea typeface="Pretendard"/>
                           <a:sym typeface="Pretendard"/>
                         </a:rPr>
-                        <a:t>AUCinf + Cmax: 신뢰할 수 있는 AUCinf⁠만</a:t>
+                        <a:t>AUCinf + Cmax: 신뢰할 수 있는 AUCinf</a:t>
                       </a:r>
                     </a:p>
                   </a:txBody>
@@ -38007,7 +38052,7 @@
       </p:graphicFrame>
       <p:sp>
         <p:nvSpPr>
-          <p:cNvPr id="7" name="card_1"/>
+          <p:cNvPr id="7" name="caption_why"/>
           <p:cNvSpPr>
             <a:spLocks noGrp="1"/>
           </p:cNvSpPr>
@@ -38015,132 +38060,12 @@
         </p:nvSpPr>
         <p:spPr>
           <a:xfrm>
-            <a:off x="502920" y="1773936"/>
-            <a:ext cx="2487799" cy="1311656"/>
+            <a:off x="502920" y="1792224"/>
+            <a:ext cx="11185855" cy="1095248"/>
           </a:xfrm>
           <a:prstGeom prst="roundRect">
             <a:avLst>
-              <a:gd name="adj" fmla="val 6971"/>
-            </a:avLst>
-          </a:prstGeom>
-          <a:solidFill>
-            <a:srgbClr val="EAF2FC">
-              <a:alpha val="100000"/>
-            </a:srgbClr>
-          </a:solidFill>
-          <a:ln w="0" cap="rnd" cmpd="sng">
-            <a:noFill/>
-            <a:prstDash val="solid"/>
-            <a:round/>
-            <a:headEnd type="none" w="med" len="med"/>
-            <a:tailEnd type="none" w="med" len="med"/>
-          </a:ln>
-        </p:spPr>
-        <p:txBody>
-          <a:bodyPr lIns="109728" rIns="109728" tIns="73152" bIns="73152"/>
-          <a:lstStyle/>
-          <a:p>
-            <a:pPr algn="l" marL="0" marR="0" eaLnBrk="0">
-              <a:lnSpc>
-                <a:spcPct val="110000"/>
-              </a:lnSpc>
-              <a:spcBef>
-                <a:spcPts val="0"/>
-              </a:spcBef>
-              <a:spcAft>
-                <a:spcPts val="600"/>
-              </a:spcAft>
-              <a:buNone/>
-            </a:pPr>
-            <a:r>
-              <a:rPr cap="none" sz="1800" i="0" b="1" u="none">
-                <a:solidFill>
-                  <a:srgbClr val="2A78D6">
-                    <a:alpha val="100000"/>
-                  </a:srgbClr>
-                </a:solidFill>
-                <a:latin typeface="Pretendard"/>
-                <a:cs typeface="Pretendard"/>
-                <a:ea typeface="Pretendard"/>
-                <a:sym typeface="Pretendard"/>
-              </a:rPr>
-              <a:t>제안 SAP</a:t>
-            </a:r>
-          </a:p>
-          <a:p>
-            <a:pPr algn="l" marL="0" marR="0" eaLnBrk="0">
-              <a:lnSpc>
-                <a:spcPct val="110000"/>
-              </a:lnSpc>
-              <a:spcBef>
-                <a:spcPts val="0"/>
-              </a:spcBef>
-              <a:spcAft>
-                <a:spcPts val="400"/>
-              </a:spcAft>
-              <a:buNone/>
-            </a:pPr>
-            <a:r>
-              <a:rPr cap="none" sz="1800" i="0" b="0" u="none">
-                <a:solidFill>
-                  <a:srgbClr val="0B0B0B">
-                    <a:alpha val="100000"/>
-                  </a:srgbClr>
-                </a:solidFill>
-                <a:latin typeface="Pretendard"/>
-                <a:cs typeface="Pretendard"/>
-                <a:ea typeface="Pretendard"/>
-                <a:sym typeface="Pretendard"/>
-              </a:rPr>
-              <a:t>1⁠차: AUClast + Cmax</a:t>
-            </a:r>
-          </a:p>
-          <a:p>
-            <a:pPr algn="l" marL="0" marR="0" eaLnBrk="0">
-              <a:lnSpc>
-                <a:spcPct val="110000"/>
-              </a:lnSpc>
-              <a:spcBef>
-                <a:spcPts val="0"/>
-              </a:spcBef>
-              <a:spcAft>
-                <a:spcPts val="400"/>
-              </a:spcAft>
-              <a:buNone/>
-            </a:pPr>
-            <a:r>
-              <a:rPr cap="none" sz="1800" i="0" b="0" u="none">
-                <a:solidFill>
-                  <a:srgbClr val="0B0B0B">
-                    <a:alpha val="100000"/>
-                  </a:srgbClr>
-                </a:solidFill>
-                <a:latin typeface="Pretendard"/>
-                <a:cs typeface="Pretendard"/>
-                <a:ea typeface="Pretendard"/>
-                <a:sym typeface="Pretendard"/>
-              </a:rPr>
-              <a:t>2⁠차: AUCinf(두 분석군)</a:t>
-            </a:r>
-          </a:p>
-        </p:txBody>
-      </p:sp>
-      <p:sp>
-        <p:nvSpPr>
-          <p:cNvPr id="8" name="card_2"/>
-          <p:cNvSpPr>
-            <a:spLocks noGrp="1"/>
-          </p:cNvSpPr>
-          <p:nvPr/>
-        </p:nvSpPr>
-        <p:spPr>
-          <a:xfrm>
-            <a:off x="3173599" y="1773936"/>
-            <a:ext cx="5222548" cy="1311656"/>
-          </a:xfrm>
-          <a:prstGeom prst="roundRect">
-            <a:avLst>
-              <a:gd name="adj" fmla="val 6971"/>
+              <a:gd name="adj" fmla="val 8349"/>
             </a:avLst>
           </a:prstGeom>
           <a:solidFill>
@@ -38168,12 +38093,12 @@
                 <a:spcPts val="0"/>
               </a:spcBef>
               <a:spcAft>
-                <a:spcPts val="600"/>
+                <a:spcPts val="400"/>
               </a:spcAft>
               <a:buNone/>
             </a:pPr>
             <a:r>
-              <a:rPr cap="none" sz="1800" i="0" b="1" u="none">
+              <a:rPr cap="none" sz="1600" i="0" b="1" u="none">
                 <a:solidFill>
                   <a:srgbClr val="0B0B0B">
                     <a:alpha val="100000"/>
@@ -38184,7 +38109,21 @@
                 <a:ea typeface="Pretendard"/>
                 <a:sym typeface="Pretendard"/>
               </a:rPr>
-              <a:t>AUCinf 공동 1⁠차 요구 시 (대응안)</a:t>
+              <a:t>대응안을 기본으로 두지 않는 이유</a:t>
+            </a:r>
+            <a:r>
+              <a:rPr cap="none" sz="1600" i="0" b="0" u="none">
+                <a:solidFill>
+                  <a:srgbClr val="0B0B0B">
+                    <a:alpha val="100000"/>
+                  </a:srgbClr>
+                </a:solidFill>
+                <a:latin typeface="Pretendard"/>
+                <a:cs typeface="Pretendard"/>
+                <a:ea typeface="Pretendard"/>
+                <a:sym typeface="Pretendard"/>
+              </a:rPr>
+              <a:t>: 낮은 1⁠종 오류는 AUCinf 정보가 아니라 지표 하나를 더 통과해야 하는 교집합 판정에서 오고, 규칙 ⁠B⁠는 신뢰 기준 미달 AUCinf(대상자 33~37%)⁠를 1⁠차 판정에 넣는다.</a:t>
             </a:r>
           </a:p>
           <a:p>
@@ -38201,7 +38140,7 @@
               <a:buNone/>
             </a:pPr>
             <a:r>
-              <a:rPr cap="none" sz="1800" i="0" b="0" u="none">
+              <a:rPr cap="none" sz="1600" i="0" b="1" u="none">
                 <a:solidFill>
                   <a:srgbClr val="0B0B0B">
                     <a:alpha val="100000"/>
@@ -38212,24 +38151,10 @@
                 <a:ea typeface="Pretendard"/>
                 <a:sym typeface="Pretendard"/>
               </a:rPr>
-              <a:t>AUClast + AUCinf(규칙 ⁠B) + Cmax</a:t>
+              <a:t>AUCinf + Cmax⁠만은 권하지 않는다</a:t>
             </a:r>
-          </a:p>
-          <a:p>
-            <a:pPr algn="l" marL="0" marR="0" eaLnBrk="0">
-              <a:lnSpc>
-                <a:spcPct val="110000"/>
-              </a:lnSpc>
-              <a:spcBef>
-                <a:spcPts val="0"/>
-              </a:spcBef>
-              <a:spcAft>
-                <a:spcPts val="400"/>
-              </a:spcAft>
-              <a:buNone/>
-            </a:pPr>
             <a:r>
-              <a:rPr cap="none" sz="1800" i="0" b="0" u="none">
+              <a:rPr cap="none" sz="1600" i="0" b="0" u="none">
                 <a:solidFill>
                   <a:srgbClr val="0B0B0B">
                     <a:alpha val="100000"/>
@@ -38240,134 +38165,14 @@
                 <a:ea typeface="Pretendard"/>
                 <a:sym typeface="Pretendard"/>
               </a:rPr>
-              <a:t>규칙 ⁠A: 통과율이 더 줄고 노출 낮은 대상자 제외(표)</a:t>
+              <a:t>(주황 행): 점추정 5% 초과가 16⁠칸 중 10⁠칸이고, 기준 미달자를 빼면 노출이 낮은 대상자가 빠진다.</a:t>
             </a:r>
           </a:p>
         </p:txBody>
       </p:sp>
       <p:sp>
         <p:nvSpPr>
-          <p:cNvPr id="9" name="card_3"/>
-          <p:cNvSpPr>
-            <a:spLocks noGrp="1"/>
-          </p:cNvSpPr>
-          <p:nvPr/>
-        </p:nvSpPr>
-        <p:spPr>
-          <a:xfrm>
-            <a:off x="8579027" y="1773936"/>
-            <a:ext cx="3109748" cy="1311656"/>
-          </a:xfrm>
-          <a:prstGeom prst="roundRect">
-            <a:avLst>
-              <a:gd name="adj" fmla="val 6971"/>
-            </a:avLst>
-          </a:prstGeom>
-          <a:solidFill>
-            <a:srgbClr val="FDF0EA">
-              <a:alpha val="100000"/>
-            </a:srgbClr>
-          </a:solidFill>
-          <a:ln w="0" cap="rnd" cmpd="sng">
-            <a:noFill/>
-            <a:prstDash val="solid"/>
-            <a:round/>
-            <a:headEnd type="none" w="med" len="med"/>
-            <a:tailEnd type="none" w="med" len="med"/>
-          </a:ln>
-        </p:spPr>
-        <p:txBody>
-          <a:bodyPr lIns="109728" rIns="109728" tIns="73152" bIns="73152"/>
-          <a:lstStyle/>
-          <a:p>
-            <a:pPr algn="l" marL="0" marR="0" eaLnBrk="0">
-              <a:lnSpc>
-                <a:spcPct val="110000"/>
-              </a:lnSpc>
-              <a:spcBef>
-                <a:spcPts val="0"/>
-              </a:spcBef>
-              <a:spcAft>
-                <a:spcPts val="600"/>
-              </a:spcAft>
-              <a:buNone/>
-            </a:pPr>
-            <a:r>
-              <a:rPr cap="none" sz="1800" i="0" b="1" u="none">
-                <a:solidFill>
-                  <a:srgbClr val="EB6834">
-                    <a:alpha val="100000"/>
-                  </a:srgbClr>
-                </a:solidFill>
-                <a:latin typeface="Pretendard"/>
-                <a:cs typeface="Pretendard"/>
-                <a:ea typeface="Pretendard"/>
-                <a:sym typeface="Pretendard"/>
-              </a:rPr>
-              <a:t>권하지 않음: AUCinf + Cmax</a:t>
-            </a:r>
-          </a:p>
-          <a:p>
-            <a:pPr algn="l" marL="0" marR="0" eaLnBrk="0">
-              <a:lnSpc>
-                <a:spcPct val="110000"/>
-              </a:lnSpc>
-              <a:spcBef>
-                <a:spcPts val="0"/>
-              </a:spcBef>
-              <a:spcAft>
-                <a:spcPts val="400"/>
-              </a:spcAft>
-              <a:buNone/>
-            </a:pPr>
-            <a:r>
-              <a:rPr cap="none" sz="1800" i="0" b="0" u="none">
-                <a:solidFill>
-                  <a:srgbClr val="0B0B0B">
-                    <a:alpha val="100000"/>
-                  </a:srgbClr>
-                </a:solidFill>
-                <a:latin typeface="Pretendard"/>
-                <a:cs typeface="Pretendard"/>
-                <a:ea typeface="Pretendard"/>
-                <a:sym typeface="Pretendard"/>
-              </a:rPr>
-              <a:t>점추정 5% 초과: 16⁠칸 중 10⁠칸</a:t>
-            </a:r>
-          </a:p>
-          <a:p>
-            <a:pPr algn="l" marL="0" marR="0" eaLnBrk="0">
-              <a:lnSpc>
-                <a:spcPct val="110000"/>
-              </a:lnSpc>
-              <a:spcBef>
-                <a:spcPts val="0"/>
-              </a:spcBef>
-              <a:spcAft>
-                <a:spcPts val="400"/>
-              </a:spcAft>
-              <a:buNone/>
-            </a:pPr>
-            <a:r>
-              <a:rPr cap="none" sz="1800" i="0" b="0" u="none">
-                <a:solidFill>
-                  <a:srgbClr val="0B0B0B">
-                    <a:alpha val="100000"/>
-                  </a:srgbClr>
-                </a:solidFill>
-                <a:latin typeface="Pretendard"/>
-                <a:cs typeface="Pretendard"/>
-                <a:ea typeface="Pretendard"/>
-                <a:sym typeface="Pretendard"/>
-              </a:rPr>
-              <a:t>노출이 낮은 미달자가 빠진다</a:t>
-            </a:r>
-          </a:p>
-        </p:txBody>
-      </p:sp>
-      <p:sp>
-        <p:nvSpPr>
-          <p:cNvPr id="10" name="footer_src"/>
+          <p:cNvPr id="8" name="footer_src"/>
           <p:cNvSpPr>
             <a:spLocks noGrp="1"/>
           </p:cNvSpPr>
@@ -38410,14 +38215,14 @@
                 <a:ea typeface="Pretendard"/>
                 <a:sym typeface="Pretendard"/>
               </a:rPr>
-              <a:t>출처: type1_models.csv, fallback_cost.csv, power_models.csv, tp_retained_per_arm.csv, tp_characteristics.csv 외 6개</a:t>
+              <a:t>출처: type1_models.csv, fallback_cost.csv, power_models.csv, p2_decomposition_models.csv, tp_failure_by_set.csv 외 7개</a:t>
             </a:r>
           </a:p>
         </p:txBody>
       </p:sp>
       <p:sp>
         <p:nvSpPr>
-          <p:cNvPr id="11" name="footer_ver"/>
+          <p:cNvPr id="9" name="footer_ver"/>
           <p:cNvSpPr>
             <a:spLocks noGrp="1"/>
           </p:cNvSpPr>
@@ -38649,7 +38454,35 @@
                 <a:ea typeface="Pretendard"/>
                 <a:sym typeface="Pretendard"/>
               </a:rPr>
-              <a:t>체중이 무거울수록 AUCinf 신뢰 기준 미달은 늘지만(최대 47.5%), AUClast/AUCinf 80% 미만은 두 모델의 모든 체중 구간에서 0.01% 이하다</a:t>
+              <a:t>무거울수록 세트 ⁠(iii) 미달이 늘지만(아토피 가정 분포 100 ⁠kg 초과 47.5%)</a:t>
+            </a:r>
+          </a:p>
+          <a:p>
+            <a:pPr algn="l" marL="0" marR="0" eaLnBrk="0">
+              <a:lnSpc>
+                <a:spcPct val="105000"/>
+              </a:lnSpc>
+              <a:spcBef>
+                <a:spcPts val="0"/>
+              </a:spcBef>
+              <a:spcAft>
+                <a:spcPts val="0"/>
+              </a:spcAft>
+              <a:buNone/>
+            </a:pPr>
+            <a:r>
+              <a:rPr cap="none" sz="2800" i="0" b="1" u="none">
+                <a:solidFill>
+                  <a:srgbClr val="0B0B0B">
+                    <a:alpha val="100000"/>
+                  </a:srgbClr>
+                </a:solidFill>
+                <a:latin typeface="Pretendard"/>
+                <a:cs typeface="Pretendard"/>
+                <a:ea typeface="Pretendard"/>
+                <a:sym typeface="Pretendard"/>
+              </a:rPr>
+              <a:t>AUClast/AUCinf 80% 미만은 모든 구간에서 0.01% 이하다(두 모델)</a:t>
             </a:r>
           </a:p>
         </p:txBody>
@@ -38777,7 +38610,7 @@
                 <a:ea typeface="Pretendard"/>
                 <a:sym typeface="Pretendard"/>
               </a:rPr>
-              <a:t>AUClast/AUCinf 80% 미만 대상자는 두 패널, 두 모델의 모든 구간에서 0.01% 이하. 회색 띠: 연구 체중 범위, 점선 오른쪽(130 ⁠kg 이상)⁠은 모델 외삽일 수 있음. 세트 ⁠(i): adjusted R² ≥ ⁠0.80, 외삽 ≤ ⁠20%; 세트 ⁠(iii) = 신뢰할 수 있는 AUCinf(adjusted R² ≥ ⁠0.90). 표의 AUCinf + Cmax⁠는 세트 ⁠(iii) 기준이고 정량한계 행만 세트 ⁠(ii)⁠다. 1⁠종 오류는 점추정; M0 층 없음, M1 체중 층 포함(주분석 후보), M2 log 체중 공분산분석. 표의 행은 S8, S9, 별첨 A5⁠의 근거를 요약한다.</a:t>
+              <a:t>AUClast/AUCinf 80% 미만 대상자는 두 패널, 두 모델의 모든 구간에서 0.01% 이하. 회색 띠: 연구 체중 범위, 점선 오른쪽(130 ⁠kg 이상)⁠은 모델 외삽일 수 있음. (b)⁠의 체중 분포는 문헌 요약으로 만든 가정 분포다(로그정규, 평균 78 ⁠kg, 표준편차 19 ⁠kg; 3⁠상 원자료 미확인). 세트 ⁠(i) = adjusted R² ≥ ⁠0.80, 외삽 ≤ ⁠20%; 세트 ⁠(iii) = 신뢰할 수 있는 AUCinf(adjusted R² ≥ ⁠0.90, 외삽 ≤ ⁠20%). 표의 AUCinf + Cmax⁠는 세트 ⁠(iii) 기준(정량한계 행만 세트 ⁠(ii)); M0 층 없음, M1 체중 층 포함(주분석 후보), M2 log 체중 공분산분석. 표는 S8, S9, 별첨 A5 근거의 요약이다.</a:t>
             </a:r>
           </a:p>
         </p:txBody>
@@ -39052,7 +38885,7 @@
                           <a:ea typeface="Pretendard"/>
                           <a:sym typeface="Pretendard"/>
                         </a:rPr>
-                        <a:t>AUClast + Cmax 최대 4.3% / 5.6%.</a:t>
+                        <a:t>AUClast + Cmax 최대 4.33% / 5.63%.</a:t>
                       </a:r>
                       <a:br>
                         <a:rPr cap="none" sz="1400" i="0" b="0" u="none">
@@ -39079,34 +38912,7 @@
                           <a:ea typeface="Pretendard"/>
                           <a:sym typeface="Pretendard"/>
                         </a:rPr>
-                        <a:t>AUCinf + Cmax⁠는 16⁠개 중 10⁠개 조건에서</a:t>
-                      </a:r>
-                      <a:br>
-                        <a:rPr cap="none" sz="1400" i="0" b="0" u="none">
-                          <a:solidFill>
-                            <a:srgbClr val="0B0B0B">
-                              <a:alpha val="100000"/>
-                            </a:srgbClr>
-                          </a:solidFill>
-                          <a:latin typeface="Pretendard"/>
-                          <a:cs typeface="Pretendard"/>
-                          <a:ea typeface="Pretendard"/>
-                          <a:sym typeface="Pretendard"/>
-                        </a:rPr>
-                      </a:br>
-                      <a:r>
-                        <a:rPr cap="none" sz="1400" i="0" b="0" u="none">
-                          <a:solidFill>
-                            <a:srgbClr val="0B0B0B">
-                              <a:alpha val="100000"/>
-                            </a:srgbClr>
-                          </a:solidFill>
-                          <a:latin typeface="Pretendard"/>
-                          <a:cs typeface="Pretendard"/>
-                          <a:ea typeface="Pretendard"/>
-                          <a:sym typeface="Pretendard"/>
-                        </a:rPr>
-                        <a:t>점추정 5% 초과</a:t>
+                        <a:t>AUCinf + Cmax: 16⁠칸 중 10⁠칸 점추정 5% 초과</a:t>
                       </a:r>
                     </a:p>
                   </a:txBody>
@@ -39196,7 +39002,7 @@
                           <a:ea typeface="Pretendard"/>
                           <a:sym typeface="Pretendard"/>
                         </a:rPr>
-                        <a:t>(양 군 공통)</a:t>
+                        <a:t>(두 arm 공통)</a:t>
                       </a:r>
                     </a:p>
                   </a:txBody>
@@ -39447,6 +39253,33 @@
                           <a:ea typeface="Pretendard"/>
                           <a:sym typeface="Pretendard"/>
                         </a:rPr>
+                        <a:t>2016 ⁠모델 경계 3⁠칸, 칸당 5,000⁠회만 계산.</a:t>
+                      </a:r>
+                      <a:br>
+                        <a:rPr cap="none" sz="1400" i="0" b="0" u="none">
+                          <a:solidFill>
+                            <a:srgbClr val="0B0B0B">
+                              <a:alpha val="100000"/>
+                            </a:srgbClr>
+                          </a:solidFill>
+                          <a:latin typeface="Pretendard"/>
+                          <a:cs typeface="Pretendard"/>
+                          <a:ea typeface="Pretendard"/>
+                          <a:sym typeface="Pretendard"/>
+                        </a:rPr>
+                      </a:br>
+                      <a:r>
+                        <a:rPr cap="none" sz="1400" i="0" b="0" u="none">
+                          <a:solidFill>
+                            <a:srgbClr val="0B0B0B">
+                              <a:alpha val="100000"/>
+                            </a:srgbClr>
+                          </a:solidFill>
+                          <a:latin typeface="Pretendard"/>
+                          <a:cs typeface="Pretendard"/>
+                          <a:ea typeface="Pretendard"/>
+                          <a:sym typeface="Pretendard"/>
+                        </a:rPr>
                         <a:t>AUClast + Cmax 2.60~4.62%.</a:t>
                       </a:r>
                       <a:br>
@@ -39633,7 +39466,7 @@
                           <a:ea typeface="Pretendard"/>
                           <a:sym typeface="Pretendard"/>
                         </a:rPr>
-                        <a:t>신뢰할 수 있는 AUCinf 미확보 38.8% → 27.2%.</a:t>
+                        <a:t>세트 ⁠(iii) 기준 미달 38.8% → 27.2%.</a:t>
                       </a:r>
                       <a:br>
                         <a:rPr cap="none" sz="1400" i="0" b="0" u="none">
@@ -40210,8 +40043,8 @@
         </p:nvSpPr>
         <p:spPr>
           <a:xfrm>
-            <a:off x="502920" y="5910072"/>
-            <a:ext cx="11185855" cy="344424"/>
+            <a:off x="502920" y="5675376"/>
+            <a:ext cx="11185855" cy="579120"/>
           </a:xfrm>
           <a:prstGeom prst="rect">
             <a:avLst/>
@@ -40245,7 +40078,7 @@
                 <a:ea typeface="Pretendard"/>
                 <a:sym typeface="Pretendard"/>
               </a:rPr>
-              <a:t>별첨 A13(규제 업무(RA) 포지션 페이퍼 7⁠절 대응표)⁠은 싣지 않았다: 포지션 페이퍼와 직전 지시의 결과가 저장소에 없다(DECISIONS D-063).</a:t>
+              <a:t>별첨 A13(규제 업무(RA) 포지션 페이퍼 7⁠절 대응표)⁠과 별첨 A6⁠의 FDA 리뷰 Table 4.2.b, TYENNE(BLA 761275), MSB11456 피하 투여 초록은 저장소에 자료가 없어 싣지 않았다(DECISIONS D-063). 핵심 덱 새 요약의 재생성 대조는 모두 일치했다(별첨 A14).</a:t>
             </a:r>
           </a:p>
         </p:txBody>
@@ -40260,16 +40093,16 @@
         </p:nvGraphicFramePr>
         <p:xfrm rot="0">
           <a:off x="502920" y="1773936"/>
-          <a:ext cx="11185855" cy="4026408"/>
+          <a:ext cx="11185855" cy="3855720"/>
         </p:xfrm>
         <a:graphic>
           <a:graphicData uri="http://schemas.openxmlformats.org/drawingml/2006/table">
             <a:tbl>
               <a:tblPr/>
               <a:tblGrid>
-                <a:gridCol w="1783517"/>
-                <a:gridCol w="2835335"/>
-                <a:gridCol w="6567002"/>
+                <a:gridCol w="1509130"/>
+                <a:gridCol w="2560948"/>
+                <a:gridCol w="7115777"/>
               </a:tblGrid>
               <a:tr h="228600">
                 <a:tc>
@@ -40559,7 +40392,7 @@
                           <a:ea typeface="Pretendard"/>
                           <a:sym typeface="Pretendard"/>
                         </a:rPr>
-                        <a:t>정량한계 아래 곡선 모양,</a:t>
+                        <a:t>곡선 모양, Km ⁠0.01 ⁠mg/L 고정,</a:t>
                       </a:r>
                       <a:br>
                         <a:rPr cap="none" sz="1400" i="0" b="0" u="none">
@@ -40586,7 +40419,7 @@
                           <a:ea typeface="Pretendard"/>
                           <a:sym typeface="Pretendard"/>
                         </a:rPr>
-                        <a:t>Km ⁠0.01 ⁠mg/L 고정(개인차 없음)</a:t>
+                        <a:t>측정 오차(정밀도 확인 필요)</a:t>
                       </a:r>
                     </a:p>
                   </a:txBody>
@@ -40647,7 +40480,7 @@
                           <a:ea typeface="Pretendard"/>
                           <a:sym typeface="Pretendard"/>
                         </a:rPr>
-                        <a:t>사전 등록 변형 4⁠개(양 군 최대 소실 속도(Vmax) ×0.8·×1.25, Km ⁠×0.5·×10)⁠에서</a:t>
+                        <a:t>사전 등록 곡선 변형 4⁠개: AUClast/AUCinf 5⁠번째 백분위수 94.7% 이상(S8).</a:t>
                       </a:r>
                       <a:br>
                         <a:rPr cap="none" sz="1400" i="0" b="0" u="none">
@@ -40674,7 +40507,7 @@
                           <a:ea typeface="Pretendard"/>
                           <a:sym typeface="Pretendard"/>
                         </a:rPr>
-                        <a:t>AUClast/AUCinf 5⁠번째 백분위수 94.7% 이상(S8, 별첨 A8)</a:t>
+                        <a:t>측정 오차 = 모델 비례 잔차 24.2%·15%. 12%⁠면 세트 ⁠(iii) 미달 38.8% → 27.2%(별첨 A3b)</a:t>
                       </a:r>
                     </a:p>
                   </a:txBody>
@@ -40921,7 +40754,7 @@
                           <a:ea typeface="Pretendard"/>
                           <a:sym typeface="Pretendard"/>
                         </a:rPr>
-                        <a:t>연구 제형 300 ⁠mg⁠은 노출 재현(별첨 A1): 두 군 모두 이 제형인지 확인</a:t>
+                        <a:t>연구 제형 300 ⁠mg⁠은 노출 재현(별첨 A1): 두 arm 모두 이 제형인지 확인</a:t>
                       </a:r>
                     </a:p>
                   </a:txBody>
@@ -40988,7 +40821,7 @@
                           <a:ea typeface="Pretendard"/>
                           <a:sym typeface="Pretendard"/>
                         </a:rPr>
-                        <a:t>과대예측</a:t>
+                        <a:t>완전 외부 판정 불통과</a:t>
                       </a:r>
                     </a:p>
                   </a:txBody>
@@ -41053,7 +40886,34 @@
                           <a:ea typeface="Pretendard"/>
                           <a:sym typeface="Pretendard"/>
                         </a:rPr>
-                        <a:t>연구 제형의 Cmax(제안 1⁠차 평가변수)</a:t>
+                        <a:t>모델 개발 자료를 뺀</a:t>
+                      </a:r>
+                      <a:br>
+                        <a:rPr cap="none" sz="1400" i="0" b="0" u="none">
+                          <a:solidFill>
+                            <a:srgbClr val="0B0B0B">
+                              <a:alpha val="100000"/>
+                            </a:srgbClr>
+                          </a:solidFill>
+                          <a:latin typeface="Pretendard"/>
+                          <a:cs typeface="Pretendard"/>
+                          <a:ea typeface="Pretendard"/>
+                          <a:sym typeface="Pretendard"/>
+                        </a:rPr>
+                      </a:br>
+                      <a:r>
+                        <a:rPr cap="none" sz="1400" i="0" b="0" u="none">
+                          <a:solidFill>
+                            <a:srgbClr val="0B0B0B">
+                              <a:alpha val="100000"/>
+                            </a:srgbClr>
+                          </a:solidFill>
+                          <a:latin typeface="Pretendard"/>
+                          <a:cs typeface="Pretendard"/>
+                          <a:ea typeface="Pretendard"/>
+                          <a:sym typeface="Pretendard"/>
+                        </a:rPr>
+                        <a:t>외부 자료만의 재판정</a:t>
                       </a:r>
                     </a:p>
                   </a:txBody>
@@ -41118,7 +40978,7 @@
                           <a:ea typeface="Pretendard"/>
                           <a:sym typeface="Pretendard"/>
                         </a:rPr>
-                        <a:t>모의/관측 Cmax 1.08~1.27(2016 ⁠모델), 1.00~1.17(2020 ⁠모델).</a:t>
+                        <a:t>두 모델 불통과: PKM12350(연구 제형 300 ⁠mg) arm 모의/관측 1.14~1.27(78 ⁠kg 가정).</a:t>
                       </a:r>
                       <a:br>
                         <a:rPr cap="none" sz="1400" i="0" b="0" u="none">
@@ -41145,7 +41005,7 @@
                           <a:ea typeface="Pretendard"/>
                           <a:sym typeface="Pretendard"/>
                         </a:rPr>
-                        <a:t>1⁠종 오류·검정력 계산에 모의 Cmax⁠를 그대로 썼다</a:t>
+                        <a:t>체중 미보고. 가정 평균 82 ⁠kg(2016 ⁠모델), 86 ⁠kg(2020 ⁠모델)⁠이면 ±15% 안(별첨 A1, A6)</a:t>
                       </a:r>
                     </a:p>
                   </a:txBody>
@@ -41212,6 +41072,257 @@
                           <a:ea typeface="Pretendard"/>
                           <a:sym typeface="Pretendard"/>
                         </a:rPr>
+                        <a:t>과대예측</a:t>
+                      </a:r>
+                    </a:p>
+                  </a:txBody>
+                  <a:tcPr anchor="ctr" marB="25400" marT="25400" marR="0" marL="0">
+                    <a:lnL algn="ctr" cmpd="sng" cap="flat" w="0">
+                      <a:noFill/>
+                      <a:prstDash val="solid"/>
+                    </a:lnL>
+                    <a:lnR algn="ctr" cmpd="sng" cap="flat" w="0">
+                      <a:noFill/>
+                      <a:prstDash val="solid"/>
+                    </a:lnR>
+                    <a:lnT algn="ctr" cmpd="sng" cap="flat" w="9525">
+                      <a:solidFill>
+                        <a:srgbClr val="E6E5E0">
+                          <a:alpha val="100000"/>
+                        </a:srgbClr>
+                      </a:solidFill>
+                      <a:prstDash val="solid"/>
+                    </a:lnT>
+                    <a:lnB algn="ctr" cmpd="sng" cap="flat" w="9525">
+                      <a:solidFill>
+                        <a:srgbClr val="E6E5E0">
+                          <a:alpha val="100000"/>
+                        </a:srgbClr>
+                      </a:solidFill>
+                      <a:prstDash val="solid"/>
+                    </a:lnB>
+                    <a:solidFill>
+                      <a:srgbClr val="FFFFFF">
+                        <a:alpha val="0"/>
+                      </a:srgbClr>
+                    </a:solidFill>
+                  </a:tcPr>
+                </a:tc>
+                <a:tc>
+                  <a:txBody>
+                    <a:bodyPr/>
+                    <a:lstStyle/>
+                    <a:p>
+                      <a:pPr algn="l" marL="63500" marR="63500" eaLnBrk="0">
+                        <a:lnSpc>
+                          <a:spcPct val="100000"/>
+                        </a:lnSpc>
+                        <a:spcBef>
+                          <a:spcPts val="200"/>
+                        </a:spcBef>
+                        <a:spcAft>
+                          <a:spcPts val="200"/>
+                        </a:spcAft>
+                        <a:buNone/>
+                      </a:pPr>
+                      <a:r>
+                        <a:rPr cap="none" sz="1400" i="0" b="0" u="none">
+                          <a:solidFill>
+                            <a:srgbClr val="0B0B0B">
+                              <a:alpha val="100000"/>
+                            </a:srgbClr>
+                          </a:solidFill>
+                          <a:latin typeface="Pretendard"/>
+                          <a:cs typeface="Pretendard"/>
+                          <a:ea typeface="Pretendard"/>
+                          <a:sym typeface="Pretendard"/>
+                        </a:rPr>
+                        <a:t>연구 제형의 Cmax</a:t>
+                      </a:r>
+                      <a:br>
+                        <a:rPr cap="none" sz="1400" i="0" b="0" u="none">
+                          <a:solidFill>
+                            <a:srgbClr val="0B0B0B">
+                              <a:alpha val="100000"/>
+                            </a:srgbClr>
+                          </a:solidFill>
+                          <a:latin typeface="Pretendard"/>
+                          <a:cs typeface="Pretendard"/>
+                          <a:ea typeface="Pretendard"/>
+                          <a:sym typeface="Pretendard"/>
+                        </a:rPr>
+                      </a:br>
+                      <a:r>
+                        <a:rPr cap="none" sz="1400" i="0" b="0" u="none">
+                          <a:solidFill>
+                            <a:srgbClr val="0B0B0B">
+                              <a:alpha val="100000"/>
+                            </a:srgbClr>
+                          </a:solidFill>
+                          <a:latin typeface="Pretendard"/>
+                          <a:cs typeface="Pretendard"/>
+                          <a:ea typeface="Pretendard"/>
+                          <a:sym typeface="Pretendard"/>
+                        </a:rPr>
+                        <a:t>(제안 1⁠차 평가변수)</a:t>
+                      </a:r>
+                    </a:p>
+                  </a:txBody>
+                  <a:tcPr anchor="ctr" marB="25400" marT="25400" marR="0" marL="0">
+                    <a:lnL algn="ctr" cmpd="sng" cap="flat" w="0">
+                      <a:noFill/>
+                      <a:prstDash val="solid"/>
+                    </a:lnL>
+                    <a:lnR algn="ctr" cmpd="sng" cap="flat" w="0">
+                      <a:noFill/>
+                      <a:prstDash val="solid"/>
+                    </a:lnR>
+                    <a:lnT algn="ctr" cmpd="sng" cap="flat" w="9525">
+                      <a:solidFill>
+                        <a:srgbClr val="E6E5E0">
+                          <a:alpha val="100000"/>
+                        </a:srgbClr>
+                      </a:solidFill>
+                      <a:prstDash val="solid"/>
+                    </a:lnT>
+                    <a:lnB algn="ctr" cmpd="sng" cap="flat" w="9525">
+                      <a:solidFill>
+                        <a:srgbClr val="E6E5E0">
+                          <a:alpha val="100000"/>
+                        </a:srgbClr>
+                      </a:solidFill>
+                      <a:prstDash val="solid"/>
+                    </a:lnB>
+                    <a:solidFill>
+                      <a:srgbClr val="FFFFFF">
+                        <a:alpha val="0"/>
+                      </a:srgbClr>
+                    </a:solidFill>
+                  </a:tcPr>
+                </a:tc>
+                <a:tc>
+                  <a:txBody>
+                    <a:bodyPr/>
+                    <a:lstStyle/>
+                    <a:p>
+                      <a:pPr algn="l" marL="63500" marR="63500" eaLnBrk="0">
+                        <a:lnSpc>
+                          <a:spcPct val="100000"/>
+                        </a:lnSpc>
+                        <a:spcBef>
+                          <a:spcPts val="200"/>
+                        </a:spcBef>
+                        <a:spcAft>
+                          <a:spcPts val="200"/>
+                        </a:spcAft>
+                        <a:buNone/>
+                      </a:pPr>
+                      <a:r>
+                        <a:rPr cap="none" sz="1400" i="0" b="0" u="none">
+                          <a:solidFill>
+                            <a:srgbClr val="0B0B0B">
+                              <a:alpha val="100000"/>
+                            </a:srgbClr>
+                          </a:solidFill>
+                          <a:latin typeface="Pretendard"/>
+                          <a:cs typeface="Pretendard"/>
+                          <a:ea typeface="Pretendard"/>
+                          <a:sym typeface="Pretendard"/>
+                        </a:rPr>
+                        <a:t>모의/관측 Cmax 1.08~1.27(2016 ⁠모델), 1.00~1.17(2020 ⁠모델).</a:t>
+                      </a:r>
+                      <a:br>
+                        <a:rPr cap="none" sz="1400" i="0" b="0" u="none">
+                          <a:solidFill>
+                            <a:srgbClr val="0B0B0B">
+                              <a:alpha val="100000"/>
+                            </a:srgbClr>
+                          </a:solidFill>
+                          <a:latin typeface="Pretendard"/>
+                          <a:cs typeface="Pretendard"/>
+                          <a:ea typeface="Pretendard"/>
+                          <a:sym typeface="Pretendard"/>
+                        </a:rPr>
+                      </a:br>
+                      <a:r>
+                        <a:rPr cap="none" sz="1400" i="0" b="0" u="none">
+                          <a:solidFill>
+                            <a:srgbClr val="0B0B0B">
+                              <a:alpha val="100000"/>
+                            </a:srgbClr>
+                          </a:solidFill>
+                          <a:latin typeface="Pretendard"/>
+                          <a:cs typeface="Pretendard"/>
+                          <a:ea typeface="Pretendard"/>
+                          <a:sym typeface="Pretendard"/>
+                        </a:rPr>
+                        <a:t>1⁠종 오류·검정력 계산에 모의 Cmax⁠를 그대로 썼다</a:t>
+                      </a:r>
+                    </a:p>
+                  </a:txBody>
+                  <a:tcPr anchor="ctr" marB="25400" marT="25400" marR="0" marL="0">
+                    <a:lnL algn="ctr" cmpd="sng" cap="flat" w="0">
+                      <a:noFill/>
+                      <a:prstDash val="solid"/>
+                    </a:lnL>
+                    <a:lnR algn="ctr" cmpd="sng" cap="flat" w="0">
+                      <a:noFill/>
+                      <a:prstDash val="solid"/>
+                    </a:lnR>
+                    <a:lnT algn="ctr" cmpd="sng" cap="flat" w="9525">
+                      <a:solidFill>
+                        <a:srgbClr val="E6E5E0">
+                          <a:alpha val="100000"/>
+                        </a:srgbClr>
+                      </a:solidFill>
+                      <a:prstDash val="solid"/>
+                    </a:lnT>
+                    <a:lnB algn="ctr" cmpd="sng" cap="flat" w="9525">
+                      <a:solidFill>
+                        <a:srgbClr val="E6E5E0">
+                          <a:alpha val="100000"/>
+                        </a:srgbClr>
+                      </a:solidFill>
+                      <a:prstDash val="solid"/>
+                    </a:lnB>
+                    <a:solidFill>
+                      <a:srgbClr val="FFFFFF">
+                        <a:alpha val="0"/>
+                      </a:srgbClr>
+                    </a:solidFill>
+                  </a:tcPr>
+                </a:tc>
+              </a:tr>
+              <a:tr h="228600">
+                <a:tc>
+                  <a:txBody>
+                    <a:bodyPr/>
+                    <a:lstStyle/>
+                    <a:p>
+                      <a:pPr algn="l" marL="63500" marR="63500" eaLnBrk="0">
+                        <a:lnSpc>
+                          <a:spcPct val="100000"/>
+                        </a:lnSpc>
+                        <a:spcBef>
+                          <a:spcPts val="200"/>
+                        </a:spcBef>
+                        <a:spcAft>
+                          <a:spcPts val="200"/>
+                        </a:spcAft>
+                        <a:buNone/>
+                      </a:pPr>
+                      <a:r>
+                        <a:rPr cap="none" sz="1400" i="0" b="1" u="none">
+                          <a:solidFill>
+                            <a:srgbClr val="0B0B0B">
+                              <a:alpha val="100000"/>
+                            </a:srgbClr>
+                          </a:solidFill>
+                          <a:latin typeface="Pretendard"/>
+                          <a:cs typeface="Pretendard"/>
+                          <a:ea typeface="Pretendard"/>
+                          <a:sym typeface="Pretendard"/>
+                        </a:rPr>
                         <a:t>미실시</a:t>
                       </a:r>
                     </a:p>
@@ -41369,7 +41480,7 @@
                           <a:ea typeface="Pretendard"/>
                           <a:sym typeface="Pretendard"/>
                         </a:rPr>
-                        <a:t>NCA 엔진은 NonCompart·PKNCA⁠와만 대조(λz 창 3,054 / 3,054 ⁠일치).</a:t>
+                        <a:t>NCA 엔진은 NonCompart·PKNCA⁠와만 대조(λz 구간 3,054 / 3,054 ⁠일치).</a:t>
                       </a:r>
                       <a:br>
                         <a:rPr cap="none" sz="1400" i="0" b="0" u="none">
@@ -41725,7 +41836,7 @@
                           <a:ea typeface="Pretendard"/>
                           <a:sym typeface="Pretendard"/>
                         </a:rPr>
-                        <a:t>문헌·지침·문서 인용(검색 발췌):</a:t>
+                        <a:t>문헌·지침·문서 인용</a:t>
                       </a:r>
                       <a:br>
                         <a:rPr cap="none" sz="1400" i="0" b="0" u="none">
@@ -41752,7 +41863,7 @@
                           <a:ea typeface="Pretendard"/>
                           <a:sym typeface="Pretendard"/>
                         </a:rPr>
-                        <a:t>원문과 대조 필요</a:t>
+                        <a:t>(검색 발췌)</a:t>
                       </a:r>
                     </a:p>
                   </a:txBody>
@@ -41817,7 +41928,7 @@
                           <a:ea typeface="Pretendard"/>
                           <a:sym typeface="Pretendard"/>
                         </a:rPr>
-                        <a:t>FDA BLA 761055 리뷰 문구·쪽(48⁠쪽), EMA 생동 지침 80% 기준,</a:t>
+                        <a:t>FDA BLA 761055 리뷰 문구·쪽(48⁠쪽), EMA 생동 지침 80% 기준, 선례 MSB11456,</a:t>
                       </a:r>
                       <a:br>
                         <a:rPr cap="none" sz="1400" i="0" b="0" u="none">
@@ -41844,7 +41955,7 @@
                           <a:ea typeface="Pretendard"/>
                           <a:sym typeface="Pretendard"/>
                         </a:rPr>
-                        <a:t>EMA 2012 단클론항체 지침, MSB11456, NCT04700163 SAP, Phoenix 8.2 문서</a:t>
+                        <a:t>EMA 2012 단클론항체 지침, NCT04700163 SAP, Phoenix 8.2 문서: 원문과 대조</a:t>
                       </a:r>
                     </a:p>
                   </a:txBody>
@@ -41911,7 +42022,7 @@
                           <a:ea typeface="Pretendard"/>
                           <a:sym typeface="Pretendard"/>
                         </a:rPr>
-                        <a:t>일치</a:t>
+                        <a:t>의뢰자 결정 대기</a:t>
                       </a:r>
                     </a:p>
                   </a:txBody>
@@ -41976,7 +42087,34 @@
                           <a:ea typeface="Pretendard"/>
                           <a:sym typeface="Pretendard"/>
                         </a:rPr>
-                        <a:t>핵심 덱 새 요약(scripts/63) 재생성</a:t>
+                        <a:t>정량한계, 잠정 설계값,</a:t>
+                      </a:r>
+                      <a:br>
+                        <a:rPr cap="none" sz="1400" i="0" b="0" u="none">
+                          <a:solidFill>
+                            <a:srgbClr val="0B0B0B">
+                              <a:alpha val="100000"/>
+                            </a:srgbClr>
+                          </a:solidFill>
+                          <a:latin typeface="Pretendard"/>
+                          <a:cs typeface="Pretendard"/>
+                          <a:ea typeface="Pretendard"/>
+                          <a:sym typeface="Pretendard"/>
+                        </a:rPr>
+                      </a:br>
+                      <a:r>
+                        <a:rPr cap="none" sz="1400" i="0" b="0" u="none">
+                          <a:solidFill>
+                            <a:srgbClr val="0B0B0B">
+                              <a:alpha val="100000"/>
+                            </a:srgbClr>
+                          </a:solidFill>
+                          <a:latin typeface="Pretendard"/>
+                          <a:cs typeface="Pretendard"/>
+                          <a:ea typeface="Pretendard"/>
+                          <a:sym typeface="Pretendard"/>
+                        </a:rPr>
+                        <a:t>주분석 모형, 목표 검정력</a:t>
                       </a:r>
                     </a:p>
                   </a:txBody>
@@ -42041,231 +42179,7 @@
                           <a:ea typeface="Pretendard"/>
                           <a:sym typeface="Pretendard"/>
                         </a:rPr>
-                        <a:t>원래 시드 규칙으로 재생성해 커밋된 결과와 대조 36⁠개 모두 일치(provenance.csv)</a:t>
-                      </a:r>
-                    </a:p>
-                  </a:txBody>
-                  <a:tcPr anchor="ctr" marB="25400" marT="25400" marR="0" marL="0">
-                    <a:lnL algn="ctr" cmpd="sng" cap="flat" w="0">
-                      <a:noFill/>
-                      <a:prstDash val="solid"/>
-                    </a:lnL>
-                    <a:lnR algn="ctr" cmpd="sng" cap="flat" w="0">
-                      <a:noFill/>
-                      <a:prstDash val="solid"/>
-                    </a:lnR>
-                    <a:lnT algn="ctr" cmpd="sng" cap="flat" w="9525">
-                      <a:solidFill>
-                        <a:srgbClr val="E6E5E0">
-                          <a:alpha val="100000"/>
-                        </a:srgbClr>
-                      </a:solidFill>
-                      <a:prstDash val="solid"/>
-                    </a:lnT>
-                    <a:lnB algn="ctr" cmpd="sng" cap="flat" w="9525">
-                      <a:solidFill>
-                        <a:srgbClr val="E6E5E0">
-                          <a:alpha val="100000"/>
-                        </a:srgbClr>
-                      </a:solidFill>
-                      <a:prstDash val="solid"/>
-                    </a:lnB>
-                    <a:solidFill>
-                      <a:srgbClr val="FFFFFF">
-                        <a:alpha val="0"/>
-                      </a:srgbClr>
-                    </a:solidFill>
-                  </a:tcPr>
-                </a:tc>
-              </a:tr>
-              <a:tr h="228600">
-                <a:tc>
-                  <a:txBody>
-                    <a:bodyPr/>
-                    <a:lstStyle/>
-                    <a:p>
-                      <a:pPr algn="l" marL="63500" marR="63500" eaLnBrk="0">
-                        <a:lnSpc>
-                          <a:spcPct val="100000"/>
-                        </a:lnSpc>
-                        <a:spcBef>
-                          <a:spcPts val="200"/>
-                        </a:spcBef>
-                        <a:spcAft>
-                          <a:spcPts val="200"/>
-                        </a:spcAft>
-                        <a:buNone/>
-                      </a:pPr>
-                      <a:r>
-                        <a:rPr cap="none" sz="1400" i="0" b="1" u="none">
-                          <a:solidFill>
-                            <a:srgbClr val="0B0B0B">
-                              <a:alpha val="100000"/>
-                            </a:srgbClr>
-                          </a:solidFill>
-                          <a:latin typeface="Pretendard"/>
-                          <a:cs typeface="Pretendard"/>
-                          <a:ea typeface="Pretendard"/>
-                          <a:sym typeface="Pretendard"/>
-                        </a:rPr>
-                        <a:t>의뢰자 결정 대기</a:t>
-                      </a:r>
-                    </a:p>
-                  </a:txBody>
-                  <a:tcPr anchor="ctr" marB="25400" marT="25400" marR="0" marL="0">
-                    <a:lnL algn="ctr" cmpd="sng" cap="flat" w="0">
-                      <a:noFill/>
-                      <a:prstDash val="solid"/>
-                    </a:lnL>
-                    <a:lnR algn="ctr" cmpd="sng" cap="flat" w="0">
-                      <a:noFill/>
-                      <a:prstDash val="solid"/>
-                    </a:lnR>
-                    <a:lnT algn="ctr" cmpd="sng" cap="flat" w="9525">
-                      <a:solidFill>
-                        <a:srgbClr val="E6E5E0">
-                          <a:alpha val="100000"/>
-                        </a:srgbClr>
-                      </a:solidFill>
-                      <a:prstDash val="solid"/>
-                    </a:lnT>
-                    <a:lnB algn="ctr" cmpd="sng" cap="flat" w="9525">
-                      <a:solidFill>
-                        <a:srgbClr val="E6E5E0">
-                          <a:alpha val="100000"/>
-                        </a:srgbClr>
-                      </a:solidFill>
-                      <a:prstDash val="solid"/>
-                    </a:lnB>
-                    <a:solidFill>
-                      <a:srgbClr val="FFFFFF">
-                        <a:alpha val="0"/>
-                      </a:srgbClr>
-                    </a:solidFill>
-                  </a:tcPr>
-                </a:tc>
-                <a:tc>
-                  <a:txBody>
-                    <a:bodyPr/>
-                    <a:lstStyle/>
-                    <a:p>
-                      <a:pPr algn="l" marL="63500" marR="63500" eaLnBrk="0">
-                        <a:lnSpc>
-                          <a:spcPct val="100000"/>
-                        </a:lnSpc>
-                        <a:spcBef>
-                          <a:spcPts val="200"/>
-                        </a:spcBef>
-                        <a:spcAft>
-                          <a:spcPts val="200"/>
-                        </a:spcAft>
-                        <a:buNone/>
-                      </a:pPr>
-                      <a:r>
-                        <a:rPr cap="none" sz="1400" i="0" b="0" u="none">
-                          <a:solidFill>
-                            <a:srgbClr val="0B0B0B">
-                              <a:alpha val="100000"/>
-                            </a:srgbClr>
-                          </a:solidFill>
-                          <a:latin typeface="Pretendard"/>
-                          <a:cs typeface="Pretendard"/>
-                          <a:ea typeface="Pretendard"/>
-                          <a:sym typeface="Pretendard"/>
-                        </a:rPr>
-                        <a:t>정량한계, 잠정 설계값,</a:t>
-                      </a:r>
-                      <a:br>
-                        <a:rPr cap="none" sz="1400" i="0" b="0" u="none">
-                          <a:solidFill>
-                            <a:srgbClr val="0B0B0B">
-                              <a:alpha val="100000"/>
-                            </a:srgbClr>
-                          </a:solidFill>
-                          <a:latin typeface="Pretendard"/>
-                          <a:cs typeface="Pretendard"/>
-                          <a:ea typeface="Pretendard"/>
-                          <a:sym typeface="Pretendard"/>
-                        </a:rPr>
-                      </a:br>
-                      <a:r>
-                        <a:rPr cap="none" sz="1400" i="0" b="0" u="none">
-                          <a:solidFill>
-                            <a:srgbClr val="0B0B0B">
-                              <a:alpha val="100000"/>
-                            </a:srgbClr>
-                          </a:solidFill>
-                          <a:latin typeface="Pretendard"/>
-                          <a:cs typeface="Pretendard"/>
-                          <a:ea typeface="Pretendard"/>
-                          <a:sym typeface="Pretendard"/>
-                        </a:rPr>
-                        <a:t>주분석 모형, 목표 검정력</a:t>
-                      </a:r>
-                    </a:p>
-                  </a:txBody>
-                  <a:tcPr anchor="ctr" marB="25400" marT="25400" marR="0" marL="0">
-                    <a:lnL algn="ctr" cmpd="sng" cap="flat" w="0">
-                      <a:noFill/>
-                      <a:prstDash val="solid"/>
-                    </a:lnL>
-                    <a:lnR algn="ctr" cmpd="sng" cap="flat" w="0">
-                      <a:noFill/>
-                      <a:prstDash val="solid"/>
-                    </a:lnR>
-                    <a:lnT algn="ctr" cmpd="sng" cap="flat" w="9525">
-                      <a:solidFill>
-                        <a:srgbClr val="E6E5E0">
-                          <a:alpha val="100000"/>
-                        </a:srgbClr>
-                      </a:solidFill>
-                      <a:prstDash val="solid"/>
-                    </a:lnT>
-                    <a:lnB algn="ctr" cmpd="sng" cap="flat" w="9525">
-                      <a:solidFill>
-                        <a:srgbClr val="E6E5E0">
-                          <a:alpha val="100000"/>
-                        </a:srgbClr>
-                      </a:solidFill>
-                      <a:prstDash val="solid"/>
-                    </a:lnB>
-                    <a:solidFill>
-                      <a:srgbClr val="FFFFFF">
-                        <a:alpha val="0"/>
-                      </a:srgbClr>
-                    </a:solidFill>
-                  </a:tcPr>
-                </a:tc>
-                <a:tc>
-                  <a:txBody>
-                    <a:bodyPr/>
-                    <a:lstStyle/>
-                    <a:p>
-                      <a:pPr algn="l" marL="63500" marR="63500" eaLnBrk="0">
-                        <a:lnSpc>
-                          <a:spcPct val="100000"/>
-                        </a:lnSpc>
-                        <a:spcBef>
-                          <a:spcPts val="200"/>
-                        </a:spcBef>
-                        <a:spcAft>
-                          <a:spcPts val="200"/>
-                        </a:spcAft>
-                        <a:buNone/>
-                      </a:pPr>
-                      <a:r>
-                        <a:rPr cap="none" sz="1400" i="0" b="0" u="none">
-                          <a:solidFill>
-                            <a:srgbClr val="0B0B0B">
-                              <a:alpha val="100000"/>
-                            </a:srgbClr>
-                          </a:solidFill>
-                          <a:latin typeface="Pretendard"/>
-                          <a:cs typeface="Pretendard"/>
-                          <a:ea typeface="Pretendard"/>
-                          <a:sym typeface="Pretendard"/>
-                        </a:rPr>
-                        <a:t>LLOQ 0.078 ⁠mg/L⁠와 설계값은 가정. 주분석 후보 M1(체중 층 포함), M0 병기.</a:t>
+                        <a:t>정량한계 0.078 ⁠mg/L⁠와 설계값은 가정. 주분석 후보 M1(체중 층 포함), M0 병기.</a:t>
                       </a:r>
                       <a:br>
                         <a:rPr cap="none" sz="1400" i="0" b="0" u="none">
@@ -42378,7 +42292,7 @@
                 <a:ea typeface="Pretendard"/>
                 <a:sym typeface="Pretendard"/>
               </a:rPr>
-              <a:t>출처: provenance.csv, verification_qc.csv, literature_core_deck.yaml, engine_validation_summary.csv, coverage_by_case.csv 외 13개</a:t>
+              <a:t>출처: provenance.csv, verification_qc.csv, literature_core_deck.yaml, engine_validation_summary.csv, coverage_by_case.csv 외 17개</a:t>
             </a:r>
           </a:p>
         </p:txBody>
@@ -42460,71 +42374,7 @@
       </p:grpSpPr>
       <p:sp>
         <p:nvSpPr>
-          <p:cNvPr id="2" name="tag"/>
-          <p:cNvSpPr>
-            <a:spLocks noGrp="1"/>
-          </p:cNvSpPr>
-          <p:nvPr/>
-        </p:nvSpPr>
-        <p:spPr>
-          <a:xfrm>
-            <a:off x="10500055" y="201168"/>
-            <a:ext cx="1188720" cy="329184"/>
-          </a:xfrm>
-          <a:prstGeom prst="roundRect">
-            <a:avLst>
-              <a:gd name="adj" fmla="val 27778"/>
-            </a:avLst>
-          </a:prstGeom>
-          <a:solidFill>
-            <a:srgbClr val="F3F3F1">
-              <a:alpha val="100000"/>
-            </a:srgbClr>
-          </a:solidFill>
-          <a:ln w="0" cap="rnd" cmpd="sng">
-            <a:noFill/>
-            <a:prstDash val="solid"/>
-            <a:round/>
-            <a:headEnd type="none" w="med" len="med"/>
-            <a:tailEnd type="none" w="med" len="med"/>
-          </a:ln>
-        </p:spPr>
-        <p:txBody>
-          <a:bodyPr/>
-          <a:lstStyle/>
-          <a:p>
-            <a:pPr algn="ctr" marL="0" marR="0" eaLnBrk="0">
-              <a:lnSpc>
-                <a:spcPct val="100000"/>
-              </a:lnSpc>
-              <a:spcBef>
-                <a:spcPts val="0"/>
-              </a:spcBef>
-              <a:spcAft>
-                <a:spcPts val="0"/>
-              </a:spcAft>
-              <a:buNone/>
-            </a:pPr>
-            <a:r>
-              <a:rPr cap="none" sz="1400" i="0" b="1" u="none">
-                <a:solidFill>
-                  <a:srgbClr val="52514E">
-                    <a:alpha val="100000"/>
-                  </a:srgbClr>
-                </a:solidFill>
-                <a:latin typeface="Pretendard"/>
-                <a:cs typeface="Pretendard"/>
-                <a:ea typeface="Pretendard"/>
-                <a:sym typeface="Pretendard"/>
-              </a:rPr>
-              <a:t>[모의]</a:t>
-            </a:r>
-          </a:p>
-        </p:txBody>
-      </p:sp>
-      <p:sp>
-        <p:nvSpPr>
-          <p:cNvPr id="3" name="kicker"/>
+          <p:cNvPr id="2" name="kicker"/>
           <p:cNvSpPr>
             <a:spLocks noGrp="1"/>
           </p:cNvSpPr>
@@ -42574,7 +42424,7 @@
       </p:sp>
       <p:sp>
         <p:nvSpPr>
-          <p:cNvPr id="4" name="title"/>
+          <p:cNvPr id="3" name="title"/>
           <p:cNvSpPr>
             <a:spLocks noGrp="1"/>
           </p:cNvSpPr>
@@ -42617,14 +42467,14 @@
                 <a:ea typeface="Pretendard"/>
                 <a:sym typeface="Pretendard"/>
               </a:rPr>
-              <a:t>핵심 덱 입력 대조 36⁠개가 모두 일치했고 v1.0 재현 항목 7⁠개는 새 러너에서 통과했으나, v1.0.1 결과는 아직 깨끗한 러너에서 재현하지 않았다</a:t>
+              <a:t>핵심 덱 입력 대조 36⁠개가 모두 일치했고 v1.0 재현 항목 7⁠개는 새 러너에서 통과했으나, v1.0.1 결과는 아직 새 러너에서 재현하지 않았다</a:t>
             </a:r>
           </a:p>
         </p:txBody>
       </p:sp>
       <p:sp>
         <p:nvSpPr>
-          <p:cNvPr id="5" name="card"/>
+          <p:cNvPr id="4" name="card"/>
           <p:cNvSpPr>
             <a:spLocks noGrp="1"/>
           </p:cNvSpPr>
@@ -42688,7 +42538,7 @@
       </p:sp>
       <p:sp>
         <p:nvSpPr>
-          <p:cNvPr id="6" name="cardval"/>
+          <p:cNvPr id="5" name="cardval"/>
           <p:cNvSpPr>
             <a:spLocks noGrp="1"/>
           </p:cNvSpPr>
@@ -42820,7 +42670,7 @@
       </p:sp>
       <p:sp>
         <p:nvSpPr>
-          <p:cNvPr id="7" name="card"/>
+          <p:cNvPr id="6" name="card"/>
           <p:cNvSpPr>
             <a:spLocks noGrp="1"/>
           </p:cNvSpPr>
@@ -42884,7 +42734,7 @@
       </p:sp>
       <p:sp>
         <p:nvSpPr>
-          <p:cNvPr id="8" name="cardval"/>
+          <p:cNvPr id="7" name="cardval"/>
           <p:cNvSpPr>
             <a:spLocks noGrp="1"/>
           </p:cNvSpPr>
@@ -43016,7 +42866,7 @@
       </p:sp>
       <p:sp>
         <p:nvSpPr>
-          <p:cNvPr id="9" name="card"/>
+          <p:cNvPr id="8" name="card"/>
           <p:cNvSpPr>
             <a:spLocks noGrp="1"/>
           </p:cNvSpPr>
@@ -43080,7 +42930,7 @@
       </p:sp>
       <p:sp>
         <p:nvSpPr>
-          <p:cNvPr id="10" name="cardval"/>
+          <p:cNvPr id="9" name="cardval"/>
           <p:cNvSpPr>
             <a:spLocks noGrp="1"/>
           </p:cNvSpPr>
@@ -43205,35 +43055,7 @@
                 <a:ea typeface="Pretendard"/>
                 <a:sym typeface="Pretendard"/>
               </a:rPr>
-              <a:t>실행 72~101, 취소 3.</a:t>
-            </a:r>
-          </a:p>
-          <a:p>
-            <a:pPr algn="l" marL="0" marR="0" eaLnBrk="0">
-              <a:lnSpc>
-                <a:spcPct val="110000"/>
-              </a:lnSpc>
-              <a:spcBef>
-                <a:spcPts val="0"/>
-              </a:spcBef>
-              <a:spcAft>
-                <a:spcPts val="400"/>
-              </a:spcAft>
-              <a:buNone/>
-            </a:pPr>
-            <a:r>
-              <a:rPr cap="none" sz="1800" i="0" b="0" u="none">
-                <a:solidFill>
-                  <a:srgbClr val="0B0B0B">
-                    <a:alpha val="100000"/>
-                  </a:srgbClr>
-                </a:solidFill>
-                <a:latin typeface="Pretendard"/>
-                <a:cs typeface="Pretendard"/>
-                <a:ea typeface="Pretendard"/>
-                <a:sym typeface="Pretendard"/>
-              </a:rPr>
-              <a:t>실패 원인: 건너뛴 시험을 실패로 센 규칙(87~91), 환경 설정(99).</a:t>
+              <a:t>실행 72~101(취소 3). 실행 1~71⁠은 환경 설정에서 멈춤.</a:t>
             </a:r>
           </a:p>
           <a:p>
@@ -43261,14 +43083,14 @@
                 <a:ea typeface="Pretendard"/>
                 <a:sym typeface="Pretendard"/>
               </a:rPr>
-              <a:t>다음 실행(92, 100)⁠에서 고쳤다</a:t>
+              <a:t>실패 원인: 건너뛴 시험을 실패로 센 규칙(87~91), 환경 설정(99). 둘 다 다음 실행에서 고침</a:t>
             </a:r>
           </a:p>
         </p:txBody>
       </p:sp>
       <p:sp>
         <p:nvSpPr>
-          <p:cNvPr id="11" name="caption"/>
+          <p:cNvPr id="10" name="caption"/>
           <p:cNvSpPr>
             <a:spLocks noGrp="1"/>
           </p:cNvSpPr>
@@ -43318,7 +43140,7 @@
       </p:sp>
       <p:sp>
         <p:nvSpPr>
-          <p:cNvPr id="12" name="body"/>
+          <p:cNvPr id="11" name="body"/>
           <p:cNvSpPr>
             <a:spLocks noGrp="1"/>
           </p:cNvSpPr>
@@ -43396,7 +43218,7 @@
       </p:sp>
       <p:sp>
         <p:nvSpPr>
-          <p:cNvPr id="13" name="footer_src"/>
+          <p:cNvPr id="12" name="footer_src"/>
           <p:cNvSpPr>
             <a:spLocks noGrp="1"/>
           </p:cNvSpPr>
@@ -43446,7 +43268,7 @@
       </p:sp>
       <p:sp>
         <p:nvSpPr>
-          <p:cNvPr id="14" name="footer_ver"/>
+          <p:cNvPr id="13" name="footer_ver"/>
           <p:cNvSpPr>
             <a:spLocks noGrp="1"/>
           </p:cNvSpPr>

</xml_diff>